<commit_message>
Doorloopblad en hoorcollege op de cijfers van ronde 3
Ronde 1 had 25 bots en geen testbot; ronde 2 is onbruikbaar omdat de stacks uit
ronde 1 zijn meegenomen (de week-5-mechaniek), dus iedereen begon daar ongelijk.
Ronde 3 is het schone toernooi: 27 bots, iedereen op 1000.

Blok 4 van het doorloopblad ging over de spreiding tussen fold-groepen. Dat
verhaal vertelt de uitslag nu zelf, en scherper: de testbot staat eerste.

Vierde dia in het hoorcollege-deck met diezelfde uitslag. De regels waarin
kolommen met spaties waren uitgelijnd zijn herschreven -- Arial is niet
monospace, dus die lijnden niet uit.

Co-Authored-By: Claude Opus 5 <noreply@anthropic.com>
</commit_message>
<xml_diff>
--- a/powerpoints/hoorcollege/03_Exploring_Manipulating_Data_aangevuld.pptx
+++ b/powerpoints/hoorcollege/03_Exploring_Manipulating_Data_aangevuld.pptx
@@ -34,6 +34,7 @@
     <p:sldId id="902" r:id="rId35"/>
     <p:sldId id="903" r:id="rId36"/>
     <p:sldId id="904" r:id="rId37"/>
+    <p:sldId id="905" r:id="rId38"/>
   </p:sldIdLst>
   <p:sldSz cx="12192000" cy="6858000"/>
   <p:notesSz cx="6858000" cy="9144000"/>
@@ -12442,7 +12443,7 @@
               </a:defRPr>
             </a:pPr>
             <a:r>
-              <a:t>S7 S8 (allebei schoppen) → 36,6%     op de river met de flush → 94,1%</a:t>
+              <a:t>S7 S8, allebei schoppen: 36,6% op de flop — en 94,1% op de river, met de flush</a:t>
             </a:r>
           </a:p>
           <a:p>
@@ -12455,7 +12456,7 @@
               </a:defRPr>
             </a:pPr>
             <a:r>
-              <a:t>H7 C8 (gemengd)              →  8,0%     op de river                   →  0,0%</a:t>
+              <a:t>H7 C8, gemengde kleuren: 8,0% op de flop — en 0,0% op de river</a:t>
             </a:r>
           </a:p>
           <a:p>
@@ -12770,6 +12771,242 @@
             </a:pPr>
             <a:r>
               <a:t>24</a:t>
+            </a:r>
+          </a:p>
+        </p:txBody>
+      </p:sp>
+    </p:spTree>
+  </p:cSld>
+  <p:clrMapOvr>
+    <a:masterClrMapping/>
+  </p:clrMapOvr>
+</p:sld>
+</file>
+
+<file path=ppt/slides/slide25.xml><?xml version="1.0" encoding="utf-8"?>
+<p:sld xmlns:a="http://schemas.openxmlformats.org/drawingml/2006/main" xmlns:p="http://schemas.openxmlformats.org/presentationml/2006/main" xmlns:r="http://schemas.openxmlformats.org/officeDocument/2006/relationships">
+  <p:cSld>
+    <p:spTree>
+      <p:nvGrpSpPr>
+        <p:cNvPr id="1" name=""/>
+        <p:cNvGrpSpPr/>
+        <p:nvPr/>
+      </p:nvGrpSpPr>
+      <p:grpSpPr/>
+      <p:sp>
+        <p:nvSpPr>
+          <p:cNvPr id="2" name="TextBox 1"/>
+          <p:cNvSpPr txBox="1"/>
+          <p:nvPr/>
+        </p:nvSpPr>
+        <p:spPr>
+          <a:xfrm>
+            <a:off x="1984248" y="941832"/>
+            <a:ext cx="8229600" cy="1143000"/>
+          </a:xfrm>
+          <a:prstGeom prst="rect">
+            <a:avLst/>
+          </a:prstGeom>
+          <a:noFill/>
+        </p:spPr>
+        <p:txBody>
+          <a:bodyPr wrap="square">
+            <a:spAutoFit/>
+          </a:bodyPr>
+          <a:lstStyle/>
+          <a:p>
+            <a:pPr>
+              <a:defRPr sz="3200">
+                <a:solidFill>
+                  <a:srgbClr val="25167A"/>
+                </a:solidFill>
+                <a:latin typeface="Arial"/>
+              </a:defRPr>
+            </a:pPr>
+            <a:r>
+              <a:t>De bot die niet nadenkt werd eerste</a:t>
+            </a:r>
+          </a:p>
+        </p:txBody>
+      </p:sp>
+      <p:sp>
+        <p:nvSpPr>
+          <p:cNvPr id="3" name="TextBox 2"/>
+          <p:cNvSpPr txBox="1"/>
+          <p:nvPr/>
+        </p:nvSpPr>
+        <p:spPr>
+          <a:xfrm>
+            <a:off x="1984248" y="2084831"/>
+            <a:ext cx="8778240" cy="4041648"/>
+          </a:xfrm>
+          <a:prstGeom prst="rect">
+            <a:avLst/>
+          </a:prstGeom>
+          <a:noFill/>
+        </p:spPr>
+        <p:txBody>
+          <a:bodyPr wrap="square">
+            <a:spAutoFit/>
+          </a:bodyPr>
+          <a:lstStyle/>
+          <a:p>
+            <a:pPr>
+              <a:defRPr sz="1700" b="1">
+                <a:solidFill>
+                  <a:srgbClr val="000000"/>
+                </a:solidFill>
+                <a:latin typeface="Arial"/>
+              </a:defRPr>
+            </a:pPr>
+            <a:r>
+              <a:t>Toernooi week 3, 27 bots. De uitslag bovenaan:</a:t>
+            </a:r>
+          </a:p>
+          <a:p>
+            <a:pPr lvl="1">
+              <a:defRPr sz="1400" b="0">
+                <a:solidFill>
+                  <a:srgbClr val="1B4D3E"/>
+                </a:solidFill>
+                <a:latin typeface="Arial"/>
+              </a:defRPr>
+            </a:pPr>
+            <a:r>
+              <a:t>1.  Testbot_CalltAlles — 1748 chips, foldt 0,0%</a:t>
+            </a:r>
+          </a:p>
+          <a:p>
+            <a:pPr lvl="1">
+              <a:defRPr sz="1400" b="0">
+                <a:solidFill>
+                  <a:srgbClr val="000000"/>
+                </a:solidFill>
+                <a:latin typeface="Arial"/>
+              </a:defRPr>
+            </a:pPr>
+            <a:r>
+              <a:t>2.  een van jullie — 1738 chips, foldt 82,5%</a:t>
+            </a:r>
+          </a:p>
+          <a:p>
+            <a:pPr lvl="1">
+              <a:defRPr sz="1400" b="0">
+                <a:solidFill>
+                  <a:srgbClr val="000000"/>
+                </a:solidFill>
+                <a:latin typeface="Arial"/>
+              </a:defRPr>
+            </a:pPr>
+            <a:r>
+              <a:t>3.  een van jullie — 1256 chips, foldt 58,7%</a:t>
+            </a:r>
+          </a:p>
+          <a:p>
+            <a:pPr>
+              <a:spcBef>
+                <a:spcPts val="1300"/>
+              </a:spcBef>
+              <a:defRPr sz="1700" b="1">
+                <a:solidFill>
+                  <a:srgbClr val="000000"/>
+                </a:solidFill>
+                <a:latin typeface="Arial"/>
+              </a:defRPr>
+            </a:pPr>
+            <a:r>
+              <a:t>Die eerste is één regel: geef altijd "call" terug, wat je ook hebt.</a:t>
+            </a:r>
+          </a:p>
+          <a:p>
+            <a:pPr lvl="1">
+              <a:defRPr sz="1400" b="0">
+                <a:solidFill>
+                  <a:srgbClr val="000000"/>
+                </a:solidFill>
+                <a:latin typeface="Arial"/>
+              </a:defRPr>
+            </a:pPr>
+            <a:r>
+              <a:t>Geen winkans, geen pot odds, kijkt niet eens naar zijn kaarten</a:t>
+            </a:r>
+          </a:p>
+          <a:p>
+            <a:pPr lvl="1">
+              <a:defRPr sz="1400" b="0">
+                <a:solidFill>
+                  <a:srgbClr val="000000"/>
+                </a:solidFill>
+                <a:latin typeface="Arial"/>
+              </a:defRPr>
+            </a:pPr>
+            <a:r>
+              <a:t>De klas foldde 92,2% van alle beslissingen; negen bots foldden 99% of meer</a:t>
+            </a:r>
+          </a:p>
+          <a:p>
+            <a:pPr lvl="1">
+              <a:defRPr sz="1400" b="0">
+                <a:solidFill>
+                  <a:srgbClr val="505A64"/>
+                </a:solidFill>
+                <a:latin typeface="Arial"/>
+              </a:defRPr>
+            </a:pPr>
+            <a:r>
+              <a:t>Correlatie tussen fold% en eindstand: -0,69 — meer folden is minder eindigen</a:t>
+            </a:r>
+          </a:p>
+          <a:p>
+            <a:pPr>
+              <a:spcBef>
+                <a:spcPts val="1300"/>
+              </a:spcBef>
+              <a:defRPr sz="1700" b="1">
+                <a:solidFill>
+                  <a:srgbClr val="25167A"/>
+                </a:solidFill>
+                <a:latin typeface="Arial"/>
+              </a:defRPr>
+            </a:pPr>
+            <a:r>
+              <a:t>Waarom verliest een bot mét regels van een bot zonder regels?</a:t>
+            </a:r>
+          </a:p>
+        </p:txBody>
+      </p:sp>
+      <p:sp>
+        <p:nvSpPr>
+          <p:cNvPr id="4" name="TextBox 3"/>
+          <p:cNvSpPr txBox="1"/>
+          <p:nvPr/>
+        </p:nvSpPr>
+        <p:spPr>
+          <a:xfrm>
+            <a:off x="9774936" y="6126480"/>
+            <a:ext cx="630936" cy="365760"/>
+          </a:xfrm>
+          <a:prstGeom prst="rect">
+            <a:avLst/>
+          </a:prstGeom>
+          <a:noFill/>
+        </p:spPr>
+        <p:txBody>
+          <a:bodyPr wrap="none">
+            <a:spAutoFit/>
+          </a:bodyPr>
+          <a:lstStyle/>
+          <a:p>
+            <a:pPr>
+              <a:defRPr sz="1200">
+                <a:solidFill>
+                  <a:srgbClr val="505A64"/>
+                </a:solidFill>
+                <a:latin typeface="Arial"/>
+              </a:defRPr>
+            </a:pPr>
+            <a:r>
+              <a:t>25</a:t>
             </a:r>
           </a:p>
         </p:txBody>

</xml_diff>

<commit_message>
Case 2 aan het eind van het hoorcollege, en de testbot op Brightspace
Vier dia's erbij: wat je oplevert, de zeven criteria gesplitst naar IDS en VA,
de vijf voorwaarden met hun aftrek, en een slotdia die de demo van dat uur aan
drie van die criteria koppelt. Die laatste is het punt -- de curriculum-audit
constateerde dat studenten die koppeling zelf niet leggen.

De Let op op de week-3-pagina beloofde nog vijf referentiebots. Die zijn uit
week 3 gehaald; wat er nu wel speelt is Testbot_CalltAlles.

Co-Authored-By: Claude Opus 5 <noreply@anthropic.com>
</commit_message>
<xml_diff>
--- a/powerpoints/hoorcollege/03_Exploring_Manipulating_Data_aangevuld.pptx
+++ b/powerpoints/hoorcollege/03_Exploring_Manipulating_Data_aangevuld.pptx
@@ -35,6 +35,10 @@
     <p:sldId id="903" r:id="rId36"/>
     <p:sldId id="904" r:id="rId37"/>
     <p:sldId id="905" r:id="rId38"/>
+    <p:sldId id="906" r:id="rId39"/>
+    <p:sldId id="907" r:id="rId40"/>
+    <p:sldId id="908" r:id="rId41"/>
+    <p:sldId id="909" r:id="rId42"/>
   </p:sldIdLst>
   <p:sldSz cx="12192000" cy="6858000"/>
   <p:notesSz cx="6858000" cy="9144000"/>
@@ -12721,7 +12725,7 @@
               </a:defRPr>
             </a:pPr>
             <a:r>
-              <a:t>all_in en grote_raise mogen dan pas — zonder te weten hoeveel je hebt kun je dat niet afwegen</a:t>
+              <a:t>all_in en grote_raise mogen dan pas: zonder je stack kun je dat niet afwegen</a:t>
             </a:r>
           </a:p>
           <a:p>
@@ -13007,6 +13011,944 @@
             </a:pPr>
             <a:r>
               <a:t>25</a:t>
+            </a:r>
+          </a:p>
+        </p:txBody>
+      </p:sp>
+    </p:spTree>
+  </p:cSld>
+  <p:clrMapOvr>
+    <a:masterClrMapping/>
+  </p:clrMapOvr>
+</p:sld>
+</file>
+
+<file path=ppt/slides/slide26.xml><?xml version="1.0" encoding="utf-8"?>
+<p:sld xmlns:a="http://schemas.openxmlformats.org/drawingml/2006/main" xmlns:p="http://schemas.openxmlformats.org/presentationml/2006/main" xmlns:r="http://schemas.openxmlformats.org/officeDocument/2006/relationships">
+  <p:cSld>
+    <p:spTree>
+      <p:nvGrpSpPr>
+        <p:cNvPr id="1" name=""/>
+        <p:cNvGrpSpPr/>
+        <p:nvPr/>
+      </p:nvGrpSpPr>
+      <p:grpSpPr/>
+      <p:sp>
+        <p:nvSpPr>
+          <p:cNvPr id="2" name="TextBox 1"/>
+          <p:cNvSpPr txBox="1"/>
+          <p:nvPr/>
+        </p:nvSpPr>
+        <p:spPr>
+          <a:xfrm>
+            <a:off x="1984248" y="941832"/>
+            <a:ext cx="8229600" cy="1143000"/>
+          </a:xfrm>
+          <a:prstGeom prst="rect">
+            <a:avLst/>
+          </a:prstGeom>
+          <a:noFill/>
+        </p:spPr>
+        <p:txBody>
+          <a:bodyPr wrap="square">
+            <a:spAutoFit/>
+          </a:bodyPr>
+          <a:lstStyle/>
+          <a:p>
+            <a:pPr>
+              <a:defRPr sz="3200">
+                <a:solidFill>
+                  <a:srgbClr val="25167A"/>
+                </a:solidFill>
+                <a:latin typeface="Arial"/>
+              </a:defRPr>
+            </a:pPr>
+            <a:r>
+              <a:t>Groepscase 2 — wat je oplevert</a:t>
+            </a:r>
+          </a:p>
+        </p:txBody>
+      </p:sp>
+      <p:sp>
+        <p:nvSpPr>
+          <p:cNvPr id="3" name="TextBox 2"/>
+          <p:cNvSpPr txBox="1"/>
+          <p:nvPr/>
+        </p:nvSpPr>
+        <p:spPr>
+          <a:xfrm>
+            <a:off x="1984248" y="2084831"/>
+            <a:ext cx="8778240" cy="4041648"/>
+          </a:xfrm>
+          <a:prstGeom prst="rect">
+            <a:avLst/>
+          </a:prstGeom>
+          <a:noFill/>
+        </p:spPr>
+        <p:txBody>
+          <a:bodyPr wrap="square">
+            <a:spAutoFit/>
+          </a:bodyPr>
+          <a:lstStyle/>
+          <a:p>
+            <a:pPr>
+              <a:defRPr sz="1700" b="1">
+                <a:solidFill>
+                  <a:srgbClr val="000000"/>
+                </a:solidFill>
+                <a:latin typeface="Arial"/>
+              </a:defRPr>
+            </a:pPr>
+            <a:r>
+              <a:t>Een Streamlit-dashboard over een onderwerp dat je zelf kiest.</a:t>
+            </a:r>
+          </a:p>
+          <a:p>
+            <a:pPr lvl="1">
+              <a:defRPr sz="1400" b="0">
+                <a:solidFill>
+                  <a:srgbClr val="000000"/>
+                </a:solidFill>
+                <a:latin typeface="Arial"/>
+              </a:defRPr>
+            </a:pPr>
+            <a:r>
+              <a:t>Gepubliceerd via GitHub op share.streamlit.io, te openen met een link</a:t>
+            </a:r>
+          </a:p>
+          <a:p>
+            <a:pPr lvl="1">
+              <a:defRPr sz="1400" b="0">
+                <a:solidFill>
+                  <a:srgbClr val="000000"/>
+                </a:solidFill>
+                <a:latin typeface="Arial"/>
+              </a:defRPr>
+            </a:pPr>
+            <a:r>
+              <a:t>De app haalt de data zelf op bij een openbare API — niet met de hand gedownload</a:t>
+            </a:r>
+          </a:p>
+          <a:p>
+            <a:pPr lvl="1">
+              <a:defRPr sz="1400" b="0">
+                <a:solidFill>
+                  <a:srgbClr val="1B4D3E"/>
+                </a:solidFill>
+                <a:latin typeface="Arial"/>
+              </a:defRPr>
+            </a:pPr>
+            <a:r>
+              <a:t>Minimaal één join: twee bronnen die je tot één tabel samenvoegt</a:t>
+            </a:r>
+          </a:p>
+          <a:p>
+            <a:pPr>
+              <a:spcBef>
+                <a:spcPts val="1300"/>
+              </a:spcBef>
+              <a:defRPr sz="1700" b="1">
+                <a:solidFill>
+                  <a:srgbClr val="000000"/>
+                </a:solidFill>
+                <a:latin typeface="Arial"/>
+              </a:defRPr>
+            </a:pPr>
+            <a:r>
+              <a:t>Loopt over week 3 en week 4. Dat is kort.</a:t>
+            </a:r>
+          </a:p>
+          <a:p>
+            <a:pPr lvl="1">
+              <a:defRPr sz="1400" b="0">
+                <a:solidFill>
+                  <a:srgbClr val="000000"/>
+                </a:solidFill>
+                <a:latin typeface="Arial"/>
+              </a:defRPr>
+            </a:pPr>
+            <a:r>
+              <a:t>Donderdag 18:00 staat je onderwerp vast: welke vraag, welke twee bronnen,</a:t>
+            </a:r>
+          </a:p>
+          <a:p>
+            <a:pPr lvl="1">
+              <a:defRPr sz="1400" b="0">
+                <a:solidFill>
+                  <a:srgbClr val="000000"/>
+                </a:solidFill>
+                <a:latin typeface="Arial"/>
+              </a:defRPr>
+            </a:pPr>
+            <a:r>
+              <a:t>op welke kolom die aan elkaar passen, en wie in de groep wat doet</a:t>
+            </a:r>
+          </a:p>
+          <a:p>
+            <a:pPr>
+              <a:spcBef>
+                <a:spcPts val="1300"/>
+              </a:spcBef>
+              <a:defRPr sz="1700" b="1">
+                <a:solidFill>
+                  <a:srgbClr val="25167A"/>
+                </a:solidFill>
+                <a:latin typeface="Arial"/>
+              </a:defRPr>
+            </a:pPr>
+            <a:r>
+              <a:t>Zoek nu al op of die twee bronnen écht een gemeenschappelijke kolom hebben.</a:t>
+            </a:r>
+          </a:p>
+          <a:p>
+            <a:pPr lvl="1">
+              <a:defRPr sz="1400" b="0">
+                <a:solidFill>
+                  <a:srgbClr val="505A64"/>
+                </a:solidFill>
+                <a:latin typeface="Arial"/>
+              </a:defRPr>
+            </a:pPr>
+            <a:r>
+              <a:t>"Den Haag" en "'s-Gravenhage" passen niet op elkaar zonder werk</a:t>
+            </a:r>
+          </a:p>
+        </p:txBody>
+      </p:sp>
+      <p:sp>
+        <p:nvSpPr>
+          <p:cNvPr id="4" name="TextBox 3"/>
+          <p:cNvSpPr txBox="1"/>
+          <p:nvPr/>
+        </p:nvSpPr>
+        <p:spPr>
+          <a:xfrm>
+            <a:off x="9774936" y="6126480"/>
+            <a:ext cx="630936" cy="365760"/>
+          </a:xfrm>
+          <a:prstGeom prst="rect">
+            <a:avLst/>
+          </a:prstGeom>
+          <a:noFill/>
+        </p:spPr>
+        <p:txBody>
+          <a:bodyPr wrap="none">
+            <a:spAutoFit/>
+          </a:bodyPr>
+          <a:lstStyle/>
+          <a:p>
+            <a:pPr>
+              <a:defRPr sz="1200">
+                <a:solidFill>
+                  <a:srgbClr val="505A64"/>
+                </a:solidFill>
+                <a:latin typeface="Arial"/>
+              </a:defRPr>
+            </a:pPr>
+            <a:r>
+              <a:t>26</a:t>
+            </a:r>
+          </a:p>
+        </p:txBody>
+      </p:sp>
+    </p:spTree>
+  </p:cSld>
+  <p:clrMapOvr>
+    <a:masterClrMapping/>
+  </p:clrMapOvr>
+</p:sld>
+</file>
+
+<file path=ppt/slides/slide27.xml><?xml version="1.0" encoding="utf-8"?>
+<p:sld xmlns:a="http://schemas.openxmlformats.org/drawingml/2006/main" xmlns:p="http://schemas.openxmlformats.org/presentationml/2006/main" xmlns:r="http://schemas.openxmlformats.org/officeDocument/2006/relationships">
+  <p:cSld>
+    <p:spTree>
+      <p:nvGrpSpPr>
+        <p:cNvPr id="1" name=""/>
+        <p:cNvGrpSpPr/>
+        <p:nvPr/>
+      </p:nvGrpSpPr>
+      <p:grpSpPr/>
+      <p:sp>
+        <p:nvSpPr>
+          <p:cNvPr id="2" name="TextBox 1"/>
+          <p:cNvSpPr txBox="1"/>
+          <p:nvPr/>
+        </p:nvSpPr>
+        <p:spPr>
+          <a:xfrm>
+            <a:off x="1984248" y="941832"/>
+            <a:ext cx="8229600" cy="1143000"/>
+          </a:xfrm>
+          <a:prstGeom prst="rect">
+            <a:avLst/>
+          </a:prstGeom>
+          <a:noFill/>
+        </p:spPr>
+        <p:txBody>
+          <a:bodyPr wrap="square">
+            <a:spAutoFit/>
+          </a:bodyPr>
+          <a:lstStyle/>
+          <a:p>
+            <a:pPr>
+              <a:defRPr sz="3200">
+                <a:solidFill>
+                  <a:srgbClr val="25167A"/>
+                </a:solidFill>
+                <a:latin typeface="Arial"/>
+              </a:defRPr>
+            </a:pPr>
+            <a:r>
+              <a:t>Waar je cijfer vandaan komt</a:t>
+            </a:r>
+          </a:p>
+        </p:txBody>
+      </p:sp>
+      <p:sp>
+        <p:nvSpPr>
+          <p:cNvPr id="3" name="TextBox 2"/>
+          <p:cNvSpPr txBox="1"/>
+          <p:nvPr/>
+        </p:nvSpPr>
+        <p:spPr>
+          <a:xfrm>
+            <a:off x="1984248" y="2084831"/>
+            <a:ext cx="8778240" cy="4041648"/>
+          </a:xfrm>
+          <a:prstGeom prst="rect">
+            <a:avLst/>
+          </a:prstGeom>
+          <a:noFill/>
+        </p:spPr>
+        <p:txBody>
+          <a:bodyPr wrap="square">
+            <a:spAutoFit/>
+          </a:bodyPr>
+          <a:lstStyle/>
+          <a:p>
+            <a:pPr>
+              <a:defRPr sz="1700" b="1">
+                <a:solidFill>
+                  <a:srgbClr val="25167A"/>
+                </a:solidFill>
+                <a:latin typeface="Arial"/>
+              </a:defRPr>
+            </a:pPr>
+            <a:r>
+              <a:t>Drie criteria voor IDS — de data-kant</a:t>
+            </a:r>
+          </a:p>
+          <a:p>
+            <a:pPr lvl="1">
+              <a:defRPr sz="1400" b="0">
+                <a:solidFill>
+                  <a:srgbClr val="000000"/>
+                </a:solidFill>
+                <a:latin typeface="Arial"/>
+              </a:defRPr>
+            </a:pPr>
+            <a:r>
+              <a:t>Data verzameling · twee bronnen, plus de sleutel en de rijen vóór en ná de join</a:t>
+            </a:r>
+          </a:p>
+          <a:p>
+            <a:pPr lvl="1">
+              <a:defRPr sz="1400" b="0">
+                <a:solidFill>
+                  <a:srgbClr val="000000"/>
+                </a:solidFill>
+                <a:latin typeface="Arial"/>
+              </a:defRPr>
+            </a:pPr>
+            <a:r>
+              <a:t>Data verkenning · lege waarden, bereik, dubbele rijen — en wat je ermee deed</a:t>
+            </a:r>
+          </a:p>
+          <a:p>
+            <a:pPr lvl="1">
+              <a:defRPr sz="1400" b="0">
+                <a:solidFill>
+                  <a:srgbClr val="000000"/>
+                </a:solidFill>
+                <a:latin typeface="Arial"/>
+              </a:defRPr>
+            </a:pPr>
+            <a:r>
+              <a:t>Analyse · een conclusie die de data draagt, niet meer dan dat</a:t>
+            </a:r>
+          </a:p>
+          <a:p>
+            <a:pPr>
+              <a:spcBef>
+                <a:spcPts val="1300"/>
+              </a:spcBef>
+              <a:defRPr sz="1700" b="1">
+                <a:solidFill>
+                  <a:srgbClr val="25167A"/>
+                </a:solidFill>
+                <a:latin typeface="Arial"/>
+              </a:defRPr>
+            </a:pPr>
+            <a:r>
+              <a:t>Vier criteria voor VA — de verhaalkant</a:t>
+            </a:r>
+          </a:p>
+          <a:p>
+            <a:pPr lvl="1">
+              <a:defRPr sz="1400" b="0">
+                <a:solidFill>
+                  <a:srgbClr val="000000"/>
+                </a:solidFill>
+                <a:latin typeface="Arial"/>
+              </a:defRPr>
+            </a:pPr>
+            <a:r>
+              <a:t>Opbouw en verhaallijn · Interactiviteit · Dashboardontwerp</a:t>
+            </a:r>
+          </a:p>
+          <a:p>
+            <a:pPr lvl="1">
+              <a:defRPr sz="1400" b="0">
+                <a:solidFill>
+                  <a:srgbClr val="000000"/>
+                </a:solidFill>
+                <a:latin typeface="Arial"/>
+              </a:defRPr>
+            </a:pPr>
+            <a:r>
+              <a:t>Vergelijken en annoteren · het verschil, het opgetelde verloop, of de waarde</a:t>
+            </a:r>
+          </a:p>
+          <a:p>
+            <a:pPr lvl="1">
+              <a:defRPr sz="1400" b="0">
+                <a:solidFill>
+                  <a:srgbClr val="1B4D3E"/>
+                </a:solidFill>
+                <a:latin typeface="Arial"/>
+              </a:defRPr>
+            </a:pPr>
+            <a:r>
+              <a:t>ten opzichte van het moment ervoor — diff, cumsum, shift</a:t>
+            </a:r>
+          </a:p>
+          <a:p>
+            <a:pPr>
+              <a:spcBef>
+                <a:spcPts val="1300"/>
+              </a:spcBef>
+              <a:defRPr sz="1700" b="1">
+                <a:solidFill>
+                  <a:srgbClr val="000000"/>
+                </a:solidFill>
+                <a:latin typeface="Arial"/>
+              </a:defRPr>
+            </a:pPr>
+            <a:r>
+              <a:t>Vijf niveaus, van Ontbreekt (1) tot Uitstekend (9).</a:t>
+            </a:r>
+          </a:p>
+        </p:txBody>
+      </p:sp>
+      <p:sp>
+        <p:nvSpPr>
+          <p:cNvPr id="4" name="TextBox 3"/>
+          <p:cNvSpPr txBox="1"/>
+          <p:nvPr/>
+        </p:nvSpPr>
+        <p:spPr>
+          <a:xfrm>
+            <a:off x="9774936" y="6126480"/>
+            <a:ext cx="630936" cy="365760"/>
+          </a:xfrm>
+          <a:prstGeom prst="rect">
+            <a:avLst/>
+          </a:prstGeom>
+          <a:noFill/>
+        </p:spPr>
+        <p:txBody>
+          <a:bodyPr wrap="none">
+            <a:spAutoFit/>
+          </a:bodyPr>
+          <a:lstStyle/>
+          <a:p>
+            <a:pPr>
+              <a:defRPr sz="1200">
+                <a:solidFill>
+                  <a:srgbClr val="505A64"/>
+                </a:solidFill>
+                <a:latin typeface="Arial"/>
+              </a:defRPr>
+            </a:pPr>
+            <a:r>
+              <a:t>27</a:t>
+            </a:r>
+          </a:p>
+        </p:txBody>
+      </p:sp>
+    </p:spTree>
+  </p:cSld>
+  <p:clrMapOvr>
+    <a:masterClrMapping/>
+  </p:clrMapOvr>
+</p:sld>
+</file>
+
+<file path=ppt/slides/slide28.xml><?xml version="1.0" encoding="utf-8"?>
+<p:sld xmlns:a="http://schemas.openxmlformats.org/drawingml/2006/main" xmlns:p="http://schemas.openxmlformats.org/presentationml/2006/main" xmlns:r="http://schemas.openxmlformats.org/officeDocument/2006/relationships">
+  <p:cSld>
+    <p:spTree>
+      <p:nvGrpSpPr>
+        <p:cNvPr id="1" name=""/>
+        <p:cNvGrpSpPr/>
+        <p:nvPr/>
+      </p:nvGrpSpPr>
+      <p:grpSpPr/>
+      <p:sp>
+        <p:nvSpPr>
+          <p:cNvPr id="2" name="TextBox 1"/>
+          <p:cNvSpPr txBox="1"/>
+          <p:nvPr/>
+        </p:nvSpPr>
+        <p:spPr>
+          <a:xfrm>
+            <a:off x="1984248" y="941832"/>
+            <a:ext cx="8229600" cy="1143000"/>
+          </a:xfrm>
+          <a:prstGeom prst="rect">
+            <a:avLst/>
+          </a:prstGeom>
+          <a:noFill/>
+        </p:spPr>
+        <p:txBody>
+          <a:bodyPr wrap="square">
+            <a:spAutoFit/>
+          </a:bodyPr>
+          <a:lstStyle/>
+          <a:p>
+            <a:pPr>
+              <a:defRPr sz="3200">
+                <a:solidFill>
+                  <a:srgbClr val="25167A"/>
+                </a:solidFill>
+                <a:latin typeface="Arial"/>
+              </a:defRPr>
+            </a:pPr>
+            <a:r>
+              <a:t>Vijf voorwaarden — die gaan van je cijfer af</a:t>
+            </a:r>
+          </a:p>
+        </p:txBody>
+      </p:sp>
+      <p:sp>
+        <p:nvSpPr>
+          <p:cNvPr id="3" name="TextBox 2"/>
+          <p:cNvSpPr txBox="1"/>
+          <p:nvPr/>
+        </p:nvSpPr>
+        <p:spPr>
+          <a:xfrm>
+            <a:off x="1984248" y="2084831"/>
+            <a:ext cx="8778240" cy="4041648"/>
+          </a:xfrm>
+          <a:prstGeom prst="rect">
+            <a:avLst/>
+          </a:prstGeom>
+          <a:noFill/>
+        </p:spPr>
+        <p:txBody>
+          <a:bodyPr wrap="square">
+            <a:spAutoFit/>
+          </a:bodyPr>
+          <a:lstStyle/>
+          <a:p>
+            <a:pPr>
+              <a:defRPr sz="1700" b="1">
+                <a:solidFill>
+                  <a:srgbClr val="000000"/>
+                </a:solidFill>
+                <a:latin typeface="Arial"/>
+              </a:defRPr>
+            </a:pPr>
+            <a:r>
+              <a:t>Dit zijn geen criteria maar drempels. Beide cijfers, IDS en VA.</a:t>
+            </a:r>
+          </a:p>
+          <a:p>
+            <a:pPr lvl="1">
+              <a:defRPr sz="1400" b="0">
+                <a:solidFill>
+                  <a:srgbClr val="000000"/>
+                </a:solidFill>
+                <a:latin typeface="Arial"/>
+              </a:defRPr>
+            </a:pPr>
+            <a:r>
+              <a:t>App niet online, of een schone clone draait niet zonder handwerk</a:t>
+            </a:r>
+          </a:p>
+          <a:p>
+            <a:pPr lvl="1">
+              <a:defRPr sz="1400" b="0">
+                <a:solidFill>
+                  <a:srgbClr val="25167A"/>
+                </a:solidFill>
+                <a:latin typeface="Arial"/>
+              </a:defRPr>
+            </a:pPr>
+            <a:r>
+              <a:t>     -1,0</a:t>
+            </a:r>
+          </a:p>
+          <a:p>
+            <a:pPr lvl="1">
+              <a:defRPr sz="1400" b="0">
+                <a:solidFill>
+                  <a:srgbClr val="000000"/>
+                </a:solidFill>
+                <a:latin typeface="Arial"/>
+              </a:defRPr>
+            </a:pPr>
+            <a:r>
+              <a:t>Presentatie langer dan 10 minuten, exclusief vragen</a:t>
+            </a:r>
+          </a:p>
+          <a:p>
+            <a:pPr lvl="1">
+              <a:defRPr sz="1400" b="0">
+                <a:solidFill>
+                  <a:srgbClr val="25167A"/>
+                </a:solidFill>
+                <a:latin typeface="Arial"/>
+              </a:defRPr>
+            </a:pPr>
+            <a:r>
+              <a:t>     -1,0</a:t>
+            </a:r>
+          </a:p>
+          <a:p>
+            <a:pPr lvl="1">
+              <a:defRPr sz="1400" b="0">
+                <a:solidFill>
+                  <a:srgbClr val="000000"/>
+                </a:solidFill>
+                <a:latin typeface="Arial"/>
+              </a:defRPr>
+            </a:pPr>
+            <a:r>
+              <a:t>Geen slider, checkbox én dropdown, elk gekoppeld aan een tabel of grafiek</a:t>
+            </a:r>
+          </a:p>
+          <a:p>
+            <a:pPr lvl="1">
+              <a:defRPr sz="1400" b="0">
+                <a:solidFill>
+                  <a:srgbClr val="25167A"/>
+                </a:solidFill>
+                <a:latin typeface="Arial"/>
+              </a:defRPr>
+            </a:pPr>
+            <a:r>
+              <a:t>     -0,5</a:t>
+            </a:r>
+          </a:p>
+          <a:p>
+            <a:pPr>
+              <a:spcBef>
+                <a:spcPts val="1300"/>
+              </a:spcBef>
+              <a:defRPr sz="1700" b="1">
+                <a:solidFill>
+                  <a:srgbClr val="000000"/>
+                </a:solidFill>
+                <a:latin typeface="Arial"/>
+              </a:defRPr>
+            </a:pPr>
+            <a:r>
+              <a:t>En twee zonder aftrek, maar niet vrijblijvend:</a:t>
+            </a:r>
+          </a:p>
+          <a:p>
+            <a:pPr lvl="1">
+              <a:defRPr sz="1400" b="0">
+                <a:solidFill>
+                  <a:srgbClr val="505A64"/>
+                </a:solidFill>
+                <a:latin typeface="Arial"/>
+              </a:defRPr>
+            </a:pPr>
+            <a:r>
+              <a:t>Onderwerp op tijd gemeld · code van anderen met bron erbij, en uit te leggen</a:t>
+            </a:r>
+          </a:p>
+        </p:txBody>
+      </p:sp>
+      <p:sp>
+        <p:nvSpPr>
+          <p:cNvPr id="4" name="TextBox 3"/>
+          <p:cNvSpPr txBox="1"/>
+          <p:nvPr/>
+        </p:nvSpPr>
+        <p:spPr>
+          <a:xfrm>
+            <a:off x="9774936" y="6126480"/>
+            <a:ext cx="630936" cy="365760"/>
+          </a:xfrm>
+          <a:prstGeom prst="rect">
+            <a:avLst/>
+          </a:prstGeom>
+          <a:noFill/>
+        </p:spPr>
+        <p:txBody>
+          <a:bodyPr wrap="none">
+            <a:spAutoFit/>
+          </a:bodyPr>
+          <a:lstStyle/>
+          <a:p>
+            <a:pPr>
+              <a:defRPr sz="1200">
+                <a:solidFill>
+                  <a:srgbClr val="505A64"/>
+                </a:solidFill>
+                <a:latin typeface="Arial"/>
+              </a:defRPr>
+            </a:pPr>
+            <a:r>
+              <a:t>28</a:t>
+            </a:r>
+          </a:p>
+        </p:txBody>
+      </p:sp>
+    </p:spTree>
+  </p:cSld>
+  <p:clrMapOvr>
+    <a:masterClrMapping/>
+  </p:clrMapOvr>
+</p:sld>
+</file>
+
+<file path=ppt/slides/slide29.xml><?xml version="1.0" encoding="utf-8"?>
+<p:sld xmlns:a="http://schemas.openxmlformats.org/drawingml/2006/main" xmlns:p="http://schemas.openxmlformats.org/presentationml/2006/main" xmlns:r="http://schemas.openxmlformats.org/officeDocument/2006/relationships">
+  <p:cSld>
+    <p:spTree>
+      <p:nvGrpSpPr>
+        <p:cNvPr id="1" name=""/>
+        <p:cNvGrpSpPr/>
+        <p:nvPr/>
+      </p:nvGrpSpPr>
+      <p:grpSpPr/>
+      <p:sp>
+        <p:nvSpPr>
+          <p:cNvPr id="2" name="TextBox 1"/>
+          <p:cNvSpPr txBox="1"/>
+          <p:nvPr/>
+        </p:nvSpPr>
+        <p:spPr>
+          <a:xfrm>
+            <a:off x="1984248" y="941832"/>
+            <a:ext cx="8229600" cy="1143000"/>
+          </a:xfrm>
+          <a:prstGeom prst="rect">
+            <a:avLst/>
+          </a:prstGeom>
+          <a:noFill/>
+        </p:spPr>
+        <p:txBody>
+          <a:bodyPr wrap="square">
+            <a:spAutoFit/>
+          </a:bodyPr>
+          <a:lstStyle/>
+          <a:p>
+            <a:pPr>
+              <a:defRPr sz="3200">
+                <a:solidFill>
+                  <a:srgbClr val="25167A"/>
+                </a:solidFill>
+                <a:latin typeface="Arial"/>
+              </a:defRPr>
+            </a:pPr>
+            <a:r>
+              <a:t>Dat heb je vanmiddag al gedaan</a:t>
+            </a:r>
+          </a:p>
+        </p:txBody>
+      </p:sp>
+      <p:sp>
+        <p:nvSpPr>
+          <p:cNvPr id="3" name="TextBox 2"/>
+          <p:cNvSpPr txBox="1"/>
+          <p:nvPr/>
+        </p:nvSpPr>
+        <p:spPr>
+          <a:xfrm>
+            <a:off x="1984248" y="2084831"/>
+            <a:ext cx="8778240" cy="4041648"/>
+          </a:xfrm>
+          <a:prstGeom prst="rect">
+            <a:avLst/>
+          </a:prstGeom>
+          <a:noFill/>
+        </p:spPr>
+        <p:txBody>
+          <a:bodyPr wrap="square">
+            <a:spAutoFit/>
+          </a:bodyPr>
+          <a:lstStyle/>
+          <a:p>
+            <a:pPr>
+              <a:defRPr sz="1700" b="1">
+                <a:solidFill>
+                  <a:srgbClr val="000000"/>
+                </a:solidFill>
+                <a:latin typeface="Arial"/>
+              </a:defRPr>
+            </a:pPr>
+            <a:r>
+              <a:t>De demo van zojuist was Case 2 in het klein:</a:t>
+            </a:r>
+          </a:p>
+          <a:p>
+            <a:pPr lvl="1">
+              <a:defRPr sz="1400" b="0">
+                <a:solidFill>
+                  <a:srgbClr val="1B4D3E"/>
+                </a:solidFill>
+                <a:latin typeface="Arial"/>
+              </a:defRPr>
+            </a:pPr>
+            <a:r>
+              <a:t>twee tabellen op bot_naam samengevoegd, rijen geteld vóór en ná</a:t>
+            </a:r>
+          </a:p>
+          <a:p>
+            <a:pPr lvl="1">
+              <a:defRPr sz="1400" b="0">
+                <a:solidFill>
+                  <a:srgbClr val="000000"/>
+                </a:solidFill>
+                <a:latin typeface="Arial"/>
+              </a:defRPr>
+            </a:pPr>
+            <a:r>
+              <a:t>     → criterium Data verzameling</a:t>
+            </a:r>
+          </a:p>
+          <a:p>
+            <a:pPr lvl="1">
+              <a:defRPr sz="1400" b="0">
+                <a:solidFill>
+                  <a:srgbClr val="1B4D3E"/>
+                </a:solidFill>
+                <a:latin typeface="Arial"/>
+              </a:defRPr>
+            </a:pPr>
+            <a:r>
+              <a:t>928 lege waarden gevonden, en gezien wat ze met je percentage deden</a:t>
+            </a:r>
+          </a:p>
+          <a:p>
+            <a:pPr lvl="1">
+              <a:defRPr sz="1400" b="0">
+                <a:solidFill>
+                  <a:srgbClr val="000000"/>
+                </a:solidFill>
+                <a:latin typeface="Arial"/>
+              </a:defRPr>
+            </a:pPr>
+            <a:r>
+              <a:t>     → criterium Data verkenning</a:t>
+            </a:r>
+          </a:p>
+          <a:p>
+            <a:pPr lvl="1">
+              <a:defRPr sz="1400" b="0">
+                <a:solidFill>
+                  <a:srgbClr val="1B4D3E"/>
+                </a:solidFill>
+                <a:latin typeface="Arial"/>
+              </a:defRPr>
+            </a:pPr>
+            <a:r>
+              <a:t>diff en cumsum over het verloop van een stack</a:t>
+            </a:r>
+          </a:p>
+          <a:p>
+            <a:pPr lvl="1">
+              <a:defRPr sz="1400" b="0">
+                <a:solidFill>
+                  <a:srgbClr val="000000"/>
+                </a:solidFill>
+                <a:latin typeface="Arial"/>
+              </a:defRPr>
+            </a:pPr>
+            <a:r>
+              <a:t>     → criterium Vergelijken en annoteren</a:t>
+            </a:r>
+          </a:p>
+          <a:p>
+            <a:pPr>
+              <a:spcBef>
+                <a:spcPts val="1300"/>
+              </a:spcBef>
+              <a:defRPr sz="1700" b="1">
+                <a:solidFill>
+                  <a:srgbClr val="000000"/>
+                </a:solidFill>
+                <a:latin typeface="Arial"/>
+              </a:defRPr>
+            </a:pPr>
+            <a:r>
+              <a:t>Het verschil met de case: daar kiest niemand de dataset voor je,</a:t>
+            </a:r>
+          </a:p>
+          <a:p>
+            <a:pPr lvl="1">
+              <a:defRPr sz="1400" b="0">
+                <a:solidFill>
+                  <a:srgbClr val="505A64"/>
+                </a:solidFill>
+                <a:latin typeface="Arial"/>
+              </a:defRPr>
+            </a:pPr>
+            <a:r>
+              <a:t>en staat er geen kolom aan_zet klaar om je fout te laten zien.</a:t>
+            </a:r>
+          </a:p>
+        </p:txBody>
+      </p:sp>
+      <p:sp>
+        <p:nvSpPr>
+          <p:cNvPr id="4" name="TextBox 3"/>
+          <p:cNvSpPr txBox="1"/>
+          <p:nvPr/>
+        </p:nvSpPr>
+        <p:spPr>
+          <a:xfrm>
+            <a:off x="9774936" y="6126480"/>
+            <a:ext cx="630936" cy="365760"/>
+          </a:xfrm>
+          <a:prstGeom prst="rect">
+            <a:avLst/>
+          </a:prstGeom>
+          <a:noFill/>
+        </p:spPr>
+        <p:txBody>
+          <a:bodyPr wrap="none">
+            <a:spAutoFit/>
+          </a:bodyPr>
+          <a:lstStyle/>
+          <a:p>
+            <a:pPr>
+              <a:defRPr sz="1200">
+                <a:solidFill>
+                  <a:srgbClr val="505A64"/>
+                </a:solidFill>
+                <a:latin typeface="Arial"/>
+              </a:defRPr>
+            </a:pPr>
+            <a:r>
+              <a:t>29</a:t>
             </a:r>
           </a:p>
         </p:txBody>

</xml_diff>

<commit_message>
De vier blokken van het doorloopblad zijn dia's, en de cijfers komen uit één bron
Blok 1 en 2 stonden alleen in de notities, blok 3 en 4 als dia met getallen die
ik met de hand had overgetypt. Dat ging mis: "5 handen onder de -200" werd
onderweg een 9, en dat ziet niemand terug -- het is een plausibel getal op een
nette dia. Het doorloopblad is gecorrigeerd.

Daarom rekent scripts/toernooicijfers.py de cijfers nu uit en delen de drie
afnemers hem: collegecijfers.py print ze, maak_histogram_hoorcollege.py tekent
ze, vul_hoorcollege_aan.py zet ze op de dia. Eén set bakjesgrenzen, één
winstberekening. Overtypen kan niet meer.

Zes nieuwe dia's: de vier blokken, plus de verdeling als echte plaat. Die staat
op een log-y-as, want lineair zie je één balk en verder wit -- df["winst"]
.hist(bins=40) geeft precies dat lege plaatje, en dat is zelf een vraag voor de
zaal.

Co-Authored-By: Claude Opus 5 <noreply@anthropic.com>
</commit_message>
<xml_diff>
--- a/powerpoints/hoorcollege/03_Exploring_Manipulating_Data_aangevuld.pptx
+++ b/powerpoints/hoorcollege/03_Exploring_Manipulating_Data_aangevuld.pptx
@@ -41,6 +41,9 @@
     <p:sldId id="909" r:id="rId42"/>
     <p:sldId id="910" r:id="rId43"/>
     <p:sldId id="911" r:id="rId44"/>
+    <p:sldId id="912" r:id="rId45"/>
+    <p:sldId id="913" r:id="rId46"/>
+    <p:sldId id="914" r:id="rId47"/>
   </p:sldIdLst>
   <p:sldSz cx="12192000" cy="6858000"/>
   <p:notesSz cx="6858000" cy="9144000"/>
@@ -2105,33 +2108,33 @@
           <a:lstStyle/>
           <a:p>
             <a:r>
-              <a:t>De deadline is donderdag 18:00 en dat is geen</a:t>
-            </a:r>
-          </a:p>
-          <a:p>
-            <a:r>
-              <a:t>inlevermoment maar een BESLUIT: welke vraag, welke twee bronnen, op welke kolom die</a:t>
-            </a:r>
-          </a:p>
-          <a:p>
-            <a:r>
-              <a:t>aan elkaar passen, wie doet wat.</a:t>
+              <a:t>De y-as is logaritmisch, en dat is geen truc maar de</a:t>
+            </a:r>
+          </a:p>
+          <a:p>
+            <a:r>
+              <a:t>enige manier om allebei te zien: de piek is duizenden handen hoog en de staart is</a:t>
+            </a:r>
+          </a:p>
+          <a:p>
+            <a:r>
+              <a:t>één hand. Lineair zie je één balk en verder wit.</a:t>
             </a:r>
           </a:p>
           <a:p/>
           <a:p>
             <a:r>
-              <a:t>Het zinnetje over Den Haag en 's-Gravenhage is niet grappig bedoeld. Laat ze nu al</a:t>
-            </a:r>
-          </a:p>
-          <a:p>
-            <a:r>
-              <a:t>een keer kijken of hun twee bronnen echt een gemeenschappelijke kolom hebben met</a:t>
-            </a:r>
-          </a:p>
-          <a:p>
-            <a:r>
-              <a:t>dezelfde schrijfwijze.</a:t>
+              <a:t>Goede vraag aan de zaal: df["winst"].hist(bins=40) geeft precies dat lege plaatje.</a:t>
+            </a:r>
+          </a:p>
+          <a:p>
+            <a:r>
+              <a:t>Wie had gemerkt dat er iets ontbrak? De standaardinstelling van een grafiek is een</a:t>
+            </a:r>
+          </a:p>
+          <a:p>
+            <a:r>
+              <a:t>keuze die iemand anders voor je heeft gemaakt.</a:t>
             </a:r>
           </a:p>
         </p:txBody>
@@ -2201,22 +2204,44 @@
           <a:lstStyle/>
           <a:p>
             <a:r>
-              <a:t>Vergelijken en annoteren is het criterium waar</a:t>
-            </a:r>
-          </a:p>
-          <a:p>
-            <a:r>
-              <a:t>groepen punten laten liggen. Het vraagt diff, cumsum of shift - het verschil met het</a:t>
-            </a:r>
-          </a:p>
-          <a:p>
-            <a:r>
-              <a:t>moment ervoor, niet alleen de waarde. Ze hebben diff vanmiddag al gebruikt om de</a:t>
-            </a:r>
-          </a:p>
-          <a:p>
-            <a:r>
-              <a:t>winst-kolom te maken; zeg dat er hardop bij.</a:t>
+              <a:t>[Blok 3 - het gesprek van vandaag] Laat ze de</a:t>
+            </a:r>
+          </a:p>
+          <a:p>
+            <a:r>
+              <a:t>tabel zelf lezen voordat je iets zegt.</a:t>
+            </a:r>
+          </a:p>
+          <a:p/>
+          <a:p>
+            <a:r>
+              <a:t>De vraag is niet "waarom foldt de klas zoveel" maar "waarom levert elke andere actie</a:t>
+            </a:r>
+          </a:p>
+          <a:p>
+            <a:r>
+              <a:t>gemiddeld geld op, en doet niemand het". Antwoord: aan een tafel van folders wint de</a:t>
+            </a:r>
+          </a:p>
+          <a:p>
+            <a:r>
+              <a:t>big blind de small blind. Folden kost je bijna niets - en levert je ook niets op.</a:t>
+            </a:r>
+          </a:p>
+          <a:p/>
+          <a:p>
+            <a:r>
+              <a:t>Let op bij het navolgen: filter op aan_zet, anders tel je handen mee waarin de bot</a:t>
+            </a:r>
+          </a:p>
+          <a:p>
+            <a:r>
+              <a:t>nooit iets koos en komt elk percentage te laag uit. Dat is dezelfde val als in de</a:t>
+            </a:r>
+          </a:p>
+          <a:p>
+            <a:r>
+              <a:t>demo van vanmiddag.</a:t>
             </a:r>
           </a:p>
         </p:txBody>
@@ -2286,23 +2311,55 @@
           <a:lstStyle/>
           <a:p>
             <a:r>
-              <a:t>Deze dia is saai en bespaart je</a:t>
-            </a:r>
-          </a:p>
-          <a:p>
-            <a:r>
-              <a:t>in week 4 een half uur discussie. De aftrek gaat van BEIDE cijfers af, IDS en VA.</a:t>
+              <a:t>[Blok 4 - hier eindig je] Laat de uitslag</a:t>
+            </a:r>
+          </a:p>
+          <a:p>
+            <a:r>
+              <a:t>even staan voordat je hem uitlegt.</a:t>
             </a:r>
           </a:p>
           <a:p/>
           <a:p>
             <a:r>
-              <a:t>"Een schone clone draait zonder handmatige stappen" is de zwaarste: hun app moet het</a:t>
-            </a:r>
-          </a:p>
-          <a:p>
-            <a:r>
-              <a:t>doen op een computer die hun notebook nooit heeft gezien.</a:t>
+              <a:t>Het gaat niet om "de domme bot wint". Het gaat om: jullie drempels staan zo hoog dat</a:t>
+            </a:r>
+          </a:p>
+          <a:p>
+            <a:r>
+              <a:t>niet meedoen bijna net zo goed werkt als meedoen. Kijk naar nummer twee - die foldt</a:t>
+            </a:r>
+          </a:p>
+          <a:p>
+            <a:r>
+              <a:t>ruim tachtig procent en niet negenennegentig, en dat is het verschil.</a:t>
+            </a:r>
+          </a:p>
+          <a:p/>
+          <a:p>
+            <a:r>
+              <a:t>Over de correlatie: niet doorslaan. Een handvol bots draagt dat getal en een paar</a:t>
+            </a:r>
+          </a:p>
+          <a:p>
+            <a:r>
+              <a:t>tientallen punten is weinig. Dat onderscheid, zie ik een verband tegenover heb ik</a:t>
+            </a:r>
+          </a:p>
+          <a:p>
+            <a:r>
+              <a:t>iets aangetoond, is precies wat het criterium Analyse van Case 2 beoordeelt.</a:t>
+            </a:r>
+          </a:p>
+          <a:p/>
+          <a:p>
+            <a:r>
+              <a:t>De vraag voor donderdag is niet "moet ik minder folden" maar "waar liggen mijn</a:t>
+            </a:r>
+          </a:p>
+          <a:p>
+            <a:r>
+              <a:t>drempels, en waarom daar".</a:t>
             </a:r>
           </a:p>
         </p:txBody>
@@ -2372,22 +2429,33 @@
           <a:lstStyle/>
           <a:p>
             <a:r>
-              <a:t>Dit is de dia die de curriculum-audit vroeg.</a:t>
-            </a:r>
-          </a:p>
-          <a:p>
-            <a:r>
-              <a:t>Studenten leggen de koppeling tussen werkcollege en rubric zelf niet. Een zin - dit</a:t>
-            </a:r>
-          </a:p>
-          <a:p>
-            <a:r>
-              <a:t>is het criterium waarop je case wordt beoordeeld - is het verschil tussen een</a:t>
-            </a:r>
-          </a:p>
-          <a:p>
-            <a:r>
-              <a:t>oefening en een reden.</a:t>
+              <a:t>De deadline is donderdag 18:00 en dat is geen</a:t>
+            </a:r>
+          </a:p>
+          <a:p>
+            <a:r>
+              <a:t>inlevermoment maar een BESLUIT: welke vraag, welke twee bronnen, op welke kolom die</a:t>
+            </a:r>
+          </a:p>
+          <a:p>
+            <a:r>
+              <a:t>aan elkaar passen, wie doet wat.</a:t>
+            </a:r>
+          </a:p>
+          <a:p/>
+          <a:p>
+            <a:r>
+              <a:t>Het zinnetje over Den Haag en 's-Gravenhage is niet grappig bedoeld. Laat ze nu al</a:t>
+            </a:r>
+          </a:p>
+          <a:p>
+            <a:r>
+              <a:t>een keer kijken of hun twee bronnen echt een gemeenschappelijke kolom hebben met</a:t>
+            </a:r>
+          </a:p>
+          <a:p>
+            <a:r>
+              <a:t>dezelfde schrijfwijze.</a:t>
             </a:r>
           </a:p>
         </p:txBody>
@@ -2457,17 +2525,22 @@
           <a:lstStyle/>
           <a:p>
             <a:r>
-              <a:t>[EDA-recept] Dit recept is precies de volgorde van de demo straks:</a:t>
-            </a:r>
-          </a:p>
-          <a:p>
-            <a:r>
-              <a:t>describe -&gt; univariaat -&gt; bivariaat. Blok 1 is describe, blok 3 is bivariaat.</a:t>
-            </a:r>
-          </a:p>
-          <a:p>
-            <a:r>
-              <a:t>Zeg dat je het zo meteen op hun eigen toernooi doet, dan luisteren ze anders.</a:t>
+              <a:t>Vergelijken en annoteren is het criterium waar</a:t>
+            </a:r>
+          </a:p>
+          <a:p>
+            <a:r>
+              <a:t>groepen punten laten liggen. Het vraagt diff, cumsum of shift - het verschil met het</a:t>
+            </a:r>
+          </a:p>
+          <a:p>
+            <a:r>
+              <a:t>moment ervoor, niet alleen de waarde. Ze hebben diff vanmiddag al gebruikt om de</a:t>
+            </a:r>
+          </a:p>
+          <a:p>
+            <a:r>
+              <a:t>winst-kolom te maken; zeg dat er hardop bij.</a:t>
             </a:r>
           </a:p>
         </p:txBody>
@@ -2537,39 +2610,23 @@
           <a:lstStyle/>
           <a:p>
             <a:r>
-              <a:t>[Blok 1 - wat de samenvatting verbergt] Op het toernooi van deze week:</a:t>
-            </a:r>
-          </a:p>
-          <a:p>
-            <a:r>
-              <a:t>gemiddelde 0,0 - mediaan 0,0 - std 39 - laagste -1030 - hoogste +1750.</a:t>
+              <a:t>Deze dia is saai en bespaart je</a:t>
+            </a:r>
+          </a:p>
+          <a:p>
+            <a:r>
+              <a:t>in week 4 een half uur discussie. De aftrek gaat van BEIDE cijfers af, IDS en VA.</a:t>
             </a:r>
           </a:p>
           <a:p/>
           <a:p>
             <a:r>
-              <a:t>Het gemiddelde is exact nul en dat is geen toeval: poker is een nulsom, wat de</a:t>
-            </a:r>
-          </a:p>
-          <a:p>
-            <a:r>
-              <a:t>een wint verliest de ander. Dat is meteen je controle. Komt er geen nul uit je</a:t>
-            </a:r>
-          </a:p>
-          <a:p>
-            <a:r>
-              <a:t>eigen berekening, dan klopt je groepering niet.</a:t>
-            </a:r>
-          </a:p>
-          <a:p/>
-          <a:p>
-            <a:r>
-              <a:t>Mediaan nul betekent: in de meeste handen gebeurt er niets. En toch ging er in</a:t>
-            </a:r>
-          </a:p>
-          <a:p>
-            <a:r>
-              <a:t>een van die handen 1750 chips om. Vier getallen, en geen van de vier vertelt dat.</a:t>
+              <a:t>"Een schone clone draait zonder handmatige stappen" is de zwaarste: hun app moet het</a:t>
+            </a:r>
+          </a:p>
+          <a:p>
+            <a:r>
+              <a:t>doen op een computer die hun notebook nooit heeft gezien.</a:t>
             </a:r>
           </a:p>
         </p:txBody>
@@ -2639,33 +2696,22 @@
           <a:lstStyle/>
           <a:p>
             <a:r>
-              <a:t>[Blok 2 - de verdeling] Op hun data: 4838 van de 6750 handen vallen</a:t>
-            </a:r>
-          </a:p>
-          <a:p>
-            <a:r>
-              <a:t>tussen 0 en 20 chips. 1488 tussen -20 en -1. En dan de staarten: 53 handen tussen</a:t>
-            </a:r>
-          </a:p>
-          <a:p>
-            <a:r>
-              <a:t>-100 en -20, negen onder de -200, zeven boven de +200.</a:t>
-            </a:r>
-          </a:p>
-          <a:p/>
-          <a:p>
-            <a:r>
-              <a:t>Die ene piek rond nul zijn handen die zijn weggelegd zonder in de blinds te zitten.</a:t>
-            </a:r>
-          </a:p>
-          <a:p>
-            <a:r>
-              <a:t>Het echte spel zit in de zeven handen rechts. Vraag aan de zaal: welk van de vier</a:t>
-            </a:r>
-          </a:p>
-          <a:p>
-            <a:r>
-              <a:t>getallen van de vorige dia had je dat verteld? Geen enkel.</a:t>
+              <a:t>Dit is de dia die de curriculum-audit vroeg.</a:t>
+            </a:r>
+          </a:p>
+          <a:p>
+            <a:r>
+              <a:t>Studenten leggen de koppeling tussen werkcollege en rubric zelf niet. Een zin - dit</a:t>
+            </a:r>
+          </a:p>
+          <a:p>
+            <a:r>
+              <a:t>is het criterium waarop je case wordt beoordeeld - is het verschil tussen een</a:t>
+            </a:r>
+          </a:p>
+          <a:p>
+            <a:r>
+              <a:t>oefening en een reden.</a:t>
             </a:r>
           </a:p>
         </p:txBody>
@@ -2735,33 +2781,17 @@
           <a:lstStyle/>
           <a:p>
             <a:r>
-              <a:t>[Central tendency] Hier maakt de keuze het verschil tussen twee conclusies,</a:t>
-            </a:r>
-          </a:p>
-          <a:p>
-            <a:r>
-              <a:t>en dat kun je op hun data laten zien. Gemiddelde winst per hand: 0. Mediaan: 0.</a:t>
-            </a:r>
-          </a:p>
-          <a:p>
-            <a:r>
-              <a:t>Allebei nul, allebei waar, en samen verbergen ze een hand van +1750.</a:t>
-            </a:r>
-          </a:p>
-          <a:p/>
-          <a:p>
-            <a:r>
-              <a:t>Bij de bots ligt het andersom: de mediaan van de eindstand is 946, het gemiddelde</a:t>
-            </a:r>
-          </a:p>
-          <a:p>
-            <a:r>
-              <a:t>1000 (want nulsom). Dat verschil van 54 chips is de scheefheid - een paar bots</a:t>
-            </a:r>
-          </a:p>
-          <a:p>
-            <a:r>
-              <a:t>hebben veel, de meeste iets minder dan waarmee ze begonnen.</a:t>
+              <a:t>[EDA-recept] Dit recept is precies de volgorde van de demo straks:</a:t>
+            </a:r>
+          </a:p>
+          <a:p>
+            <a:r>
+              <a:t>describe -&gt; univariaat -&gt; bivariaat. Blok 1 is describe, blok 3 is bivariaat.</a:t>
+            </a:r>
+          </a:p>
+          <a:p>
+            <a:r>
+              <a:t>Zeg dat je het zo meteen op hun eigen toernooi doet, dan luisteren ze anders.</a:t>
             </a:r>
           </a:p>
         </p:txBody>
@@ -2831,39 +2861,39 @@
           <a:lstStyle/>
           <a:p>
             <a:r>
-              <a:t>[Filteren] De twee filters uit de demo:</a:t>
+              <a:t>[Blok 1 - wat de samenvatting verbergt] Op het toernooi van deze week:</a:t>
+            </a:r>
+          </a:p>
+          <a:p>
+            <a:r>
+              <a:t>gemiddelde 0,0 - mediaan 0,0 - std 39 - laagste -1030 - hoogste +1750.</a:t>
             </a:r>
           </a:p>
           <a:p/>
           <a:p>
             <a:r>
-              <a:t>  handen[handen["bot_naam"] == "500959250"]      -- rijen op inhoud</a:t>
-            </a:r>
-          </a:p>
-          <a:p>
-            <a:r>
-              <a:t>  handen.loc[handen["aan_zet"], "actie"]         -- boolean mask</a:t>
+              <a:t>Het gemiddelde is exact nul en dat is geen toeval: poker is een nulsom, wat de</a:t>
+            </a:r>
+          </a:p>
+          <a:p>
+            <a:r>
+              <a:t>een wint verliest de ander. Dat is meteen je controle. Komt er geen nul uit je</a:t>
+            </a:r>
+          </a:p>
+          <a:p>
+            <a:r>
+              <a:t>eigen berekening, dan klopt je groepering niet.</a:t>
             </a:r>
           </a:p>
           <a:p/>
           <a:p>
             <a:r>
-              <a:t>Die tweede is de belangrijkste regel van het college. aan_zet is een kolom vol</a:t>
-            </a:r>
-          </a:p>
-          <a:p>
-            <a:r>
-              <a:t>True/False; in .loc zetten houdt alleen de rijen waar hij True is. 928 van de 6750</a:t>
-            </a:r>
-          </a:p>
-          <a:p>
-            <a:r>
-              <a:t>logregels zijn handen waarin de bot nooit iets koos - hij zat in de blinds en de</a:t>
-            </a:r>
-          </a:p>
-          <a:p>
-            <a:r>
-              <a:t>hand was al voorbij.</a:t>
+              <a:t>Mediaan nul betekent: in de meeste handen gebeurt er niets. En toch ging er in</a:t>
+            </a:r>
+          </a:p>
+          <a:p>
+            <a:r>
+              <a:t>een van die handen 1750 chips om. Vier getallen, en geen van de vier vertelt dat.</a:t>
             </a:r>
           </a:p>
         </p:txBody>
@@ -2933,50 +2963,33 @@
           <a:lstStyle/>
           <a:p>
             <a:r>
-              <a:t>[Nieuwe variabelen] De winst-kolom is hier het voorbeeld, en hij komt</a:t>
-            </a:r>
-          </a:p>
-          <a:p>
-            <a:r>
-              <a:t>niet uit het log maar reken je zelf uit:</a:t>
+              <a:t>[Blok 2 - de verdeling] Op hun data: 4838 van de 6750 handen vallen</a:t>
+            </a:r>
+          </a:p>
+          <a:p>
+            <a:r>
+              <a:t>tussen 0 en 20 chips. 1488 tussen -20 en -1. En dan de staarten: 53 handen tussen</a:t>
+            </a:r>
+          </a:p>
+          <a:p>
+            <a:r>
+              <a:t>-100 en -20, negen onder de -200, zeven boven de +200.</a:t>
             </a:r>
           </a:p>
           <a:p/>
           <a:p>
             <a:r>
-              <a:t>  handen["winst"] = handen.groupby(["bot_naam","simulatie"])["stack"].diff()</a:t>
-            </a:r>
-          </a:p>
-          <a:p>
-            <a:r>
-              <a:t>                          .fillna(handen["stack"] - 1000)</a:t>
-            </a:r>
-          </a:p>
-          <a:p/>
-          <a:p>
-            <a:r>
-              <a:t>Het log bewaart de stack NA elke hand, dus winst is het verschil met de hand</a:t>
-            </a:r>
-          </a:p>
-          <a:p>
-            <a:r>
-              <a:t>ervoor. Twee dingen die misgaan: groeperen zonder simulatie (dan trek je de</a:t>
-            </a:r>
-          </a:p>
-          <a:p>
-            <a:r>
-              <a:t>eerste hand van zitting 1 af van de laatste van zitting 0), en de NaN van de</a:t>
-            </a:r>
-          </a:p>
-          <a:p>
-            <a:r>
-              <a:t>eerste hand laten staan.</a:t>
-            </a:r>
-          </a:p>
-          <a:p/>
-          <a:p>
-            <a:r>
-              <a:t>Controle: alle winst samen is precies 0.</a:t>
+              <a:t>Die ene piek rond nul zijn handen die zijn weggelegd zonder in de blinds te zitten.</a:t>
+            </a:r>
+          </a:p>
+          <a:p>
+            <a:r>
+              <a:t>Het echte spel zit in de zeven handen rechts. Vraag aan de zaal: welk van de vier</a:t>
+            </a:r>
+          </a:p>
+          <a:p>
+            <a:r>
+              <a:t>getallen van de vorige dia had je dat verteld? Geen enkel.</a:t>
             </a:r>
           </a:p>
         </p:txBody>
@@ -3200,46 +3213,33 @@
           <a:lstStyle/>
           <a:p>
             <a:r>
-              <a:t>[Groupby] Een-op-een met de vorige dia:</a:t>
+              <a:t>[Central tendency] Hier maakt de keuze het verschil tussen twee conclusies,</a:t>
+            </a:r>
+          </a:p>
+          <a:p>
+            <a:r>
+              <a:t>en dat kun je op hun data laten zien. Gemiddelde winst per hand: 0. Mediaan: 0.</a:t>
+            </a:r>
+          </a:p>
+          <a:p>
+            <a:r>
+              <a:t>Allebei nul, allebei waar, en samen verbergen ze een hand van +1750.</a:t>
             </a:r>
           </a:p>
           <a:p/>
           <a:p>
             <a:r>
-              <a:t>  gapminder.groupby('continent')['pop'].sum()</a:t>
-            </a:r>
-          </a:p>
-          <a:p>
-            <a:r>
-              <a:t>  handen.groupby('bot_naam')['winst'].sum()</a:t>
-            </a:r>
-          </a:p>
-          <a:p/>
-          <a:p>
-            <a:r>
-              <a:t>Letterlijk dezelfde regel. En dan de valkuil, die je moet laten zien:</a:t>
-            </a:r>
-          </a:p>
-          <a:p/>
-          <a:p>
-            <a:r>
-              <a:t>  handen.groupby('bot_naam')['stack'].sum()   -&gt;  258.550 chips</a:t>
-            </a:r>
-          </a:p>
-          <a:p/>
-          <a:p>
-            <a:r>
-              <a:t>Geen foutmelding, keurig getal, volslagen onzin. Een stack is een STAND, geen</a:t>
-            </a:r>
-          </a:p>
-          <a:p>
-            <a:r>
-              <a:t>stroom. Dat over 250 handen optellen is hetzelfde als de bevolking van Europa</a:t>
-            </a:r>
-          </a:p>
-          <a:p>
-            <a:r>
-              <a:t>over alle twaalf gapminder-jaren optellen. Voor een stand wil je .last().</a:t>
+              <a:t>Bij de bots ligt het andersom: de mediaan van de eindstand is 946, het gemiddelde</a:t>
+            </a:r>
+          </a:p>
+          <a:p>
+            <a:r>
+              <a:t>1000 (want nulsom). Dat verschil van 54 chips is de scheefheid - een paar bots</a:t>
+            </a:r>
+          </a:p>
+          <a:p>
+            <a:r>
+              <a:t>hebben veel, de meeste iets minder dan waarmee ze begonnen.</a:t>
             </a:r>
           </a:p>
         </p:txBody>
@@ -3309,6 +3309,330 @@
           <a:lstStyle/>
           <a:p>
             <a:r>
+              <a:t>[Filteren] De twee filters uit de demo:</a:t>
+            </a:r>
+          </a:p>
+          <a:p/>
+          <a:p>
+            <a:r>
+              <a:t>  handen[handen["bot_naam"] == "500959250"]      -- rijen op inhoud</a:t>
+            </a:r>
+          </a:p>
+          <a:p>
+            <a:r>
+              <a:t>  handen.loc[handen["aan_zet"], "actie"]         -- boolean mask</a:t>
+            </a:r>
+          </a:p>
+          <a:p/>
+          <a:p>
+            <a:r>
+              <a:t>Die tweede is de belangrijkste regel van het college. aan_zet is een kolom vol</a:t>
+            </a:r>
+          </a:p>
+          <a:p>
+            <a:r>
+              <a:t>True/False; in .loc zetten houdt alleen de rijen waar hij True is. 928 van de 6750</a:t>
+            </a:r>
+          </a:p>
+          <a:p>
+            <a:r>
+              <a:t>logregels zijn handen waarin de bot nooit iets koos - hij zat in de blinds en de</a:t>
+            </a:r>
+          </a:p>
+          <a:p>
+            <a:r>
+              <a:t>hand was al voorbij.</a:t>
+            </a:r>
+          </a:p>
+        </p:txBody>
+      </p:sp>
+      <p:sp>
+        <p:nvSpPr>
+          <p:cNvPr id="4" name="Slide Number Placeholder 3"/>
+          <p:cNvSpPr>
+            <a:spLocks noGrp="1"/>
+          </p:cNvSpPr>
+          <p:nvPr>
+            <p:ph type="sldNum"/>
+          </p:nvPr>
+        </p:nvSpPr>
+        <p:spPr/>
+      </p:sp>
+    </p:spTree>
+  </p:cSld>
+  <p:clrMapOvr>
+    <a:masterClrMapping/>
+  </p:clrMapOvr>
+</p:notes>
+</file>
+
+<file path=ppt/notesSlides/notesSlide22.xml><?xml version="1.0" encoding="utf-8"?>
+<p:notes xmlns:a="http://schemas.openxmlformats.org/drawingml/2006/main" xmlns:p="http://schemas.openxmlformats.org/presentationml/2006/main" xmlns:r="http://schemas.openxmlformats.org/officeDocument/2006/relationships">
+  <p:cSld>
+    <p:spTree>
+      <p:nvGrpSpPr>
+        <p:cNvPr id="1" name=""/>
+        <p:cNvGrpSpPr/>
+        <p:nvPr/>
+      </p:nvGrpSpPr>
+      <p:grpSpPr>
+        <a:xfrm>
+          <a:off x="0" y="0"/>
+          <a:ext cx="0" cy="0"/>
+          <a:chOff x="0" y="0"/>
+          <a:chExt cx="0" cy="0"/>
+        </a:xfrm>
+      </p:grpSpPr>
+      <p:sp>
+        <p:nvSpPr>
+          <p:cNvPr id="2" name="Slide Image Placeholder 1"/>
+          <p:cNvSpPr>
+            <a:spLocks noGrp="1"/>
+          </p:cNvSpPr>
+          <p:nvPr>
+            <p:ph type="sldImg"/>
+          </p:nvPr>
+        </p:nvSpPr>
+        <p:spPr/>
+      </p:sp>
+      <p:sp>
+        <p:nvSpPr>
+          <p:cNvPr id="3" name="Notes Placeholder 2"/>
+          <p:cNvSpPr>
+            <a:spLocks noGrp="1"/>
+          </p:cNvSpPr>
+          <p:nvPr>
+            <p:ph type="body"/>
+          </p:nvPr>
+        </p:nvSpPr>
+        <p:spPr/>
+        <p:txBody>
+          <a:bodyPr/>
+          <a:lstStyle/>
+          <a:p>
+            <a:r>
+              <a:t>[Nieuwe variabelen] De winst-kolom is hier het voorbeeld, en hij komt</a:t>
+            </a:r>
+          </a:p>
+          <a:p>
+            <a:r>
+              <a:t>niet uit het log maar reken je zelf uit:</a:t>
+            </a:r>
+          </a:p>
+          <a:p/>
+          <a:p>
+            <a:r>
+              <a:t>  handen["winst"] = handen.groupby(["bot_naam","simulatie"])["stack"].diff()</a:t>
+            </a:r>
+          </a:p>
+          <a:p>
+            <a:r>
+              <a:t>                          .fillna(handen["stack"] - 1000)</a:t>
+            </a:r>
+          </a:p>
+          <a:p/>
+          <a:p>
+            <a:r>
+              <a:t>Het log bewaart de stack NA elke hand, dus winst is het verschil met de hand</a:t>
+            </a:r>
+          </a:p>
+          <a:p>
+            <a:r>
+              <a:t>ervoor. Twee dingen die misgaan: groeperen zonder simulatie (dan trek je de</a:t>
+            </a:r>
+          </a:p>
+          <a:p>
+            <a:r>
+              <a:t>eerste hand van zitting 1 af van de laatste van zitting 0), en de NaN van de</a:t>
+            </a:r>
+          </a:p>
+          <a:p>
+            <a:r>
+              <a:t>eerste hand laten staan.</a:t>
+            </a:r>
+          </a:p>
+          <a:p/>
+          <a:p>
+            <a:r>
+              <a:t>Controle: alle winst samen is precies 0.</a:t>
+            </a:r>
+          </a:p>
+        </p:txBody>
+      </p:sp>
+      <p:sp>
+        <p:nvSpPr>
+          <p:cNvPr id="4" name="Slide Number Placeholder 3"/>
+          <p:cNvSpPr>
+            <a:spLocks noGrp="1"/>
+          </p:cNvSpPr>
+          <p:nvPr>
+            <p:ph type="sldNum"/>
+          </p:nvPr>
+        </p:nvSpPr>
+        <p:spPr/>
+      </p:sp>
+    </p:spTree>
+  </p:cSld>
+  <p:clrMapOvr>
+    <a:masterClrMapping/>
+  </p:clrMapOvr>
+</p:notes>
+</file>
+
+<file path=ppt/notesSlides/notesSlide23.xml><?xml version="1.0" encoding="utf-8"?>
+<p:notes xmlns:a="http://schemas.openxmlformats.org/drawingml/2006/main" xmlns:p="http://schemas.openxmlformats.org/presentationml/2006/main" xmlns:r="http://schemas.openxmlformats.org/officeDocument/2006/relationships">
+  <p:cSld>
+    <p:spTree>
+      <p:nvGrpSpPr>
+        <p:cNvPr id="1" name=""/>
+        <p:cNvGrpSpPr/>
+        <p:nvPr/>
+      </p:nvGrpSpPr>
+      <p:grpSpPr>
+        <a:xfrm>
+          <a:off x="0" y="0"/>
+          <a:ext cx="0" cy="0"/>
+          <a:chOff x="0" y="0"/>
+          <a:chExt cx="0" cy="0"/>
+        </a:xfrm>
+      </p:grpSpPr>
+      <p:sp>
+        <p:nvSpPr>
+          <p:cNvPr id="2" name="Slide Image Placeholder 1"/>
+          <p:cNvSpPr>
+            <a:spLocks noGrp="1"/>
+          </p:cNvSpPr>
+          <p:nvPr>
+            <p:ph type="sldImg"/>
+          </p:nvPr>
+        </p:nvSpPr>
+        <p:spPr/>
+      </p:sp>
+      <p:sp>
+        <p:nvSpPr>
+          <p:cNvPr id="3" name="Notes Placeholder 2"/>
+          <p:cNvSpPr>
+            <a:spLocks noGrp="1"/>
+          </p:cNvSpPr>
+          <p:nvPr>
+            <p:ph type="body"/>
+          </p:nvPr>
+        </p:nvSpPr>
+        <p:spPr/>
+        <p:txBody>
+          <a:bodyPr/>
+          <a:lstStyle/>
+          <a:p>
+            <a:r>
+              <a:t>[Groupby] Een-op-een met de vorige dia:</a:t>
+            </a:r>
+          </a:p>
+          <a:p/>
+          <a:p>
+            <a:r>
+              <a:t>  gapminder.groupby('continent')['pop'].sum()</a:t>
+            </a:r>
+          </a:p>
+          <a:p>
+            <a:r>
+              <a:t>  handen.groupby('bot_naam')['winst'].sum()</a:t>
+            </a:r>
+          </a:p>
+          <a:p/>
+          <a:p>
+            <a:r>
+              <a:t>Letterlijk dezelfde regel. En dan de valkuil, die je moet laten zien:</a:t>
+            </a:r>
+          </a:p>
+          <a:p/>
+          <a:p>
+            <a:r>
+              <a:t>  handen.groupby('bot_naam')['stack'].sum()   -&gt;  258.550 chips</a:t>
+            </a:r>
+          </a:p>
+          <a:p/>
+          <a:p>
+            <a:r>
+              <a:t>Geen foutmelding, keurig getal, volslagen onzin. Een stack is een STAND, geen</a:t>
+            </a:r>
+          </a:p>
+          <a:p>
+            <a:r>
+              <a:t>stroom. Dat over 250 handen optellen is hetzelfde als de bevolking van Europa</a:t>
+            </a:r>
+          </a:p>
+          <a:p>
+            <a:r>
+              <a:t>over alle twaalf gapminder-jaren optellen. Voor een stand wil je .last().</a:t>
+            </a:r>
+          </a:p>
+        </p:txBody>
+      </p:sp>
+      <p:sp>
+        <p:nvSpPr>
+          <p:cNvPr id="4" name="Slide Number Placeholder 3"/>
+          <p:cNvSpPr>
+            <a:spLocks noGrp="1"/>
+          </p:cNvSpPr>
+          <p:nvPr>
+            <p:ph type="sldNum"/>
+          </p:nvPr>
+        </p:nvSpPr>
+        <p:spPr/>
+      </p:sp>
+    </p:spTree>
+  </p:cSld>
+  <p:clrMapOvr>
+    <a:masterClrMapping/>
+  </p:clrMapOvr>
+</p:notes>
+</file>
+
+<file path=ppt/notesSlides/notesSlide24.xml><?xml version="1.0" encoding="utf-8"?>
+<p:notes xmlns:a="http://schemas.openxmlformats.org/drawingml/2006/main" xmlns:p="http://schemas.openxmlformats.org/presentationml/2006/main" xmlns:r="http://schemas.openxmlformats.org/officeDocument/2006/relationships">
+  <p:cSld>
+    <p:spTree>
+      <p:nvGrpSpPr>
+        <p:cNvPr id="1" name=""/>
+        <p:cNvGrpSpPr/>
+        <p:nvPr/>
+      </p:nvGrpSpPr>
+      <p:grpSpPr>
+        <a:xfrm>
+          <a:off x="0" y="0"/>
+          <a:ext cx="0" cy="0"/>
+          <a:chOff x="0" y="0"/>
+          <a:chExt cx="0" cy="0"/>
+        </a:xfrm>
+      </p:grpSpPr>
+      <p:sp>
+        <p:nvSpPr>
+          <p:cNvPr id="2" name="Slide Image Placeholder 1"/>
+          <p:cNvSpPr>
+            <a:spLocks noGrp="1"/>
+          </p:cNvSpPr>
+          <p:nvPr>
+            <p:ph type="sldImg"/>
+          </p:nvPr>
+        </p:nvSpPr>
+        <p:spPr/>
+      </p:sp>
+      <p:sp>
+        <p:nvSpPr>
+          <p:cNvPr id="3" name="Notes Placeholder 2"/>
+          <p:cNvSpPr>
+            <a:spLocks noGrp="1"/>
+          </p:cNvSpPr>
+          <p:nvPr>
+            <p:ph type="body"/>
+          </p:nvPr>
+        </p:nvSpPr>
+        <p:spPr/>
+        <p:txBody>
+          <a:bodyPr/>
+          <a:lstStyle/>
+          <a:p>
+            <a:r>
               <a:t>[Opdracht] De opdracht is dit jaar niet gapminder maar hun eigen</a:t>
             </a:r>
           </a:p>
@@ -3882,39 +4206,39 @@
           <a:lstStyle/>
           <a:p>
             <a:r>
-              <a:t>[Blok 3 - het gesprek van vandaag] Laat ze de</a:t>
-            </a:r>
-          </a:p>
-          <a:p>
-            <a:r>
-              <a:t>tabel zelf lezen voordat je iets zegt.</a:t>
+              <a:t>[Blok 1] Vier getallen op tafel en dan stil zijn.</a:t>
             </a:r>
           </a:p>
           <a:p/>
           <a:p>
             <a:r>
-              <a:t>De vraag is niet "waarom foldt de klas zoveel" maar "waarom levert elke andere actie</a:t>
-            </a:r>
-          </a:p>
-          <a:p>
-            <a:r>
-              <a:t>gemiddeld geld op, en doet niemand het". Antwoord: aan een tafel van folders wint de</a:t>
-            </a:r>
-          </a:p>
-          <a:p>
-            <a:r>
-              <a:t>big blind de small blind. Folden kost je bijna niets - en levert je ook niets op.</a:t>
+              <a:t>Het gemiddelde is exact nul en dat is geen toeval: poker is een nulsom, wat de een</a:t>
+            </a:r>
+          </a:p>
+          <a:p>
+            <a:r>
+              <a:t>wint verliest de ander. Daarmee is het meteen je controle -- komt er geen nul uit je</a:t>
+            </a:r>
+          </a:p>
+          <a:p>
+            <a:r>
+              <a:t>eigen berekening, dan klopt je groepering niet en is alles daarna onzin.</a:t>
             </a:r>
           </a:p>
           <a:p/>
           <a:p>
             <a:r>
-              <a:t>Let op bij het navolgen: filter op aan_zet, anders tel je handen mee waarin de bot</a:t>
-            </a:r>
-          </a:p>
-          <a:p>
-            <a:r>
-              <a:t>nooit iets koos en komt elk percentage te laag uit.</a:t>
+              <a:t>Mediaan nul betekent: in de meeste handen gebeurt er niets. En toch ging er in een</a:t>
+            </a:r>
+          </a:p>
+          <a:p>
+            <a:r>
+              <a:t>van die handen meer dan duizend chips om. Vraag het aan de zaal voordat je het zegt:</a:t>
+            </a:r>
+          </a:p>
+          <a:p>
+            <a:r>
+              <a:t>welk van deze vier getallen had je dat verteld?</a:t>
             </a:r>
           </a:p>
         </p:txBody>
@@ -3984,55 +4308,33 @@
           <a:lstStyle/>
           <a:p>
             <a:r>
-              <a:t>[Blok 4 - hier eindig je] Laat de uitslag</a:t>
-            </a:r>
-          </a:p>
-          <a:p>
-            <a:r>
-              <a:t>even staan voordat je hem uitlegt.</a:t>
+              <a:t>[Blok 2] De bakjes zijn met opzet ongelijk.</a:t>
+            </a:r>
+          </a:p>
+          <a:p>
+            <a:r>
+              <a:t>Rond nul zit bijna alles, dus daar wil je fijn verdelen; de staarten zijn zo dun dat</a:t>
+            </a:r>
+          </a:p>
+          <a:p>
+            <a:r>
+              <a:t>ze alleen als één bakje zichtbaar blijven.</a:t>
             </a:r>
           </a:p>
           <a:p/>
           <a:p>
             <a:r>
-              <a:t>Tien chips verschil, over 6750 beslissingen. Dat is geen klinkende overwinning en dat</a:t>
-            </a:r>
-          </a:p>
-          <a:p>
-            <a:r>
-              <a:t>is precies goed: het gaat niet om "de domme bot wint", het gaat om "jullie drempels</a:t>
-            </a:r>
-          </a:p>
-          <a:p>
-            <a:r>
-              <a:t>staan zo hoog dat niet meedoen bijna net zo goed werkt als meedoen".</a:t>
-            </a:r>
-          </a:p>
-          <a:p/>
-          <a:p>
-            <a:r>
-              <a:t>Correlatie fold% met eindstand: -0,69. Niet doorslaan - vier bots dragen dat getal en</a:t>
-            </a:r>
-          </a:p>
-          <a:p>
-            <a:r>
-              <a:t>27 punten is weinig. Dat onderscheid, zie ik een verband tegenover heb ik iets</a:t>
-            </a:r>
-          </a:p>
-          <a:p>
-            <a:r>
-              <a:t>aangetoond, is precies wat het criterium Analyse van Case 2 beoordeelt.</a:t>
-            </a:r>
-          </a:p>
-          <a:p/>
-          <a:p>
-            <a:r>
-              <a:t>De vraag voor donderdag is niet "moet ik minder folden" maar "waar liggen mijn</a:t>
-            </a:r>
-          </a:p>
-          <a:p>
-            <a:r>
-              <a:t>drempels, en waarom daar".</a:t>
+              <a:t>Die piek rond nul zijn handen die zijn weggelegd zonder in de blinds te zitten: je</a:t>
+            </a:r>
+          </a:p>
+          <a:p>
+            <a:r>
+              <a:t>verliest niets en je wint niets. Het spel gebeurt in de handen aan de randen, en dat</a:t>
+            </a:r>
+          </a:p>
+          <a:p>
+            <a:r>
+              <a:t>zijn er een paar van de duizenden.</a:t>
             </a:r>
           </a:p>
         </p:txBody>
@@ -13939,7 +14241,7 @@
               </a:defRPr>
             </a:pPr>
             <a:r>
-              <a:t>handsterkte · winkans · pot odds — en die laatste twee naast elkaar is een beslisregel</a:t>
+              <a:t>handsterkte · winkans · pot odds — die laatste twee naast elkaar is een beslisregel</a:t>
             </a:r>
           </a:p>
           <a:p>
@@ -13968,7 +14270,7 @@
               </a:defRPr>
             </a:pPr>
             <a:r>
-              <a:t>live testen tegen een klasgenoot · v2 naast v1 · de spelregels terugvinden in je eigen log</a:t>
+              <a:t>live testen tegen een klasgenoot · v2 naast v1 · de spelregels in je eigen log</a:t>
             </a:r>
           </a:p>
           <a:p>
@@ -14782,7 +15084,7 @@
               </a:defRPr>
             </a:pPr>
             <a:r>
-              <a:t>Wat het log over de klas zegt</a:t>
+              <a:t>Wat de samenvatting verbergt</a:t>
             </a:r>
           </a:p>
         </p:txBody>
@@ -14812,13 +15114,13 @@
             <a:pPr>
               <a:defRPr sz="1700" b="1">
                 <a:solidFill>
-                  <a:srgbClr val="000000"/>
+                  <a:srgbClr val="1B4D3E"/>
                 </a:solidFill>
                 <a:latin typeface="Arial"/>
               </a:defRPr>
             </a:pPr>
             <a:r>
-              <a:t>6750 beslissingen: 27 bots, 50 handen, 5 zittingen.</a:t>
+              <a:t>df["winst"].describe()</a:t>
             </a:r>
           </a:p>
           <a:p>
@@ -14831,46 +15133,46 @@
               </a:defRPr>
             </a:pPr>
             <a:r>
-              <a:t>fold · 92,2% van alle beslissingen · gemiddeld -3 chips</a:t>
+              <a:t>gemiddelde 0,0 · nulsom: wat de een wint, verliest de ander</a:t>
             </a:r>
           </a:p>
           <a:p>
             <a:pPr lvl="1">
               <a:defRPr sz="1400" b="0">
                 <a:solidFill>
-                  <a:srgbClr val="1B4D3E"/>
+                  <a:srgbClr val="000000"/>
                 </a:solidFill>
                 <a:latin typeface="Arial"/>
               </a:defRPr>
             </a:pPr>
             <a:r>
-              <a:t>call · 5,9% · gemiddeld +10 chips</a:t>
+              <a:t>mediaan 0,0 · in de meeste handen gebeurt er niets</a:t>
             </a:r>
           </a:p>
           <a:p>
             <a:pPr lvl="1">
               <a:defRPr sz="1400" b="0">
                 <a:solidFill>
-                  <a:srgbClr val="1B4D3E"/>
+                  <a:srgbClr val="000000"/>
                 </a:solidFill>
                 <a:latin typeface="Arial"/>
               </a:defRPr>
             </a:pPr>
             <a:r>
-              <a:t>raise · 1,3% · gemiddeld +65 chips</a:t>
+              <a:t>standaarddeviatie 39</a:t>
             </a:r>
           </a:p>
           <a:p>
             <a:pPr lvl="1">
               <a:defRPr sz="1400" b="0">
                 <a:solidFill>
-                  <a:srgbClr val="1B4D3E"/>
+                  <a:srgbClr val="000000"/>
                 </a:solidFill>
                 <a:latin typeface="Arial"/>
               </a:defRPr>
             </a:pPr>
             <a:r>
-              <a:t>grote_raise · 0,6% · gemiddeld +19 chips</a:t>
+              <a:t>laagste -1030 · hoogste +1750 — iemand verloor zijn hele stack in één hand</a:t>
             </a:r>
           </a:p>
           <a:p>
@@ -14886,15 +15188,12 @@
               </a:defRPr>
             </a:pPr>
             <a:r>
-              <a:t>Elke actie behalve fold levert gemiddeld geld op.</a:t>
-            </a:r>
-          </a:p>
-          <a:p>
-            <a:pPr>
-              <a:spcBef>
-                <a:spcPts val="1300"/>
-              </a:spcBef>
-              <a:defRPr sz="1700" b="1">
+              <a:t>Gemiddelde nul, mediaan nul. Maar in één hand ging er 1750 om.</a:t>
+            </a:r>
+          </a:p>
+          <a:p>
+            <a:pPr lvl="1">
+              <a:defRPr sz="1400" b="0">
                 <a:solidFill>
                   <a:srgbClr val="000000"/>
                 </a:solidFill>
@@ -14902,33 +15201,7 @@
               </a:defRPr>
             </a:pPr>
             <a:r>
-              <a:t>En toch is de mediaan van alle handen 0.</a:t>
-            </a:r>
-          </a:p>
-          <a:p>
-            <a:pPr lvl="1">
-              <a:defRPr sz="1400" b="0">
-                <a:solidFill>
-                  <a:srgbClr val="000000"/>
-                </a:solidFill>
-                <a:latin typeface="Arial"/>
-              </a:defRPr>
-            </a:pPr>
-            <a:r>
-              <a:t>4838 van de 6750 handen leveren tussen 0 en 20 chips op — dat is de blind, niet het spel</a:t>
-            </a:r>
-          </a:p>
-          <a:p>
-            <a:pPr lvl="1">
-              <a:defRPr sz="1400" b="0">
-                <a:solidFill>
-                  <a:srgbClr val="505A64"/>
-                </a:solidFill>
-                <a:latin typeface="Arial"/>
-              </a:defRPr>
-            </a:pPr>
-            <a:r>
-              <a:t>Zeven handen maken de hele staart. Die zie je in geen enkel samenvattend getal terug.</a:t>
+              <a:t>Wat zeggen die drie getallen dan eigenlijk?</a:t>
             </a:r>
           </a:p>
         </p:txBody>
@@ -15018,7 +15291,7 @@
               </a:defRPr>
             </a:pPr>
             <a:r>
-              <a:t>De bot die niet nadenkt werd eerste</a:t>
+              <a:t>En dat zie je in het histogram</a:t>
             </a:r>
           </a:p>
         </p:txBody>
@@ -15048,26 +15321,26 @@
             <a:pPr>
               <a:defRPr sz="1700" b="1">
                 <a:solidFill>
-                  <a:srgbClr val="000000"/>
+                  <a:srgbClr val="1B4D3E"/>
                 </a:solidFill>
                 <a:latin typeface="Arial"/>
               </a:defRPr>
             </a:pPr>
             <a:r>
-              <a:t>Toernooi week 3, 27 bots. De uitslag bovenaan:</a:t>
+              <a:t>df["winst"].hist(bins=40)</a:t>
             </a:r>
           </a:p>
           <a:p>
             <a:pPr lvl="1">
               <a:defRPr sz="1400" b="0">
                 <a:solidFill>
-                  <a:srgbClr val="1B4D3E"/>
+                  <a:srgbClr val="000000"/>
                 </a:solidFill>
                 <a:latin typeface="Arial"/>
               </a:defRPr>
             </a:pPr>
             <a:r>
-              <a:t>1.  Testbot_CalltAlles — 1748 chips, foldt 0,0%</a:t>
+              <a:t>-200 en lager · 9 handen</a:t>
             </a:r>
           </a:p>
           <a:p>
@@ -15080,7 +15353,7 @@
               </a:defRPr>
             </a:pPr>
             <a:r>
-              <a:t>2.  een van jullie — 1738 chips, foldt 82,5%</a:t>
+              <a:t>-100 tot -20 · 53 handen</a:t>
             </a:r>
           </a:p>
           <a:p>
@@ -15093,7 +15366,46 @@
               </a:defRPr>
             </a:pPr>
             <a:r>
-              <a:t>3.  een van jullie — 1256 chips, foldt 58,7%</a:t>
+              <a:t>-20 tot -1 · 1488 handen</a:t>
+            </a:r>
+          </a:p>
+          <a:p>
+            <a:pPr lvl="1">
+              <a:defRPr sz="1400" b="0">
+                <a:solidFill>
+                  <a:srgbClr val="000000"/>
+                </a:solidFill>
+                <a:latin typeface="Arial"/>
+              </a:defRPr>
+            </a:pPr>
+            <a:r>
+              <a:t>0 tot 20 · 4838 handen</a:t>
+            </a:r>
+          </a:p>
+          <a:p>
+            <a:pPr lvl="1">
+              <a:defRPr sz="1400" b="0">
+                <a:solidFill>
+                  <a:srgbClr val="000000"/>
+                </a:solidFill>
+                <a:latin typeface="Arial"/>
+              </a:defRPr>
+            </a:pPr>
+            <a:r>
+              <a:t>20 tot 50 · 310 handen</a:t>
+            </a:r>
+          </a:p>
+          <a:p>
+            <a:pPr lvl="1">
+              <a:defRPr sz="1400" b="0">
+                <a:solidFill>
+                  <a:srgbClr val="000000"/>
+                </a:solidFill>
+                <a:latin typeface="Arial"/>
+              </a:defRPr>
+            </a:pPr>
+            <a:r>
+              <a:t>200 en hoger · 7 handen</a:t>
             </a:r>
           </a:p>
           <a:p>
@@ -15109,7 +15421,7 @@
               </a:defRPr>
             </a:pPr>
             <a:r>
-              <a:t>Die eerste is één regel: geef altijd "call" terug, wat je ook hebt.</a:t>
+              <a:t>Bijna alles zit in één bakje rond nul: weggelegd zonder in de blinds te zitten.</a:t>
             </a:r>
           </a:p>
           <a:p>
@@ -15122,49 +15434,20 @@
               </a:defRPr>
             </a:pPr>
             <a:r>
-              <a:t>Geen winkans, geen pot odds, kijkt niet eens naar zijn kaarten</a:t>
+              <a:t>7 handen van de 6750 bepalen het hele beeld —</a:t>
             </a:r>
           </a:p>
           <a:p>
             <a:pPr lvl="1">
               <a:defRPr sz="1400" b="0">
                 <a:solidFill>
-                  <a:srgbClr val="000000"/>
+                  <a:srgbClr val="505A64"/>
                 </a:solidFill>
                 <a:latin typeface="Arial"/>
               </a:defRPr>
             </a:pPr>
             <a:r>
-              <a:t>De klas foldde 92,2% van alle beslissingen; negen bots foldden 99% of meer</a:t>
-            </a:r>
-          </a:p>
-          <a:p>
-            <a:pPr lvl="1">
-              <a:defRPr sz="1400" b="0">
-                <a:solidFill>
-                  <a:srgbClr val="505A64"/>
-                </a:solidFill>
-                <a:latin typeface="Arial"/>
-              </a:defRPr>
-            </a:pPr>
-            <a:r>
-              <a:t>Correlatie tussen fold% en eindstand: -0,69 — meer folden is minder eindigen</a:t>
-            </a:r>
-          </a:p>
-          <a:p>
-            <a:pPr>
-              <a:spcBef>
-                <a:spcPts val="1300"/>
-              </a:spcBef>
-              <a:defRPr sz="1700" b="1">
-                <a:solidFill>
-                  <a:srgbClr val="25167A"/>
-                </a:solidFill>
-                <a:latin typeface="Arial"/>
-              </a:defRPr>
-            </a:pPr>
-            <a:r>
-              <a:t>Waarom verliest een bot mét regels van een bot zonder regels?</a:t>
+              <a:t>en die zie je in geen enkel samenvattend getal terug</a:t>
             </a:r>
           </a:p>
         </p:txBody>
@@ -15254,7 +15537,7 @@
               </a:defRPr>
             </a:pPr>
             <a:r>
-              <a:t>Groepscase 2 — wat je oplevert</a:t>
+              <a:t>Hetzelfde, getekend</a:t>
             </a:r>
           </a:p>
         </p:txBody>
@@ -15280,134 +15563,36 @@
             <a:spAutoFit/>
           </a:bodyPr>
           <a:lstStyle/>
-          <a:p>
-            <a:pPr>
-              <a:defRPr sz="1700" b="1">
-                <a:solidFill>
-                  <a:srgbClr val="000000"/>
-                </a:solidFill>
-                <a:latin typeface="Arial"/>
-              </a:defRPr>
-            </a:pPr>
-            <a:r>
-              <a:t>Een Streamlit-dashboard over een onderwerp dat je zelf kiest.</a:t>
-            </a:r>
-          </a:p>
-          <a:p>
-            <a:pPr lvl="1">
-              <a:defRPr sz="1400" b="0">
-                <a:solidFill>
-                  <a:srgbClr val="000000"/>
-                </a:solidFill>
-                <a:latin typeface="Arial"/>
-              </a:defRPr>
-            </a:pPr>
-            <a:r>
-              <a:t>Gepubliceerd via GitHub op share.streamlit.io, te openen met een link</a:t>
-            </a:r>
-          </a:p>
-          <a:p>
-            <a:pPr lvl="1">
-              <a:defRPr sz="1400" b="0">
-                <a:solidFill>
-                  <a:srgbClr val="000000"/>
-                </a:solidFill>
-                <a:latin typeface="Arial"/>
-              </a:defRPr>
-            </a:pPr>
-            <a:r>
-              <a:t>De app haalt de data zelf op bij een openbare API — niet met de hand gedownload</a:t>
-            </a:r>
-          </a:p>
-          <a:p>
-            <a:pPr lvl="1">
-              <a:defRPr sz="1400" b="0">
-                <a:solidFill>
-                  <a:srgbClr val="1B4D3E"/>
-                </a:solidFill>
-                <a:latin typeface="Arial"/>
-              </a:defRPr>
-            </a:pPr>
-            <a:r>
-              <a:t>Minimaal één join: twee bronnen die je tot één tabel samenvoegt</a:t>
-            </a:r>
-          </a:p>
-          <a:p>
-            <a:pPr>
-              <a:spcBef>
-                <a:spcPts val="1300"/>
-              </a:spcBef>
-              <a:defRPr sz="1700" b="1">
-                <a:solidFill>
-                  <a:srgbClr val="000000"/>
-                </a:solidFill>
-                <a:latin typeface="Arial"/>
-              </a:defRPr>
-            </a:pPr>
-            <a:r>
-              <a:t>Loopt over week 3 en week 4. Dat is kort.</a:t>
-            </a:r>
-          </a:p>
-          <a:p>
-            <a:pPr lvl="1">
-              <a:defRPr sz="1400" b="0">
-                <a:solidFill>
-                  <a:srgbClr val="000000"/>
-                </a:solidFill>
-                <a:latin typeface="Arial"/>
-              </a:defRPr>
-            </a:pPr>
-            <a:r>
-              <a:t>Donderdag 18:00 staat je onderwerp vast: welke vraag, welke twee bronnen,</a:t>
-            </a:r>
-          </a:p>
-          <a:p>
-            <a:pPr lvl="1">
-              <a:defRPr sz="1400" b="0">
-                <a:solidFill>
-                  <a:srgbClr val="000000"/>
-                </a:solidFill>
-                <a:latin typeface="Arial"/>
-              </a:defRPr>
-            </a:pPr>
-            <a:r>
-              <a:t>op welke kolom die aan elkaar passen, en wie in de groep wat doet</a:t>
-            </a:r>
-          </a:p>
-          <a:p>
-            <a:pPr>
-              <a:spcBef>
-                <a:spcPts val="1300"/>
-              </a:spcBef>
-              <a:defRPr sz="1700" b="1">
-                <a:solidFill>
-                  <a:srgbClr val="25167A"/>
-                </a:solidFill>
-                <a:latin typeface="Arial"/>
-              </a:defRPr>
-            </a:pPr>
-            <a:r>
-              <a:t>Zoek nu al op of die twee bronnen écht een gemeenschappelijke kolom hebben.</a:t>
-            </a:r>
-          </a:p>
-          <a:p>
-            <a:pPr lvl="1">
-              <a:defRPr sz="1400" b="0">
-                <a:solidFill>
-                  <a:srgbClr val="505A64"/>
-                </a:solidFill>
-                <a:latin typeface="Arial"/>
-              </a:defRPr>
-            </a:pPr>
-            <a:r>
-              <a:t>"Den Haag" en "'s-Gravenhage" passen niet op elkaar zonder werk</a:t>
-            </a:r>
-          </a:p>
-        </p:txBody>
-      </p:sp>
-      <p:sp>
-        <p:nvSpPr>
-          <p:cNvPr id="4" name="TextBox 3"/>
+          <a:p/>
+        </p:txBody>
+      </p:sp>
+      <p:pic>
+        <p:nvPicPr>
+          <p:cNvPr id="4" name="Picture 3" descr="winst_histogram.png"/>
+          <p:cNvPicPr>
+            <a:picLocks noChangeAspect="1"/>
+          </p:cNvPicPr>
+          <p:nvPr/>
+        </p:nvPicPr>
+        <p:blipFill>
+          <a:blip r:embed="rId2"/>
+          <a:stretch>
+            <a:fillRect/>
+          </a:stretch>
+        </p:blipFill>
+        <p:spPr>
+          <a:xfrm>
+            <a:off x="2441448" y="1920240"/>
+            <a:ext cx="7863840" cy="3677489"/>
+          </a:xfrm>
+          <a:prstGeom prst="rect">
+            <a:avLst/>
+          </a:prstGeom>
+        </p:spPr>
+      </p:pic>
+      <p:sp>
+        <p:nvSpPr>
+          <p:cNvPr id="5" name="TextBox 4"/>
           <p:cNvSpPr txBox="1"/>
           <p:nvPr/>
         </p:nvSpPr>
@@ -15490,7 +15675,7 @@
               </a:defRPr>
             </a:pPr>
             <a:r>
-              <a:t>Waar je cijfer vandaan komt</a:t>
+              <a:t>Categorisch, dan bivariaat</a:t>
             </a:r>
           </a:p>
         </p:txBody>
@@ -15520,52 +15705,13 @@
             <a:pPr>
               <a:defRPr sz="1700" b="1">
                 <a:solidFill>
-                  <a:srgbClr val="25167A"/>
+                  <a:srgbClr val="1B4D3E"/>
                 </a:solidFill>
                 <a:latin typeface="Arial"/>
               </a:defRPr>
             </a:pPr>
             <a:r>
-              <a:t>Drie criteria voor IDS — de data-kant</a:t>
-            </a:r>
-          </a:p>
-          <a:p>
-            <a:pPr lvl="1">
-              <a:defRPr sz="1400" b="0">
-                <a:solidFill>
-                  <a:srgbClr val="000000"/>
-                </a:solidFill>
-                <a:latin typeface="Arial"/>
-              </a:defRPr>
-            </a:pPr>
-            <a:r>
-              <a:t>Data verzameling · twee bronnen, plus de sleutel en de rijen vóór en ná de join</a:t>
-            </a:r>
-          </a:p>
-          <a:p>
-            <a:pPr lvl="1">
-              <a:defRPr sz="1400" b="0">
-                <a:solidFill>
-                  <a:srgbClr val="000000"/>
-                </a:solidFill>
-                <a:latin typeface="Arial"/>
-              </a:defRPr>
-            </a:pPr>
-            <a:r>
-              <a:t>Data verkenning · lege waarden, bereik, dubbele rijen — en wat je ermee deed</a:t>
-            </a:r>
-          </a:p>
-          <a:p>
-            <a:pPr lvl="1">
-              <a:defRPr sz="1400" b="0">
-                <a:solidFill>
-                  <a:srgbClr val="000000"/>
-                </a:solidFill>
-                <a:latin typeface="Arial"/>
-              </a:defRPr>
-            </a:pPr>
-            <a:r>
-              <a:t>Analyse · een conclusie die de data draagt, niet meer dan dat</a:t>
+              <a:t>az = df[df["aan_zet"]]</a:t>
             </a:r>
           </a:p>
           <a:p>
@@ -15575,13 +15721,13 @@
               </a:spcBef>
               <a:defRPr sz="1700" b="1">
                 <a:solidFill>
-                  <a:srgbClr val="25167A"/>
+                  <a:srgbClr val="1B4D3E"/>
                 </a:solidFill>
                 <a:latin typeface="Arial"/>
               </a:defRPr>
             </a:pPr>
             <a:r>
-              <a:t>Vier criteria voor VA — de verhaalkant</a:t>
+              <a:t>az["actie"].value_counts(normalize=True)</a:t>
             </a:r>
           </a:p>
           <a:p>
@@ -15594,20 +15740,20 @@
               </a:defRPr>
             </a:pPr>
             <a:r>
-              <a:t>Opbouw en verhaallijn · Interactiviteit · Dashboardontwerp</a:t>
+              <a:t>fold · 92,2% van alle beslissingen · gemiddeld -3 chips, mediaan 0</a:t>
             </a:r>
           </a:p>
           <a:p>
             <a:pPr lvl="1">
               <a:defRPr sz="1400" b="0">
                 <a:solidFill>
-                  <a:srgbClr val="000000"/>
+                  <a:srgbClr val="1B4D3E"/>
                 </a:solidFill>
                 <a:latin typeface="Arial"/>
               </a:defRPr>
             </a:pPr>
             <a:r>
-              <a:t>Vergelijken en annoteren · het verschil, het opgetelde verloop, of de waarde</a:t>
+              <a:t>call · 5,9% van alle beslissingen · gemiddeld +10 chips, mediaan +30</a:t>
             </a:r>
           </a:p>
           <a:p>
@@ -15620,7 +15766,20 @@
               </a:defRPr>
             </a:pPr>
             <a:r>
-              <a:t>ten opzichte van het moment ervoor — diff, cumsum, shift</a:t>
+              <a:t>raise · 1,3% van alle beslissingen · gemiddeld +65 chips, mediaan +30</a:t>
+            </a:r>
+          </a:p>
+          <a:p>
+            <a:pPr lvl="1">
+              <a:defRPr sz="1400" b="0">
+                <a:solidFill>
+                  <a:srgbClr val="1B4D3E"/>
+                </a:solidFill>
+                <a:latin typeface="Arial"/>
+              </a:defRPr>
+            </a:pPr>
+            <a:r>
+              <a:t>grote_raise · 0,6% van alle beslissingen · gemiddeld +19 chips, mediaan +30</a:t>
             </a:r>
           </a:p>
           <a:p>
@@ -15630,13 +15789,26 @@
               </a:spcBef>
               <a:defRPr sz="1700" b="1">
                 <a:solidFill>
-                  <a:srgbClr val="000000"/>
+                  <a:srgbClr val="25167A"/>
                 </a:solidFill>
                 <a:latin typeface="Arial"/>
               </a:defRPr>
             </a:pPr>
             <a:r>
-              <a:t>Vijf niveaus, van Ontbreekt (1) tot Uitstekend (9).</a:t>
+              <a:t>De klas foldt 92,2% van alles. En elke andere actie levert gemiddeld géld op.</a:t>
+            </a:r>
+          </a:p>
+          <a:p>
+            <a:pPr lvl="1">
+              <a:defRPr sz="1400" b="0">
+                <a:solidFill>
+                  <a:srgbClr val="505A64"/>
+                </a:solidFill>
+                <a:latin typeface="Arial"/>
+              </a:defRPr>
+            </a:pPr>
+            <a:r>
+              <a:t>Let op aan_zet: zonder dat filter tel je handen mee waarin de bot nooit iets koos</a:t>
             </a:r>
           </a:p>
         </p:txBody>
@@ -15976,7 +16148,7 @@
               </a:defRPr>
             </a:pPr>
             <a:r>
-              <a:t>Vijf voorwaarden — die gaan van je cijfer af</a:t>
+              <a:t>De bot die niet nadenkt wint</a:t>
             </a:r>
           </a:p>
         </p:txBody>
@@ -16006,39 +16178,39 @@
             <a:pPr>
               <a:defRPr sz="1700" b="1">
                 <a:solidFill>
-                  <a:srgbClr val="000000"/>
+                  <a:srgbClr val="1B4D3E"/>
                 </a:solidFill>
                 <a:latin typeface="Arial"/>
               </a:defRPr>
             </a:pPr>
             <a:r>
-              <a:t>Dit zijn geen criteria maar drempels. Beide cijfers, IDS en VA.</a:t>
+              <a:t>df.groupby("bot_naam")["stack"].last()</a:t>
             </a:r>
           </a:p>
           <a:p>
             <a:pPr lvl="1">
               <a:defRPr sz="1400" b="0">
                 <a:solidFill>
-                  <a:srgbClr val="000000"/>
+                  <a:srgbClr val="1B4D3E"/>
                 </a:solidFill>
                 <a:latin typeface="Arial"/>
               </a:defRPr>
             </a:pPr>
             <a:r>
-              <a:t>App niet online, of een schone clone draait niet zonder handwerk</a:t>
+              <a:t>1.  Testbot_CalltAlles · 1748 chips · foldt 0%</a:t>
             </a:r>
           </a:p>
           <a:p>
             <a:pPr lvl="1">
               <a:defRPr sz="1400" b="0">
                 <a:solidFill>
-                  <a:srgbClr val="25167A"/>
+                  <a:srgbClr val="000000"/>
                 </a:solidFill>
                 <a:latin typeface="Arial"/>
               </a:defRPr>
             </a:pPr>
             <a:r>
-              <a:t>     -1,0</a:t>
+              <a:t>2.  501011284 · 1738 chips · foldt 82,5%</a:t>
             </a:r>
           </a:p>
           <a:p>
@@ -16051,46 +16223,20 @@
               </a:defRPr>
             </a:pPr>
             <a:r>
-              <a:t>Presentatie langer dan 10 minuten, exclusief vragen</a:t>
+              <a:t>3.  500959250 · 1256 chips · foldt 58,7%</a:t>
             </a:r>
           </a:p>
           <a:p>
             <a:pPr lvl="1">
               <a:defRPr sz="1400" b="0">
                 <a:solidFill>
-                  <a:srgbClr val="25167A"/>
+                  <a:srgbClr val="000000"/>
                 </a:solidFill>
                 <a:latin typeface="Arial"/>
               </a:defRPr>
             </a:pPr>
             <a:r>
-              <a:t>     -1,0</a:t>
-            </a:r>
-          </a:p>
-          <a:p>
-            <a:pPr lvl="1">
-              <a:defRPr sz="1400" b="0">
-                <a:solidFill>
-                  <a:srgbClr val="000000"/>
-                </a:solidFill>
-                <a:latin typeface="Arial"/>
-              </a:defRPr>
-            </a:pPr>
-            <a:r>
-              <a:t>Geen slider, checkbox én dropdown, elk gekoppeld aan een tabel of grafiek</a:t>
-            </a:r>
-          </a:p>
-          <a:p>
-            <a:pPr lvl="1">
-              <a:defRPr sz="1400" b="0">
-                <a:solidFill>
-                  <a:srgbClr val="25167A"/>
-                </a:solidFill>
-                <a:latin typeface="Arial"/>
-              </a:defRPr>
-            </a:pPr>
-            <a:r>
-              <a:t>     -0,5</a:t>
+              <a:t>4.  500851324 · 1202 chips · foldt 96,3%</a:t>
             </a:r>
           </a:p>
           <a:p>
@@ -16106,20 +16252,49 @@
               </a:defRPr>
             </a:pPr>
             <a:r>
-              <a:t>En twee zonder aftrek, maar niet vrijblijvend:</a:t>
+              <a:t>Kijkt niet naar zijn kaarten, rekent geen winkans uit, kent geen pot odds.</a:t>
             </a:r>
           </a:p>
           <a:p>
             <a:pPr lvl="1">
               <a:defRPr sz="1400" b="0">
                 <a:solidFill>
-                  <a:srgbClr val="505A64"/>
+                  <a:srgbClr val="000000"/>
                 </a:solidFill>
                 <a:latin typeface="Arial"/>
               </a:defRPr>
             </a:pPr>
             <a:r>
-              <a:t>Onderwerp op tijd gemeld · code van anderen met bron erbij, en uit te leggen</a:t>
+              <a:t>Hij wint van 26 bots waar uren aan is gewerkt, met 10 chips voorsprong</a:t>
+            </a:r>
+          </a:p>
+          <a:p>
+            <a:pPr lvl="1">
+              <a:defRPr sz="1400" b="0">
+                <a:solidFill>
+                  <a:srgbClr val="000000"/>
+                </a:solidFill>
+                <a:latin typeface="Arial"/>
+              </a:defRPr>
+            </a:pPr>
+            <a:r>
+              <a:t>En die ene die bijna won foldt 82,5%, niet 99%</a:t>
+            </a:r>
+          </a:p>
+          <a:p>
+            <a:pPr>
+              <a:spcBef>
+                <a:spcPts val="1300"/>
+              </a:spcBef>
+              <a:defRPr sz="1700" b="1">
+                <a:solidFill>
+                  <a:srgbClr val="25167A"/>
+                </a:solidFill>
+                <a:latin typeface="Arial"/>
+              </a:defRPr>
+            </a:pPr>
+            <a:r>
+              <a:t>Correlatie fold% met eindstand: -0,69</a:t>
             </a:r>
           </a:p>
         </p:txBody>
@@ -16209,7 +16384,7 @@
               </a:defRPr>
             </a:pPr>
             <a:r>
-              <a:t>Dat heb je vanmiddag al gedaan</a:t>
+              <a:t>Groepscase 2 — wat je oplevert</a:t>
             </a:r>
           </a:p>
         </p:txBody>
@@ -16245,20 +16420,20 @@
               </a:defRPr>
             </a:pPr>
             <a:r>
-              <a:t>De demo van zojuist was Case 2 in het klein:</a:t>
+              <a:t>Een Streamlit-dashboard over een onderwerp dat je zelf kiest.</a:t>
             </a:r>
           </a:p>
           <a:p>
             <a:pPr lvl="1">
               <a:defRPr sz="1400" b="0">
                 <a:solidFill>
-                  <a:srgbClr val="1B4D3E"/>
+                  <a:srgbClr val="000000"/>
                 </a:solidFill>
                 <a:latin typeface="Arial"/>
               </a:defRPr>
             </a:pPr>
             <a:r>
-              <a:t>twee tabellen op bot_naam samengevoegd, rijen geteld vóór en ná</a:t>
+              <a:t>Gepubliceerd via GitHub op share.streamlit.io, te openen met een link</a:t>
             </a:r>
           </a:p>
           <a:p>
@@ -16271,7 +16446,7 @@
               </a:defRPr>
             </a:pPr>
             <a:r>
-              <a:t>     → criterium Data verzameling</a:t>
+              <a:t>De app haalt de data zelf op bij een openbare API — niet met de hand gedownload</a:t>
             </a:r>
           </a:p>
           <a:p>
@@ -16284,46 +16459,7 @@
               </a:defRPr>
             </a:pPr>
             <a:r>
-              <a:t>928 lege waarden gevonden, en gezien wat ze met je percentage deden</a:t>
-            </a:r>
-          </a:p>
-          <a:p>
-            <a:pPr lvl="1">
-              <a:defRPr sz="1400" b="0">
-                <a:solidFill>
-                  <a:srgbClr val="000000"/>
-                </a:solidFill>
-                <a:latin typeface="Arial"/>
-              </a:defRPr>
-            </a:pPr>
-            <a:r>
-              <a:t>     → criterium Data verkenning</a:t>
-            </a:r>
-          </a:p>
-          <a:p>
-            <a:pPr lvl="1">
-              <a:defRPr sz="1400" b="0">
-                <a:solidFill>
-                  <a:srgbClr val="1B4D3E"/>
-                </a:solidFill>
-                <a:latin typeface="Arial"/>
-              </a:defRPr>
-            </a:pPr>
-            <a:r>
-              <a:t>diff en cumsum over het verloop van een stack</a:t>
-            </a:r>
-          </a:p>
-          <a:p>
-            <a:pPr lvl="1">
-              <a:defRPr sz="1400" b="0">
-                <a:solidFill>
-                  <a:srgbClr val="000000"/>
-                </a:solidFill>
-                <a:latin typeface="Arial"/>
-              </a:defRPr>
-            </a:pPr>
-            <a:r>
-              <a:t>     → criterium Vergelijken en annoteren</a:t>
+              <a:t>Minimaal één join: twee bronnen die je tot één tabel samenvoegt</a:t>
             </a:r>
           </a:p>
           <a:p>
@@ -16339,20 +16475,62 @@
               </a:defRPr>
             </a:pPr>
             <a:r>
-              <a:t>Het verschil met de case: daar kiest niemand de dataset voor je,</a:t>
+              <a:t>Loopt over week 3 en week 4. Dat is kort.</a:t>
             </a:r>
           </a:p>
           <a:p>
             <a:pPr lvl="1">
               <a:defRPr sz="1400" b="0">
                 <a:solidFill>
-                  <a:srgbClr val="505A64"/>
+                  <a:srgbClr val="000000"/>
                 </a:solidFill>
                 <a:latin typeface="Arial"/>
               </a:defRPr>
             </a:pPr>
             <a:r>
-              <a:t>en staat er geen kolom aan_zet klaar om je fout te laten zien.</a:t>
+              <a:t>Donderdag 18:00 staat je onderwerp vast: welke vraag, welke twee bronnen,</a:t>
+            </a:r>
+          </a:p>
+          <a:p>
+            <a:pPr lvl="1">
+              <a:defRPr sz="1400" b="0">
+                <a:solidFill>
+                  <a:srgbClr val="000000"/>
+                </a:solidFill>
+                <a:latin typeface="Arial"/>
+              </a:defRPr>
+            </a:pPr>
+            <a:r>
+              <a:t>op welke kolom die aan elkaar passen, en wie in de groep wat doet</a:t>
+            </a:r>
+          </a:p>
+          <a:p>
+            <a:pPr>
+              <a:spcBef>
+                <a:spcPts val="1300"/>
+              </a:spcBef>
+              <a:defRPr sz="1700" b="1">
+                <a:solidFill>
+                  <a:srgbClr val="25167A"/>
+                </a:solidFill>
+                <a:latin typeface="Arial"/>
+              </a:defRPr>
+            </a:pPr>
+            <a:r>
+              <a:t>Zoek nu al op of die twee bronnen écht een gemeenschappelijke kolom hebben.</a:t>
+            </a:r>
+          </a:p>
+          <a:p>
+            <a:pPr lvl="1">
+              <a:defRPr sz="1400" b="0">
+                <a:solidFill>
+                  <a:srgbClr val="505A64"/>
+                </a:solidFill>
+                <a:latin typeface="Arial"/>
+              </a:defRPr>
+            </a:pPr>
+            <a:r>
+              <a:t>"Den Haag" en "'s-Gravenhage" passen niet op elkaar zonder werk</a:t>
             </a:r>
           </a:p>
         </p:txBody>
@@ -16389,6 +16567,708 @@
             </a:pPr>
             <a:r>
               <a:t>31</a:t>
+            </a:r>
+          </a:p>
+        </p:txBody>
+      </p:sp>
+    </p:spTree>
+  </p:cSld>
+  <p:clrMapOvr>
+    <a:masterClrMapping/>
+  </p:clrMapOvr>
+</p:sld>
+</file>
+
+<file path=ppt/slides/slide32.xml><?xml version="1.0" encoding="utf-8"?>
+<p:sld xmlns:a="http://schemas.openxmlformats.org/drawingml/2006/main" xmlns:p="http://schemas.openxmlformats.org/presentationml/2006/main" xmlns:r="http://schemas.openxmlformats.org/officeDocument/2006/relationships">
+  <p:cSld>
+    <p:spTree>
+      <p:nvGrpSpPr>
+        <p:cNvPr id="1" name=""/>
+        <p:cNvGrpSpPr/>
+        <p:nvPr/>
+      </p:nvGrpSpPr>
+      <p:grpSpPr/>
+      <p:sp>
+        <p:nvSpPr>
+          <p:cNvPr id="2" name="TextBox 1"/>
+          <p:cNvSpPr txBox="1"/>
+          <p:nvPr/>
+        </p:nvSpPr>
+        <p:spPr>
+          <a:xfrm>
+            <a:off x="1984248" y="941832"/>
+            <a:ext cx="8229600" cy="1143000"/>
+          </a:xfrm>
+          <a:prstGeom prst="rect">
+            <a:avLst/>
+          </a:prstGeom>
+          <a:noFill/>
+        </p:spPr>
+        <p:txBody>
+          <a:bodyPr wrap="square">
+            <a:spAutoFit/>
+          </a:bodyPr>
+          <a:lstStyle/>
+          <a:p>
+            <a:pPr>
+              <a:defRPr sz="3200">
+                <a:solidFill>
+                  <a:srgbClr val="25167A"/>
+                </a:solidFill>
+                <a:latin typeface="Arial"/>
+              </a:defRPr>
+            </a:pPr>
+            <a:r>
+              <a:t>Waar je cijfer vandaan komt</a:t>
+            </a:r>
+          </a:p>
+        </p:txBody>
+      </p:sp>
+      <p:sp>
+        <p:nvSpPr>
+          <p:cNvPr id="3" name="TextBox 2"/>
+          <p:cNvSpPr txBox="1"/>
+          <p:nvPr/>
+        </p:nvSpPr>
+        <p:spPr>
+          <a:xfrm>
+            <a:off x="1984248" y="2084831"/>
+            <a:ext cx="8778240" cy="4041648"/>
+          </a:xfrm>
+          <a:prstGeom prst="rect">
+            <a:avLst/>
+          </a:prstGeom>
+          <a:noFill/>
+        </p:spPr>
+        <p:txBody>
+          <a:bodyPr wrap="square">
+            <a:spAutoFit/>
+          </a:bodyPr>
+          <a:lstStyle/>
+          <a:p>
+            <a:pPr>
+              <a:defRPr sz="1700" b="1">
+                <a:solidFill>
+                  <a:srgbClr val="25167A"/>
+                </a:solidFill>
+                <a:latin typeface="Arial"/>
+              </a:defRPr>
+            </a:pPr>
+            <a:r>
+              <a:t>Drie criteria voor IDS — de data-kant</a:t>
+            </a:r>
+          </a:p>
+          <a:p>
+            <a:pPr lvl="1">
+              <a:defRPr sz="1400" b="0">
+                <a:solidFill>
+                  <a:srgbClr val="000000"/>
+                </a:solidFill>
+                <a:latin typeface="Arial"/>
+              </a:defRPr>
+            </a:pPr>
+            <a:r>
+              <a:t>Data verzameling · twee bronnen, plus de sleutel en de rijen vóór en ná de join</a:t>
+            </a:r>
+          </a:p>
+          <a:p>
+            <a:pPr lvl="1">
+              <a:defRPr sz="1400" b="0">
+                <a:solidFill>
+                  <a:srgbClr val="000000"/>
+                </a:solidFill>
+                <a:latin typeface="Arial"/>
+              </a:defRPr>
+            </a:pPr>
+            <a:r>
+              <a:t>Data verkenning · lege waarden, bereik, dubbele rijen — en wat je ermee deed</a:t>
+            </a:r>
+          </a:p>
+          <a:p>
+            <a:pPr lvl="1">
+              <a:defRPr sz="1400" b="0">
+                <a:solidFill>
+                  <a:srgbClr val="000000"/>
+                </a:solidFill>
+                <a:latin typeface="Arial"/>
+              </a:defRPr>
+            </a:pPr>
+            <a:r>
+              <a:t>Analyse · een conclusie die de data draagt, niet meer dan dat</a:t>
+            </a:r>
+          </a:p>
+          <a:p>
+            <a:pPr>
+              <a:spcBef>
+                <a:spcPts val="1300"/>
+              </a:spcBef>
+              <a:defRPr sz="1700" b="1">
+                <a:solidFill>
+                  <a:srgbClr val="25167A"/>
+                </a:solidFill>
+                <a:latin typeface="Arial"/>
+              </a:defRPr>
+            </a:pPr>
+            <a:r>
+              <a:t>Vier criteria voor VA — de verhaalkant</a:t>
+            </a:r>
+          </a:p>
+          <a:p>
+            <a:pPr lvl="1">
+              <a:defRPr sz="1400" b="0">
+                <a:solidFill>
+                  <a:srgbClr val="000000"/>
+                </a:solidFill>
+                <a:latin typeface="Arial"/>
+              </a:defRPr>
+            </a:pPr>
+            <a:r>
+              <a:t>Opbouw en verhaallijn · Interactiviteit · Dashboardontwerp</a:t>
+            </a:r>
+          </a:p>
+          <a:p>
+            <a:pPr lvl="1">
+              <a:defRPr sz="1400" b="0">
+                <a:solidFill>
+                  <a:srgbClr val="000000"/>
+                </a:solidFill>
+                <a:latin typeface="Arial"/>
+              </a:defRPr>
+            </a:pPr>
+            <a:r>
+              <a:t>Vergelijken en annoteren · het verschil, het opgetelde verloop, of de waarde</a:t>
+            </a:r>
+          </a:p>
+          <a:p>
+            <a:pPr lvl="1">
+              <a:defRPr sz="1400" b="0">
+                <a:solidFill>
+                  <a:srgbClr val="1B4D3E"/>
+                </a:solidFill>
+                <a:latin typeface="Arial"/>
+              </a:defRPr>
+            </a:pPr>
+            <a:r>
+              <a:t>ten opzichte van het moment ervoor — diff, cumsum, shift</a:t>
+            </a:r>
+          </a:p>
+          <a:p>
+            <a:pPr>
+              <a:spcBef>
+                <a:spcPts val="1300"/>
+              </a:spcBef>
+              <a:defRPr sz="1700" b="1">
+                <a:solidFill>
+                  <a:srgbClr val="000000"/>
+                </a:solidFill>
+                <a:latin typeface="Arial"/>
+              </a:defRPr>
+            </a:pPr>
+            <a:r>
+              <a:t>Vijf niveaus, van Ontbreekt (1) tot Uitstekend (9).</a:t>
+            </a:r>
+          </a:p>
+        </p:txBody>
+      </p:sp>
+      <p:sp>
+        <p:nvSpPr>
+          <p:cNvPr id="4" name="TextBox 3"/>
+          <p:cNvSpPr txBox="1"/>
+          <p:nvPr/>
+        </p:nvSpPr>
+        <p:spPr>
+          <a:xfrm>
+            <a:off x="9774936" y="6126480"/>
+            <a:ext cx="630936" cy="365760"/>
+          </a:xfrm>
+          <a:prstGeom prst="rect">
+            <a:avLst/>
+          </a:prstGeom>
+          <a:noFill/>
+        </p:spPr>
+        <p:txBody>
+          <a:bodyPr wrap="none">
+            <a:spAutoFit/>
+          </a:bodyPr>
+          <a:lstStyle/>
+          <a:p>
+            <a:pPr>
+              <a:defRPr sz="1200">
+                <a:solidFill>
+                  <a:srgbClr val="505A64"/>
+                </a:solidFill>
+                <a:latin typeface="Arial"/>
+              </a:defRPr>
+            </a:pPr>
+            <a:r>
+              <a:t>32</a:t>
+            </a:r>
+          </a:p>
+        </p:txBody>
+      </p:sp>
+    </p:spTree>
+  </p:cSld>
+  <p:clrMapOvr>
+    <a:masterClrMapping/>
+  </p:clrMapOvr>
+</p:sld>
+</file>
+
+<file path=ppt/slides/slide33.xml><?xml version="1.0" encoding="utf-8"?>
+<p:sld xmlns:a="http://schemas.openxmlformats.org/drawingml/2006/main" xmlns:p="http://schemas.openxmlformats.org/presentationml/2006/main" xmlns:r="http://schemas.openxmlformats.org/officeDocument/2006/relationships">
+  <p:cSld>
+    <p:spTree>
+      <p:nvGrpSpPr>
+        <p:cNvPr id="1" name=""/>
+        <p:cNvGrpSpPr/>
+        <p:nvPr/>
+      </p:nvGrpSpPr>
+      <p:grpSpPr/>
+      <p:sp>
+        <p:nvSpPr>
+          <p:cNvPr id="2" name="TextBox 1"/>
+          <p:cNvSpPr txBox="1"/>
+          <p:nvPr/>
+        </p:nvSpPr>
+        <p:spPr>
+          <a:xfrm>
+            <a:off x="1984248" y="941832"/>
+            <a:ext cx="8229600" cy="1143000"/>
+          </a:xfrm>
+          <a:prstGeom prst="rect">
+            <a:avLst/>
+          </a:prstGeom>
+          <a:noFill/>
+        </p:spPr>
+        <p:txBody>
+          <a:bodyPr wrap="square">
+            <a:spAutoFit/>
+          </a:bodyPr>
+          <a:lstStyle/>
+          <a:p>
+            <a:pPr>
+              <a:defRPr sz="3200">
+                <a:solidFill>
+                  <a:srgbClr val="25167A"/>
+                </a:solidFill>
+                <a:latin typeface="Arial"/>
+              </a:defRPr>
+            </a:pPr>
+            <a:r>
+              <a:t>Vijf voorwaarden — die gaan van je cijfer af</a:t>
+            </a:r>
+          </a:p>
+        </p:txBody>
+      </p:sp>
+      <p:sp>
+        <p:nvSpPr>
+          <p:cNvPr id="3" name="TextBox 2"/>
+          <p:cNvSpPr txBox="1"/>
+          <p:nvPr/>
+        </p:nvSpPr>
+        <p:spPr>
+          <a:xfrm>
+            <a:off x="1984248" y="2084831"/>
+            <a:ext cx="8778240" cy="4041648"/>
+          </a:xfrm>
+          <a:prstGeom prst="rect">
+            <a:avLst/>
+          </a:prstGeom>
+          <a:noFill/>
+        </p:spPr>
+        <p:txBody>
+          <a:bodyPr wrap="square">
+            <a:spAutoFit/>
+          </a:bodyPr>
+          <a:lstStyle/>
+          <a:p>
+            <a:pPr>
+              <a:defRPr sz="1700" b="1">
+                <a:solidFill>
+                  <a:srgbClr val="000000"/>
+                </a:solidFill>
+                <a:latin typeface="Arial"/>
+              </a:defRPr>
+            </a:pPr>
+            <a:r>
+              <a:t>Dit zijn geen criteria maar drempels. Beide cijfers, IDS en VA.</a:t>
+            </a:r>
+          </a:p>
+          <a:p>
+            <a:pPr lvl="1">
+              <a:defRPr sz="1400" b="0">
+                <a:solidFill>
+                  <a:srgbClr val="000000"/>
+                </a:solidFill>
+                <a:latin typeface="Arial"/>
+              </a:defRPr>
+            </a:pPr>
+            <a:r>
+              <a:t>App niet online, of een schone clone draait niet zonder handwerk</a:t>
+            </a:r>
+          </a:p>
+          <a:p>
+            <a:pPr lvl="1">
+              <a:defRPr sz="1400" b="0">
+                <a:solidFill>
+                  <a:srgbClr val="25167A"/>
+                </a:solidFill>
+                <a:latin typeface="Arial"/>
+              </a:defRPr>
+            </a:pPr>
+            <a:r>
+              <a:t>     -1,0</a:t>
+            </a:r>
+          </a:p>
+          <a:p>
+            <a:pPr lvl="1">
+              <a:defRPr sz="1400" b="0">
+                <a:solidFill>
+                  <a:srgbClr val="000000"/>
+                </a:solidFill>
+                <a:latin typeface="Arial"/>
+              </a:defRPr>
+            </a:pPr>
+            <a:r>
+              <a:t>Presentatie langer dan 10 minuten, exclusief vragen</a:t>
+            </a:r>
+          </a:p>
+          <a:p>
+            <a:pPr lvl="1">
+              <a:defRPr sz="1400" b="0">
+                <a:solidFill>
+                  <a:srgbClr val="25167A"/>
+                </a:solidFill>
+                <a:latin typeface="Arial"/>
+              </a:defRPr>
+            </a:pPr>
+            <a:r>
+              <a:t>     -1,0</a:t>
+            </a:r>
+          </a:p>
+          <a:p>
+            <a:pPr lvl="1">
+              <a:defRPr sz="1400" b="0">
+                <a:solidFill>
+                  <a:srgbClr val="000000"/>
+                </a:solidFill>
+                <a:latin typeface="Arial"/>
+              </a:defRPr>
+            </a:pPr>
+            <a:r>
+              <a:t>Geen slider, checkbox én dropdown, elk gekoppeld aan een tabel of grafiek</a:t>
+            </a:r>
+          </a:p>
+          <a:p>
+            <a:pPr lvl="1">
+              <a:defRPr sz="1400" b="0">
+                <a:solidFill>
+                  <a:srgbClr val="25167A"/>
+                </a:solidFill>
+                <a:latin typeface="Arial"/>
+              </a:defRPr>
+            </a:pPr>
+            <a:r>
+              <a:t>     -0,5</a:t>
+            </a:r>
+          </a:p>
+          <a:p>
+            <a:pPr>
+              <a:spcBef>
+                <a:spcPts val="1300"/>
+              </a:spcBef>
+              <a:defRPr sz="1700" b="1">
+                <a:solidFill>
+                  <a:srgbClr val="000000"/>
+                </a:solidFill>
+                <a:latin typeface="Arial"/>
+              </a:defRPr>
+            </a:pPr>
+            <a:r>
+              <a:t>En twee zonder aftrek, maar niet vrijblijvend:</a:t>
+            </a:r>
+          </a:p>
+          <a:p>
+            <a:pPr lvl="1">
+              <a:defRPr sz="1400" b="0">
+                <a:solidFill>
+                  <a:srgbClr val="505A64"/>
+                </a:solidFill>
+                <a:latin typeface="Arial"/>
+              </a:defRPr>
+            </a:pPr>
+            <a:r>
+              <a:t>Onderwerp op tijd gemeld · code van anderen met bron erbij, en uit te leggen</a:t>
+            </a:r>
+          </a:p>
+        </p:txBody>
+      </p:sp>
+      <p:sp>
+        <p:nvSpPr>
+          <p:cNvPr id="4" name="TextBox 3"/>
+          <p:cNvSpPr txBox="1"/>
+          <p:nvPr/>
+        </p:nvSpPr>
+        <p:spPr>
+          <a:xfrm>
+            <a:off x="9774936" y="6126480"/>
+            <a:ext cx="630936" cy="365760"/>
+          </a:xfrm>
+          <a:prstGeom prst="rect">
+            <a:avLst/>
+          </a:prstGeom>
+          <a:noFill/>
+        </p:spPr>
+        <p:txBody>
+          <a:bodyPr wrap="none">
+            <a:spAutoFit/>
+          </a:bodyPr>
+          <a:lstStyle/>
+          <a:p>
+            <a:pPr>
+              <a:defRPr sz="1200">
+                <a:solidFill>
+                  <a:srgbClr val="505A64"/>
+                </a:solidFill>
+                <a:latin typeface="Arial"/>
+              </a:defRPr>
+            </a:pPr>
+            <a:r>
+              <a:t>33</a:t>
+            </a:r>
+          </a:p>
+        </p:txBody>
+      </p:sp>
+    </p:spTree>
+  </p:cSld>
+  <p:clrMapOvr>
+    <a:masterClrMapping/>
+  </p:clrMapOvr>
+</p:sld>
+</file>
+
+<file path=ppt/slides/slide34.xml><?xml version="1.0" encoding="utf-8"?>
+<p:sld xmlns:a="http://schemas.openxmlformats.org/drawingml/2006/main" xmlns:p="http://schemas.openxmlformats.org/presentationml/2006/main" xmlns:r="http://schemas.openxmlformats.org/officeDocument/2006/relationships">
+  <p:cSld>
+    <p:spTree>
+      <p:nvGrpSpPr>
+        <p:cNvPr id="1" name=""/>
+        <p:cNvGrpSpPr/>
+        <p:nvPr/>
+      </p:nvGrpSpPr>
+      <p:grpSpPr/>
+      <p:sp>
+        <p:nvSpPr>
+          <p:cNvPr id="2" name="TextBox 1"/>
+          <p:cNvSpPr txBox="1"/>
+          <p:nvPr/>
+        </p:nvSpPr>
+        <p:spPr>
+          <a:xfrm>
+            <a:off x="1984248" y="941832"/>
+            <a:ext cx="8229600" cy="1143000"/>
+          </a:xfrm>
+          <a:prstGeom prst="rect">
+            <a:avLst/>
+          </a:prstGeom>
+          <a:noFill/>
+        </p:spPr>
+        <p:txBody>
+          <a:bodyPr wrap="square">
+            <a:spAutoFit/>
+          </a:bodyPr>
+          <a:lstStyle/>
+          <a:p>
+            <a:pPr>
+              <a:defRPr sz="3200">
+                <a:solidFill>
+                  <a:srgbClr val="25167A"/>
+                </a:solidFill>
+                <a:latin typeface="Arial"/>
+              </a:defRPr>
+            </a:pPr>
+            <a:r>
+              <a:t>Dat heb je vanmiddag al gedaan</a:t>
+            </a:r>
+          </a:p>
+        </p:txBody>
+      </p:sp>
+      <p:sp>
+        <p:nvSpPr>
+          <p:cNvPr id="3" name="TextBox 2"/>
+          <p:cNvSpPr txBox="1"/>
+          <p:nvPr/>
+        </p:nvSpPr>
+        <p:spPr>
+          <a:xfrm>
+            <a:off x="1984248" y="2084831"/>
+            <a:ext cx="8778240" cy="4041648"/>
+          </a:xfrm>
+          <a:prstGeom prst="rect">
+            <a:avLst/>
+          </a:prstGeom>
+          <a:noFill/>
+        </p:spPr>
+        <p:txBody>
+          <a:bodyPr wrap="square">
+            <a:spAutoFit/>
+          </a:bodyPr>
+          <a:lstStyle/>
+          <a:p>
+            <a:pPr>
+              <a:defRPr sz="1700" b="1">
+                <a:solidFill>
+                  <a:srgbClr val="000000"/>
+                </a:solidFill>
+                <a:latin typeface="Arial"/>
+              </a:defRPr>
+            </a:pPr>
+            <a:r>
+              <a:t>De demo van zojuist was Case 2 in het klein:</a:t>
+            </a:r>
+          </a:p>
+          <a:p>
+            <a:pPr lvl="1">
+              <a:defRPr sz="1400" b="0">
+                <a:solidFill>
+                  <a:srgbClr val="1B4D3E"/>
+                </a:solidFill>
+                <a:latin typeface="Arial"/>
+              </a:defRPr>
+            </a:pPr>
+            <a:r>
+              <a:t>twee tabellen op bot_naam samengevoegd, rijen geteld vóór en ná</a:t>
+            </a:r>
+          </a:p>
+          <a:p>
+            <a:pPr lvl="1">
+              <a:defRPr sz="1400" b="0">
+                <a:solidFill>
+                  <a:srgbClr val="000000"/>
+                </a:solidFill>
+                <a:latin typeface="Arial"/>
+              </a:defRPr>
+            </a:pPr>
+            <a:r>
+              <a:t>     → criterium Data verzameling</a:t>
+            </a:r>
+          </a:p>
+          <a:p>
+            <a:pPr lvl="1">
+              <a:defRPr sz="1400" b="0">
+                <a:solidFill>
+                  <a:srgbClr val="1B4D3E"/>
+                </a:solidFill>
+                <a:latin typeface="Arial"/>
+              </a:defRPr>
+            </a:pPr>
+            <a:r>
+              <a:t>928 lege waarden gevonden, en gezien wat ze met je percentage deden</a:t>
+            </a:r>
+          </a:p>
+          <a:p>
+            <a:pPr lvl="1">
+              <a:defRPr sz="1400" b="0">
+                <a:solidFill>
+                  <a:srgbClr val="000000"/>
+                </a:solidFill>
+                <a:latin typeface="Arial"/>
+              </a:defRPr>
+            </a:pPr>
+            <a:r>
+              <a:t>     → criterium Data verkenning</a:t>
+            </a:r>
+          </a:p>
+          <a:p>
+            <a:pPr lvl="1">
+              <a:defRPr sz="1400" b="0">
+                <a:solidFill>
+                  <a:srgbClr val="1B4D3E"/>
+                </a:solidFill>
+                <a:latin typeface="Arial"/>
+              </a:defRPr>
+            </a:pPr>
+            <a:r>
+              <a:t>diff en cumsum over het verloop van een stack</a:t>
+            </a:r>
+          </a:p>
+          <a:p>
+            <a:pPr lvl="1">
+              <a:defRPr sz="1400" b="0">
+                <a:solidFill>
+                  <a:srgbClr val="000000"/>
+                </a:solidFill>
+                <a:latin typeface="Arial"/>
+              </a:defRPr>
+            </a:pPr>
+            <a:r>
+              <a:t>     → criterium Vergelijken en annoteren</a:t>
+            </a:r>
+          </a:p>
+          <a:p>
+            <a:pPr>
+              <a:spcBef>
+                <a:spcPts val="1300"/>
+              </a:spcBef>
+              <a:defRPr sz="1700" b="1">
+                <a:solidFill>
+                  <a:srgbClr val="000000"/>
+                </a:solidFill>
+                <a:latin typeface="Arial"/>
+              </a:defRPr>
+            </a:pPr>
+            <a:r>
+              <a:t>Het verschil met de case: daar kiest niemand de dataset voor je,</a:t>
+            </a:r>
+          </a:p>
+          <a:p>
+            <a:pPr lvl="1">
+              <a:defRPr sz="1400" b="0">
+                <a:solidFill>
+                  <a:srgbClr val="505A64"/>
+                </a:solidFill>
+                <a:latin typeface="Arial"/>
+              </a:defRPr>
+            </a:pPr>
+            <a:r>
+              <a:t>en staat er geen kolom aan_zet klaar om je fout te laten zien.</a:t>
+            </a:r>
+          </a:p>
+        </p:txBody>
+      </p:sp>
+      <p:sp>
+        <p:nvSpPr>
+          <p:cNvPr id="4" name="TextBox 3"/>
+          <p:cNvSpPr txBox="1"/>
+          <p:nvPr/>
+        </p:nvSpPr>
+        <p:spPr>
+          <a:xfrm>
+            <a:off x="9774936" y="6126480"/>
+            <a:ext cx="630936" cy="365760"/>
+          </a:xfrm>
+          <a:prstGeom prst="rect">
+            <a:avLst/>
+          </a:prstGeom>
+          <a:noFill/>
+        </p:spPr>
+        <p:txBody>
+          <a:bodyPr wrap="none">
+            <a:spAutoFit/>
+          </a:bodyPr>
+          <a:lstStyle/>
+          <a:p>
+            <a:pPr>
+              <a:defRPr sz="1200">
+                <a:solidFill>
+                  <a:srgbClr val="505A64"/>
+                </a:solidFill>
+                <a:latin typeface="Arial"/>
+              </a:defRPr>
+            </a:pPr>
+            <a:r>
+              <a:t>34</a:t>
             </a:r>
           </a:p>
         </p:txBody>

</xml_diff>

<commit_message>
De plaat toont de eindstanden, zonder bijschrift
Het bijschrift klopte niet: "5975 handen tussen -20 en +20" telde de handen van
precies twintig chips niet mee, terwijl de tabel op de dia ervoor dat wel doet.
432 handen verschil, op een dia waar die tabel er direct naast staat. Er staat nu
helemaal geen tekst meer in de plaat -- wat erover gezegd moet worden hoort in de
notities, en een bijschrift beweert vroeg of laat iets dat na een nieuwe ronde
niet meer klopt.

En het zijn de eindstanden geworden. De winst per hand is voor 92% een blind van
tien of twintig chips: getekend krijg je één balk en verder wit. Als tabel op de
dia ervoor is die verdeling leesbaar, getekend niet. De eindstanden wel: 27 bots,
allemaal begonnen op 1000, met de startstack als stippellijn erin.

De uitschieters in het hand-log kloppen overigens wel. Bot 501011284 ging in hand
21 van 1270 naar 3020 -- dat is echt 1750 chips in één hand.

Co-Authored-By: Claude Opus 5 <noreply@anthropic.com>
</commit_message>
<xml_diff>
--- a/powerpoints/hoorcollege/03_Exploring_Manipulating_Data_aangevuld.pptx
+++ b/powerpoints/hoorcollege/03_Exploring_Manipulating_Data_aangevuld.pptx
@@ -2108,33 +2108,49 @@
           <a:lstStyle/>
           <a:p>
             <a:r>
-              <a:t>De y-as is logaritmisch, en dat is geen truc maar de</a:t>
-            </a:r>
-          </a:p>
-          <a:p>
-            <a:r>
-              <a:t>enige manier om allebei te zien: de piek is duizenden handen hoog en de staart is</a:t>
-            </a:r>
-          </a:p>
-          <a:p>
-            <a:r>
-              <a:t>één hand. Lineair zie je één balk en verder wit.</a:t>
+              <a:t>Iedereen begon op 1000, de stippellijn.</a:t>
+            </a:r>
+          </a:p>
+          <a:p>
+            <a:r>
+              <a:t>Dertien bots eindigen tussen 900 en 1000 -- die hebben iets verloren en verder</a:t>
+            </a:r>
+          </a:p>
+          <a:p>
+            <a:r>
+              <a:t>nauwelijks gespeeld. Links één uitschieter naar beneden, rechts twee die er ver</a:t>
+            </a:r>
+          </a:p>
+          <a:p>
+            <a:r>
+              <a:t>bovenuit steken.</a:t>
             </a:r>
           </a:p>
           <a:p/>
           <a:p>
             <a:r>
-              <a:t>Goede vraag aan de zaal: df["winst"].hist(bins=40) geeft precies dat lege plaatje.</a:t>
-            </a:r>
-          </a:p>
-          <a:p>
-            <a:r>
-              <a:t>Wie had gemerkt dat er iets ontbrak? De standaardinstelling van een grafiek is een</a:t>
-            </a:r>
-          </a:p>
-          <a:p>
-            <a:r>
-              <a:t>keuze die iemand anders voor je heeft gemaakt.</a:t>
+              <a:t>Vraag aan de zaal voordat je doorklikt: wie denk je dat die twee rechts zijn? Op</a:t>
+            </a:r>
+          </a:p>
+          <a:p>
+            <a:r>
+              <a:t>de volgende dia staat het antwoord, en dat is niet wat ze verwachten.</a:t>
+            </a:r>
+          </a:p>
+          <a:p/>
+          <a:p>
+            <a:r>
+              <a:t>Waarom dit de eindstanden zijn en niet de winst per hand: dat laatste is voor 92%</a:t>
+            </a:r>
+          </a:p>
+          <a:p>
+            <a:r>
+              <a:t>een blind van tien of twintig chips, dus getekend krijg je één balk en verder wit.</a:t>
+            </a:r>
+          </a:p>
+          <a:p>
+            <a:r>
+              <a:t>Die verdeling staat als tabel op de dia hiervoor, waar hij wel leesbaar is.</a:t>
             </a:r>
           </a:p>
         </p:txBody>
@@ -15537,7 +15553,7 @@
               </a:defRPr>
             </a:pPr>
             <a:r>
-              <a:t>Hetzelfde, getekend</a:t>
+              <a:t>Waar 27 bots zijn geëindigd</a:t>
             </a:r>
           </a:p>
         </p:txBody>
@@ -15568,7 +15584,7 @@
       </p:sp>
       <p:pic>
         <p:nvPicPr>
-          <p:cNvPr id="4" name="Picture 3" descr="winst_histogram.png"/>
+          <p:cNvPr id="4" name="Picture 3" descr="eindstanden_histogram.png"/>
           <p:cNvPicPr>
             <a:picLocks noChangeAspect="1"/>
           </p:cNvPicPr>

</xml_diff>

<commit_message>
Twee platen: de winst per hand en de eindstanden
Ze vertellen niet hetzelfde en horen daarom allebei in het deck, elk naast het
blok dat erover gaat. De winst per hand staat achter de bakjestabel, de
eindstanden achter de uitslag.

Het verschil tussen de twee assen is zelf de les. De winst per hand is voor ruim
negentig procent een blind van tien of twintig chips, dus die y-as moet
logaritmisch: lineair krijg je één balk en verder wit -- precies wat
df["winst"].hist(bins=40) oplevert. De eindstand is één getal per bot en past
gewoon lineair, met de startstack als stippellijn.

Ook in het document voor volgend jaar: de ZeroDivisionError en het doorspelen
staan bij "dit jaar al opgelost", en er staat een punt bij Techniek over waaróm
dit kon gebeuren -- dezelfde functie in een notebook en in de backend, die uit
elkaar lopen zonder dat iets het meldt. De zeven testbestanden dekken de API wel
en de notebooks niet.

Co-Authored-By: Claude Opus 5 <noreply@anthropic.com>
</commit_message>
<xml_diff>
--- a/powerpoints/hoorcollege/03_Exploring_Manipulating_Data_aangevuld.pptx
+++ b/powerpoints/hoorcollege/03_Exploring_Manipulating_Data_aangevuld.pptx
@@ -44,6 +44,7 @@
     <p:sldId id="912" r:id="rId45"/>
     <p:sldId id="913" r:id="rId46"/>
     <p:sldId id="914" r:id="rId47"/>
+    <p:sldId id="915" r:id="rId48"/>
   </p:sldIdLst>
   <p:sldSz cx="12192000" cy="6858000"/>
   <p:notesSz cx="6858000" cy="9144000"/>
@@ -2108,49 +2109,44 @@
           <a:lstStyle/>
           <a:p>
             <a:r>
-              <a:t>Iedereen begon op 1000, de stippellijn.</a:t>
-            </a:r>
-          </a:p>
-          <a:p>
-            <a:r>
-              <a:t>Dertien bots eindigen tussen 900 en 1000 -- die hebben iets verloren en verder</a:t>
-            </a:r>
-          </a:p>
-          <a:p>
-            <a:r>
-              <a:t>nauwelijks gespeeld. Links één uitschieter naar beneden, rechts twee die er ver</a:t>
-            </a:r>
-          </a:p>
-          <a:p>
-            <a:r>
-              <a:t>bovenuit steken.</a:t>
+              <a:t>De y-as is logaritmisch en dat is geen truc:</a:t>
+            </a:r>
+          </a:p>
+          <a:p>
+            <a:r>
+              <a:t>de piek is duizenden handen hoog en de staarten zijn één hand. Lineair krijg je één</a:t>
+            </a:r>
+          </a:p>
+          <a:p>
+            <a:r>
+              <a:t>balk en verder wit.</a:t>
             </a:r>
           </a:p>
           <a:p/>
           <a:p>
             <a:r>
-              <a:t>Vraag aan de zaal voordat je doorklikt: wie denk je dat die twee rechts zijn? Op</a:t>
-            </a:r>
-          </a:p>
-          <a:p>
-            <a:r>
-              <a:t>de volgende dia staat het antwoord, en dat is niet wat ze verwachten.</a:t>
+              <a:t>Dat is de vraag voor de zaal. df["winst"].hist(bins=40) geeft precies dat lege</a:t>
+            </a:r>
+          </a:p>
+          <a:p>
+            <a:r>
+              <a:t>plaatje -- wie had gemerkt dat er iets ontbrak? De standaardinstelling van een</a:t>
+            </a:r>
+          </a:p>
+          <a:p>
+            <a:r>
+              <a:t>grafiek is een keuze die iemand anders voor je heeft gemaakt.</a:t>
             </a:r>
           </a:p>
           <a:p/>
           <a:p>
             <a:r>
-              <a:t>Waarom dit de eindstanden zijn en niet de winst per hand: dat laatste is voor 92%</a:t>
-            </a:r>
-          </a:p>
-          <a:p>
-            <a:r>
-              <a:t>een blind van tien of twintig chips, dus getekend krijg je één balk en verder wit.</a:t>
-            </a:r>
-          </a:p>
-          <a:p>
-            <a:r>
-              <a:t>Die verdeling staat als tabel op de dia hiervoor, waar hij wel leesbaar is.</a:t>
+              <a:t>Wijs op de bar helemaal rechts. Dat is één hand waarin 1750 chips omgingen, en die</a:t>
+            </a:r>
+          </a:p>
+          <a:p>
+            <a:r>
+              <a:t>zit in geen enkel getal van de dia's hiervoor.</a:t>
             </a:r>
           </a:p>
         </p:txBody>
@@ -2445,33 +2441,44 @@
           <a:lstStyle/>
           <a:p>
             <a:r>
-              <a:t>De deadline is donderdag 18:00 en dat is geen</a:t>
-            </a:r>
-          </a:p>
-          <a:p>
-            <a:r>
-              <a:t>inlevermoment maar een BESLUIT: welke vraag, welke twee bronnen, op welke kolom die</a:t>
-            </a:r>
-          </a:p>
-          <a:p>
-            <a:r>
-              <a:t>aan elkaar passen, wie doet wat.</a:t>
+              <a:t>Dezelfde dataset, andere eenheid, andere as.</a:t>
+            </a:r>
+          </a:p>
+          <a:p>
+            <a:r>
+              <a:t>De winst per hand had een log-as nodig; de eindstand is één getal per bot en past</a:t>
+            </a:r>
+          </a:p>
+          <a:p>
+            <a:r>
+              <a:t>gewoon lineair.</a:t>
             </a:r>
           </a:p>
           <a:p/>
           <a:p>
             <a:r>
-              <a:t>Het zinnetje over Den Haag en 's-Gravenhage is niet grappig bedoeld. Laat ze nu al</a:t>
-            </a:r>
-          </a:p>
-          <a:p>
-            <a:r>
-              <a:t>een keer kijken of hun twee bronnen echt een gemeenschappelijke kolom hebben met</a:t>
-            </a:r>
-          </a:p>
-          <a:p>
-            <a:r>
-              <a:t>dezelfde schrijfwijze.</a:t>
+              <a:t>Iedereen begon op 1000, de stippellijn. Links daarvan staat wie chips heeft</a:t>
+            </a:r>
+          </a:p>
+          <a:p>
+            <a:r>
+              <a:t>ingeleverd. De klont in het midden zijn de bots die iets verloren en verder</a:t>
+            </a:r>
+          </a:p>
+          <a:p>
+            <a:r>
+              <a:t>nauwelijks hebben gespeeld; rechts steken er twee ver bovenuit, en die ken je nu.</a:t>
+            </a:r>
+          </a:p>
+          <a:p/>
+          <a:p>
+            <a:r>
+              <a:t>Als je één ding wilt meegeven: dit is waarom een gemiddelde hier niets zegt. Het</a:t>
+            </a:r>
+          </a:p>
+          <a:p>
+            <a:r>
+              <a:t>gemiddelde is per definitie 1000, want het is een nulsom. De vorm is het verhaal.</a:t>
             </a:r>
           </a:p>
         </p:txBody>
@@ -2541,22 +2548,33 @@
           <a:lstStyle/>
           <a:p>
             <a:r>
-              <a:t>Vergelijken en annoteren is het criterium waar</a:t>
-            </a:r>
-          </a:p>
-          <a:p>
-            <a:r>
-              <a:t>groepen punten laten liggen. Het vraagt diff, cumsum of shift - het verschil met het</a:t>
-            </a:r>
-          </a:p>
-          <a:p>
-            <a:r>
-              <a:t>moment ervoor, niet alleen de waarde. Ze hebben diff vanmiddag al gebruikt om de</a:t>
-            </a:r>
-          </a:p>
-          <a:p>
-            <a:r>
-              <a:t>winst-kolom te maken; zeg dat er hardop bij.</a:t>
+              <a:t>De deadline is donderdag 18:00 en dat is geen</a:t>
+            </a:r>
+          </a:p>
+          <a:p>
+            <a:r>
+              <a:t>inlevermoment maar een BESLUIT: welke vraag, welke twee bronnen, op welke kolom die</a:t>
+            </a:r>
+          </a:p>
+          <a:p>
+            <a:r>
+              <a:t>aan elkaar passen, wie doet wat.</a:t>
+            </a:r>
+          </a:p>
+          <a:p/>
+          <a:p>
+            <a:r>
+              <a:t>Het zinnetje over Den Haag en 's-Gravenhage is niet grappig bedoeld. Laat ze nu al</a:t>
+            </a:r>
+          </a:p>
+          <a:p>
+            <a:r>
+              <a:t>een keer kijken of hun twee bronnen echt een gemeenschappelijke kolom hebben met</a:t>
+            </a:r>
+          </a:p>
+          <a:p>
+            <a:r>
+              <a:t>dezelfde schrijfwijze.</a:t>
             </a:r>
           </a:p>
         </p:txBody>
@@ -2626,23 +2644,22 @@
           <a:lstStyle/>
           <a:p>
             <a:r>
-              <a:t>Deze dia is saai en bespaart je</a:t>
-            </a:r>
-          </a:p>
-          <a:p>
-            <a:r>
-              <a:t>in week 4 een half uur discussie. De aftrek gaat van BEIDE cijfers af, IDS en VA.</a:t>
-            </a:r>
-          </a:p>
-          <a:p/>
-          <a:p>
-            <a:r>
-              <a:t>"Een schone clone draait zonder handmatige stappen" is de zwaarste: hun app moet het</a:t>
-            </a:r>
-          </a:p>
-          <a:p>
-            <a:r>
-              <a:t>doen op een computer die hun notebook nooit heeft gezien.</a:t>
+              <a:t>Vergelijken en annoteren is het criterium waar</a:t>
+            </a:r>
+          </a:p>
+          <a:p>
+            <a:r>
+              <a:t>groepen punten laten liggen. Het vraagt diff, cumsum of shift - het verschil met het</a:t>
+            </a:r>
+          </a:p>
+          <a:p>
+            <a:r>
+              <a:t>moment ervoor, niet alleen de waarde. Ze hebben diff vanmiddag al gebruikt om de</a:t>
+            </a:r>
+          </a:p>
+          <a:p>
+            <a:r>
+              <a:t>winst-kolom te maken; zeg dat er hardop bij.</a:t>
             </a:r>
           </a:p>
         </p:txBody>
@@ -2712,22 +2729,23 @@
           <a:lstStyle/>
           <a:p>
             <a:r>
-              <a:t>Dit is de dia die de curriculum-audit vroeg.</a:t>
-            </a:r>
-          </a:p>
-          <a:p>
-            <a:r>
-              <a:t>Studenten leggen de koppeling tussen werkcollege en rubric zelf niet. Een zin - dit</a:t>
-            </a:r>
-          </a:p>
-          <a:p>
-            <a:r>
-              <a:t>is het criterium waarop je case wordt beoordeeld - is het verschil tussen een</a:t>
-            </a:r>
-          </a:p>
-          <a:p>
-            <a:r>
-              <a:t>oefening en een reden.</a:t>
+              <a:t>Deze dia is saai en bespaart je</a:t>
+            </a:r>
+          </a:p>
+          <a:p>
+            <a:r>
+              <a:t>in week 4 een half uur discussie. De aftrek gaat van BEIDE cijfers af, IDS en VA.</a:t>
+            </a:r>
+          </a:p>
+          <a:p/>
+          <a:p>
+            <a:r>
+              <a:t>"Een schone clone draait zonder handmatige stappen" is de zwaarste: hun app moet het</a:t>
+            </a:r>
+          </a:p>
+          <a:p>
+            <a:r>
+              <a:t>doen op een computer die hun notebook nooit heeft gezien.</a:t>
             </a:r>
           </a:p>
         </p:txBody>
@@ -2797,17 +2815,22 @@
           <a:lstStyle/>
           <a:p>
             <a:r>
-              <a:t>[EDA-recept] Dit recept is precies de volgorde van de demo straks:</a:t>
-            </a:r>
-          </a:p>
-          <a:p>
-            <a:r>
-              <a:t>describe -&gt; univariaat -&gt; bivariaat. Blok 1 is describe, blok 3 is bivariaat.</a:t>
-            </a:r>
-          </a:p>
-          <a:p>
-            <a:r>
-              <a:t>Zeg dat je het zo meteen op hun eigen toernooi doet, dan luisteren ze anders.</a:t>
+              <a:t>Dit is de dia die de curriculum-audit vroeg.</a:t>
+            </a:r>
+          </a:p>
+          <a:p>
+            <a:r>
+              <a:t>Studenten leggen de koppeling tussen werkcollege en rubric zelf niet. Een zin - dit</a:t>
+            </a:r>
+          </a:p>
+          <a:p>
+            <a:r>
+              <a:t>is het criterium waarop je case wordt beoordeeld - is het verschil tussen een</a:t>
+            </a:r>
+          </a:p>
+          <a:p>
+            <a:r>
+              <a:t>oefening en een reden.</a:t>
             </a:r>
           </a:p>
         </p:txBody>
@@ -2877,39 +2900,17 @@
           <a:lstStyle/>
           <a:p>
             <a:r>
-              <a:t>[Blok 1 - wat de samenvatting verbergt] Op het toernooi van deze week:</a:t>
-            </a:r>
-          </a:p>
-          <a:p>
-            <a:r>
-              <a:t>gemiddelde 0,0 - mediaan 0,0 - std 39 - laagste -1030 - hoogste +1750.</a:t>
-            </a:r>
-          </a:p>
-          <a:p/>
-          <a:p>
-            <a:r>
-              <a:t>Het gemiddelde is exact nul en dat is geen toeval: poker is een nulsom, wat de</a:t>
-            </a:r>
-          </a:p>
-          <a:p>
-            <a:r>
-              <a:t>een wint verliest de ander. Dat is meteen je controle. Komt er geen nul uit je</a:t>
-            </a:r>
-          </a:p>
-          <a:p>
-            <a:r>
-              <a:t>eigen berekening, dan klopt je groepering niet.</a:t>
-            </a:r>
-          </a:p>
-          <a:p/>
-          <a:p>
-            <a:r>
-              <a:t>Mediaan nul betekent: in de meeste handen gebeurt er niets. En toch ging er in</a:t>
-            </a:r>
-          </a:p>
-          <a:p>
-            <a:r>
-              <a:t>een van die handen 1750 chips om. Vier getallen, en geen van de vier vertelt dat.</a:t>
+              <a:t>[EDA-recept] Dit recept is precies de volgorde van de demo straks:</a:t>
+            </a:r>
+          </a:p>
+          <a:p>
+            <a:r>
+              <a:t>describe -&gt; univariaat -&gt; bivariaat. Blok 1 is describe, blok 3 is bivariaat.</a:t>
+            </a:r>
+          </a:p>
+          <a:p>
+            <a:r>
+              <a:t>Zeg dat je het zo meteen op hun eigen toernooi doet, dan luisteren ze anders.</a:t>
             </a:r>
           </a:p>
         </p:txBody>
@@ -2979,33 +2980,39 @@
           <a:lstStyle/>
           <a:p>
             <a:r>
-              <a:t>[Blok 2 - de verdeling] Op hun data: 4838 van de 6750 handen vallen</a:t>
-            </a:r>
-          </a:p>
-          <a:p>
-            <a:r>
-              <a:t>tussen 0 en 20 chips. 1488 tussen -20 en -1. En dan de staarten: 53 handen tussen</a:t>
-            </a:r>
-          </a:p>
-          <a:p>
-            <a:r>
-              <a:t>-100 en -20, negen onder de -200, zeven boven de +200.</a:t>
+              <a:t>[Blok 1 - wat de samenvatting verbergt] Op het toernooi van deze week:</a:t>
+            </a:r>
+          </a:p>
+          <a:p>
+            <a:r>
+              <a:t>gemiddelde 0,0 - mediaan 0,0 - std 39 - laagste -1030 - hoogste +1750.</a:t>
             </a:r>
           </a:p>
           <a:p/>
           <a:p>
             <a:r>
-              <a:t>Die ene piek rond nul zijn handen die zijn weggelegd zonder in de blinds te zitten.</a:t>
-            </a:r>
-          </a:p>
-          <a:p>
-            <a:r>
-              <a:t>Het echte spel zit in de zeven handen rechts. Vraag aan de zaal: welk van de vier</a:t>
-            </a:r>
-          </a:p>
-          <a:p>
-            <a:r>
-              <a:t>getallen van de vorige dia had je dat verteld? Geen enkel.</a:t>
+              <a:t>Het gemiddelde is exact nul en dat is geen toeval: poker is een nulsom, wat de</a:t>
+            </a:r>
+          </a:p>
+          <a:p>
+            <a:r>
+              <a:t>een wint verliest de ander. Dat is meteen je controle. Komt er geen nul uit je</a:t>
+            </a:r>
+          </a:p>
+          <a:p>
+            <a:r>
+              <a:t>eigen berekening, dan klopt je groepering niet.</a:t>
+            </a:r>
+          </a:p>
+          <a:p/>
+          <a:p>
+            <a:r>
+              <a:t>Mediaan nul betekent: in de meeste handen gebeurt er niets. En toch ging er in</a:t>
+            </a:r>
+          </a:p>
+          <a:p>
+            <a:r>
+              <a:t>een van die handen 1750 chips om. Vier getallen, en geen van de vier vertelt dat.</a:t>
             </a:r>
           </a:p>
         </p:txBody>
@@ -3229,33 +3236,33 @@
           <a:lstStyle/>
           <a:p>
             <a:r>
-              <a:t>[Central tendency] Hier maakt de keuze het verschil tussen twee conclusies,</a:t>
-            </a:r>
-          </a:p>
-          <a:p>
-            <a:r>
-              <a:t>en dat kun je op hun data laten zien. Gemiddelde winst per hand: 0. Mediaan: 0.</a:t>
-            </a:r>
-          </a:p>
-          <a:p>
-            <a:r>
-              <a:t>Allebei nul, allebei waar, en samen verbergen ze een hand van +1750.</a:t>
+              <a:t>[Blok 2 - de verdeling] Op hun data: 4838 van de 6750 handen vallen</a:t>
+            </a:r>
+          </a:p>
+          <a:p>
+            <a:r>
+              <a:t>tussen 0 en 20 chips. 1488 tussen -20 en -1. En dan de staarten: 53 handen tussen</a:t>
+            </a:r>
+          </a:p>
+          <a:p>
+            <a:r>
+              <a:t>-100 en -20, negen onder de -200, zeven boven de +200.</a:t>
             </a:r>
           </a:p>
           <a:p/>
           <a:p>
             <a:r>
-              <a:t>Bij de bots ligt het andersom: de mediaan van de eindstand is 946, het gemiddelde</a:t>
-            </a:r>
-          </a:p>
-          <a:p>
-            <a:r>
-              <a:t>1000 (want nulsom). Dat verschil van 54 chips is de scheefheid - een paar bots</a:t>
-            </a:r>
-          </a:p>
-          <a:p>
-            <a:r>
-              <a:t>hebben veel, de meeste iets minder dan waarmee ze begonnen.</a:t>
+              <a:t>Die ene piek rond nul zijn handen die zijn weggelegd zonder in de blinds te zitten.</a:t>
+            </a:r>
+          </a:p>
+          <a:p>
+            <a:r>
+              <a:t>Het echte spel zit in de zeven handen rechts. Vraag aan de zaal: welk van de vier</a:t>
+            </a:r>
+          </a:p>
+          <a:p>
+            <a:r>
+              <a:t>getallen van de vorige dia had je dat verteld? Geen enkel.</a:t>
             </a:r>
           </a:p>
         </p:txBody>
@@ -3325,39 +3332,33 @@
           <a:lstStyle/>
           <a:p>
             <a:r>
-              <a:t>[Filteren] De twee filters uit de demo:</a:t>
+              <a:t>[Central tendency] Hier maakt de keuze het verschil tussen twee conclusies,</a:t>
+            </a:r>
+          </a:p>
+          <a:p>
+            <a:r>
+              <a:t>en dat kun je op hun data laten zien. Gemiddelde winst per hand: 0. Mediaan: 0.</a:t>
+            </a:r>
+          </a:p>
+          <a:p>
+            <a:r>
+              <a:t>Allebei nul, allebei waar, en samen verbergen ze een hand van +1750.</a:t>
             </a:r>
           </a:p>
           <a:p/>
           <a:p>
             <a:r>
-              <a:t>  handen[handen["bot_naam"] == "500959250"]      -- rijen op inhoud</a:t>
-            </a:r>
-          </a:p>
-          <a:p>
-            <a:r>
-              <a:t>  handen.loc[handen["aan_zet"], "actie"]         -- boolean mask</a:t>
-            </a:r>
-          </a:p>
-          <a:p/>
-          <a:p>
-            <a:r>
-              <a:t>Die tweede is de belangrijkste regel van het college. aan_zet is een kolom vol</a:t>
-            </a:r>
-          </a:p>
-          <a:p>
-            <a:r>
-              <a:t>True/False; in .loc zetten houdt alleen de rijen waar hij True is. 928 van de 6750</a:t>
-            </a:r>
-          </a:p>
-          <a:p>
-            <a:r>
-              <a:t>logregels zijn handen waarin de bot nooit iets koos - hij zat in de blinds en de</a:t>
-            </a:r>
-          </a:p>
-          <a:p>
-            <a:r>
-              <a:t>hand was al voorbij.</a:t>
+              <a:t>Bij de bots ligt het andersom: de mediaan van de eindstand is 946, het gemiddelde</a:t>
+            </a:r>
+          </a:p>
+          <a:p>
+            <a:r>
+              <a:t>1000 (want nulsom). Dat verschil van 54 chips is de scheefheid - een paar bots</a:t>
+            </a:r>
+          </a:p>
+          <a:p>
+            <a:r>
+              <a:t>hebben veel, de meeste iets minder dan waarmee ze begonnen.</a:t>
             </a:r>
           </a:p>
         </p:txBody>
@@ -3427,50 +3428,39 @@
           <a:lstStyle/>
           <a:p>
             <a:r>
-              <a:t>[Nieuwe variabelen] De winst-kolom is hier het voorbeeld, en hij komt</a:t>
-            </a:r>
-          </a:p>
-          <a:p>
-            <a:r>
-              <a:t>niet uit het log maar reken je zelf uit:</a:t>
+              <a:t>[Filteren] De twee filters uit de demo:</a:t>
             </a:r>
           </a:p>
           <a:p/>
           <a:p>
             <a:r>
-              <a:t>  handen["winst"] = handen.groupby(["bot_naam","simulatie"])["stack"].diff()</a:t>
-            </a:r>
-          </a:p>
-          <a:p>
-            <a:r>
-              <a:t>                          .fillna(handen["stack"] - 1000)</a:t>
+              <a:t>  handen[handen["bot_naam"] == "500959250"]      -- rijen op inhoud</a:t>
+            </a:r>
+          </a:p>
+          <a:p>
+            <a:r>
+              <a:t>  handen.loc[handen["aan_zet"], "actie"]         -- boolean mask</a:t>
             </a:r>
           </a:p>
           <a:p/>
           <a:p>
             <a:r>
-              <a:t>Het log bewaart de stack NA elke hand, dus winst is het verschil met de hand</a:t>
-            </a:r>
-          </a:p>
-          <a:p>
-            <a:r>
-              <a:t>ervoor. Twee dingen die misgaan: groeperen zonder simulatie (dan trek je de</a:t>
-            </a:r>
-          </a:p>
-          <a:p>
-            <a:r>
-              <a:t>eerste hand van zitting 1 af van de laatste van zitting 0), en de NaN van de</a:t>
-            </a:r>
-          </a:p>
-          <a:p>
-            <a:r>
-              <a:t>eerste hand laten staan.</a:t>
-            </a:r>
-          </a:p>
-          <a:p/>
-          <a:p>
-            <a:r>
-              <a:t>Controle: alle winst samen is precies 0.</a:t>
+              <a:t>Die tweede is de belangrijkste regel van het college. aan_zet is een kolom vol</a:t>
+            </a:r>
+          </a:p>
+          <a:p>
+            <a:r>
+              <a:t>True/False; in .loc zetten houdt alleen de rijen waar hij True is. 928 van de 6750</a:t>
+            </a:r>
+          </a:p>
+          <a:p>
+            <a:r>
+              <a:t>logregels zijn handen waarin de bot nooit iets koos - hij zat in de blinds en de</a:t>
+            </a:r>
+          </a:p>
+          <a:p>
+            <a:r>
+              <a:t>hand was al voorbij.</a:t>
             </a:r>
           </a:p>
         </p:txBody>
@@ -3540,46 +3530,50 @@
           <a:lstStyle/>
           <a:p>
             <a:r>
-              <a:t>[Groupby] Een-op-een met de vorige dia:</a:t>
+              <a:t>[Nieuwe variabelen] De winst-kolom is hier het voorbeeld, en hij komt</a:t>
+            </a:r>
+          </a:p>
+          <a:p>
+            <a:r>
+              <a:t>niet uit het log maar reken je zelf uit:</a:t>
             </a:r>
           </a:p>
           <a:p/>
           <a:p>
             <a:r>
-              <a:t>  gapminder.groupby('continent')['pop'].sum()</a:t>
-            </a:r>
-          </a:p>
-          <a:p>
-            <a:r>
-              <a:t>  handen.groupby('bot_naam')['winst'].sum()</a:t>
+              <a:t>  handen["winst"] = handen.groupby(["bot_naam","simulatie"])["stack"].diff()</a:t>
+            </a:r>
+          </a:p>
+          <a:p>
+            <a:r>
+              <a:t>                          .fillna(handen["stack"] - 1000)</a:t>
             </a:r>
           </a:p>
           <a:p/>
           <a:p>
             <a:r>
-              <a:t>Letterlijk dezelfde regel. En dan de valkuil, die je moet laten zien:</a:t>
+              <a:t>Het log bewaart de stack NA elke hand, dus winst is het verschil met de hand</a:t>
+            </a:r>
+          </a:p>
+          <a:p>
+            <a:r>
+              <a:t>ervoor. Twee dingen die misgaan: groeperen zonder simulatie (dan trek je de</a:t>
+            </a:r>
+          </a:p>
+          <a:p>
+            <a:r>
+              <a:t>eerste hand van zitting 1 af van de laatste van zitting 0), en de NaN van de</a:t>
+            </a:r>
+          </a:p>
+          <a:p>
+            <a:r>
+              <a:t>eerste hand laten staan.</a:t>
             </a:r>
           </a:p>
           <a:p/>
           <a:p>
             <a:r>
-              <a:t>  handen.groupby('bot_naam')['stack'].sum()   -&gt;  258.550 chips</a:t>
-            </a:r>
-          </a:p>
-          <a:p/>
-          <a:p>
-            <a:r>
-              <a:t>Geen foutmelding, keurig getal, volslagen onzin. Een stack is een STAND, geen</a:t>
-            </a:r>
-          </a:p>
-          <a:p>
-            <a:r>
-              <a:t>stroom. Dat over 250 handen optellen is hetzelfde als de bevolking van Europa</a:t>
-            </a:r>
-          </a:p>
-          <a:p>
-            <a:r>
-              <a:t>over alle twaalf gapminder-jaren optellen. Voor een stand wil je .last().</a:t>
+              <a:t>Controle: alle winst samen is precies 0.</a:t>
             </a:r>
           </a:p>
         </p:txBody>
@@ -3605,6 +3599,115 @@
 </file>
 
 <file path=ppt/notesSlides/notesSlide24.xml><?xml version="1.0" encoding="utf-8"?>
+<p:notes xmlns:a="http://schemas.openxmlformats.org/drawingml/2006/main" xmlns:p="http://schemas.openxmlformats.org/presentationml/2006/main" xmlns:r="http://schemas.openxmlformats.org/officeDocument/2006/relationships">
+  <p:cSld>
+    <p:spTree>
+      <p:nvGrpSpPr>
+        <p:cNvPr id="1" name=""/>
+        <p:cNvGrpSpPr/>
+        <p:nvPr/>
+      </p:nvGrpSpPr>
+      <p:grpSpPr>
+        <a:xfrm>
+          <a:off x="0" y="0"/>
+          <a:ext cx="0" cy="0"/>
+          <a:chOff x="0" y="0"/>
+          <a:chExt cx="0" cy="0"/>
+        </a:xfrm>
+      </p:grpSpPr>
+      <p:sp>
+        <p:nvSpPr>
+          <p:cNvPr id="2" name="Slide Image Placeholder 1"/>
+          <p:cNvSpPr>
+            <a:spLocks noGrp="1"/>
+          </p:cNvSpPr>
+          <p:nvPr>
+            <p:ph type="sldImg"/>
+          </p:nvPr>
+        </p:nvSpPr>
+        <p:spPr/>
+      </p:sp>
+      <p:sp>
+        <p:nvSpPr>
+          <p:cNvPr id="3" name="Notes Placeholder 2"/>
+          <p:cNvSpPr>
+            <a:spLocks noGrp="1"/>
+          </p:cNvSpPr>
+          <p:nvPr>
+            <p:ph type="body"/>
+          </p:nvPr>
+        </p:nvSpPr>
+        <p:spPr/>
+        <p:txBody>
+          <a:bodyPr/>
+          <a:lstStyle/>
+          <a:p>
+            <a:r>
+              <a:t>[Groupby] Een-op-een met de vorige dia:</a:t>
+            </a:r>
+          </a:p>
+          <a:p/>
+          <a:p>
+            <a:r>
+              <a:t>  gapminder.groupby('continent')['pop'].sum()</a:t>
+            </a:r>
+          </a:p>
+          <a:p>
+            <a:r>
+              <a:t>  handen.groupby('bot_naam')['winst'].sum()</a:t>
+            </a:r>
+          </a:p>
+          <a:p/>
+          <a:p>
+            <a:r>
+              <a:t>Letterlijk dezelfde regel. En dan de valkuil, die je moet laten zien:</a:t>
+            </a:r>
+          </a:p>
+          <a:p/>
+          <a:p>
+            <a:r>
+              <a:t>  handen.groupby('bot_naam')['stack'].sum()   -&gt;  258.550 chips</a:t>
+            </a:r>
+          </a:p>
+          <a:p/>
+          <a:p>
+            <a:r>
+              <a:t>Geen foutmelding, keurig getal, volslagen onzin. Een stack is een STAND, geen</a:t>
+            </a:r>
+          </a:p>
+          <a:p>
+            <a:r>
+              <a:t>stroom. Dat over 250 handen optellen is hetzelfde als de bevolking van Europa</a:t>
+            </a:r>
+          </a:p>
+          <a:p>
+            <a:r>
+              <a:t>over alle twaalf gapminder-jaren optellen. Voor een stand wil je .last().</a:t>
+            </a:r>
+          </a:p>
+        </p:txBody>
+      </p:sp>
+      <p:sp>
+        <p:nvSpPr>
+          <p:cNvPr id="4" name="Slide Number Placeholder 3"/>
+          <p:cNvSpPr>
+            <a:spLocks noGrp="1"/>
+          </p:cNvSpPr>
+          <p:nvPr>
+            <p:ph type="sldNum"/>
+          </p:nvPr>
+        </p:nvSpPr>
+        <p:spPr/>
+      </p:sp>
+    </p:spTree>
+  </p:cSld>
+  <p:clrMapOvr>
+    <a:masterClrMapping/>
+  </p:clrMapOvr>
+</p:notes>
+</file>
+
+<file path=ppt/notesSlides/notesSlide25.xml><?xml version="1.0" encoding="utf-8"?>
 <p:notes xmlns:a="http://schemas.openxmlformats.org/drawingml/2006/main" xmlns:p="http://schemas.openxmlformats.org/presentationml/2006/main" xmlns:r="http://schemas.openxmlformats.org/officeDocument/2006/relationships">
   <p:cSld>
     <p:spTree>
@@ -15553,7 +15656,7 @@
               </a:defRPr>
             </a:pPr>
             <a:r>
-              <a:t>Waar 27 bots zijn geëindigd</a:t>
+              <a:t>De winst per hand, getekend</a:t>
             </a:r>
           </a:p>
         </p:txBody>
@@ -15584,7 +15687,7 @@
       </p:sp>
       <p:pic>
         <p:nvPicPr>
-          <p:cNvPr id="4" name="Picture 3" descr="eindstanden_histogram.png"/>
+          <p:cNvPr id="4" name="Picture 3" descr="winst_per_hand_histogram.png"/>
           <p:cNvPicPr>
             <a:picLocks noChangeAspect="1"/>
           </p:cNvPicPr>
@@ -15599,7 +15702,7 @@
         <p:spPr>
           <a:xfrm>
             <a:off x="2441448" y="1920240"/>
-            <a:ext cx="7863840" cy="3677489"/>
+            <a:ext cx="7863840" cy="3420920"/>
           </a:xfrm>
           <a:prstGeom prst="rect">
             <a:avLst/>
@@ -16400,7 +16503,7 @@
               </a:defRPr>
             </a:pPr>
             <a:r>
-              <a:t>Groepscase 2 — wat je oplevert</a:t>
+              <a:t>Waar de bots zijn geëindigd</a:t>
             </a:r>
           </a:p>
         </p:txBody>
@@ -16426,134 +16529,36 @@
             <a:spAutoFit/>
           </a:bodyPr>
           <a:lstStyle/>
-          <a:p>
-            <a:pPr>
-              <a:defRPr sz="1700" b="1">
-                <a:solidFill>
-                  <a:srgbClr val="000000"/>
-                </a:solidFill>
-                <a:latin typeface="Arial"/>
-              </a:defRPr>
-            </a:pPr>
-            <a:r>
-              <a:t>Een Streamlit-dashboard over een onderwerp dat je zelf kiest.</a:t>
-            </a:r>
-          </a:p>
-          <a:p>
-            <a:pPr lvl="1">
-              <a:defRPr sz="1400" b="0">
-                <a:solidFill>
-                  <a:srgbClr val="000000"/>
-                </a:solidFill>
-                <a:latin typeface="Arial"/>
-              </a:defRPr>
-            </a:pPr>
-            <a:r>
-              <a:t>Gepubliceerd via GitHub op share.streamlit.io, te openen met een link</a:t>
-            </a:r>
-          </a:p>
-          <a:p>
-            <a:pPr lvl="1">
-              <a:defRPr sz="1400" b="0">
-                <a:solidFill>
-                  <a:srgbClr val="000000"/>
-                </a:solidFill>
-                <a:latin typeface="Arial"/>
-              </a:defRPr>
-            </a:pPr>
-            <a:r>
-              <a:t>De app haalt de data zelf op bij een openbare API — niet met de hand gedownload</a:t>
-            </a:r>
-          </a:p>
-          <a:p>
-            <a:pPr lvl="1">
-              <a:defRPr sz="1400" b="0">
-                <a:solidFill>
-                  <a:srgbClr val="1B4D3E"/>
-                </a:solidFill>
-                <a:latin typeface="Arial"/>
-              </a:defRPr>
-            </a:pPr>
-            <a:r>
-              <a:t>Minimaal één join: twee bronnen die je tot één tabel samenvoegt</a:t>
-            </a:r>
-          </a:p>
-          <a:p>
-            <a:pPr>
-              <a:spcBef>
-                <a:spcPts val="1300"/>
-              </a:spcBef>
-              <a:defRPr sz="1700" b="1">
-                <a:solidFill>
-                  <a:srgbClr val="000000"/>
-                </a:solidFill>
-                <a:latin typeface="Arial"/>
-              </a:defRPr>
-            </a:pPr>
-            <a:r>
-              <a:t>Loopt over week 3 en week 4. Dat is kort.</a:t>
-            </a:r>
-          </a:p>
-          <a:p>
-            <a:pPr lvl="1">
-              <a:defRPr sz="1400" b="0">
-                <a:solidFill>
-                  <a:srgbClr val="000000"/>
-                </a:solidFill>
-                <a:latin typeface="Arial"/>
-              </a:defRPr>
-            </a:pPr>
-            <a:r>
-              <a:t>Donderdag 18:00 staat je onderwerp vast: welke vraag, welke twee bronnen,</a:t>
-            </a:r>
-          </a:p>
-          <a:p>
-            <a:pPr lvl="1">
-              <a:defRPr sz="1400" b="0">
-                <a:solidFill>
-                  <a:srgbClr val="000000"/>
-                </a:solidFill>
-                <a:latin typeface="Arial"/>
-              </a:defRPr>
-            </a:pPr>
-            <a:r>
-              <a:t>op welke kolom die aan elkaar passen, en wie in de groep wat doet</a:t>
-            </a:r>
-          </a:p>
-          <a:p>
-            <a:pPr>
-              <a:spcBef>
-                <a:spcPts val="1300"/>
-              </a:spcBef>
-              <a:defRPr sz="1700" b="1">
-                <a:solidFill>
-                  <a:srgbClr val="25167A"/>
-                </a:solidFill>
-                <a:latin typeface="Arial"/>
-              </a:defRPr>
-            </a:pPr>
-            <a:r>
-              <a:t>Zoek nu al op of die twee bronnen écht een gemeenschappelijke kolom hebben.</a:t>
-            </a:r>
-          </a:p>
-          <a:p>
-            <a:pPr lvl="1">
-              <a:defRPr sz="1400" b="0">
-                <a:solidFill>
-                  <a:srgbClr val="505A64"/>
-                </a:solidFill>
-                <a:latin typeface="Arial"/>
-              </a:defRPr>
-            </a:pPr>
-            <a:r>
-              <a:t>"Den Haag" en "'s-Gravenhage" passen niet op elkaar zonder werk</a:t>
-            </a:r>
-          </a:p>
-        </p:txBody>
-      </p:sp>
-      <p:sp>
-        <p:nvSpPr>
-          <p:cNvPr id="4" name="TextBox 3"/>
+          <a:p/>
+        </p:txBody>
+      </p:sp>
+      <p:pic>
+        <p:nvPicPr>
+          <p:cNvPr id="4" name="Picture 3" descr="eindstanden_histogram.png"/>
+          <p:cNvPicPr>
+            <a:picLocks noChangeAspect="1"/>
+          </p:cNvPicPr>
+          <p:nvPr/>
+        </p:nvPicPr>
+        <p:blipFill>
+          <a:blip r:embed="rId2"/>
+          <a:stretch>
+            <a:fillRect/>
+          </a:stretch>
+        </p:blipFill>
+        <p:spPr>
+          <a:xfrm>
+            <a:off x="2441448" y="1920240"/>
+            <a:ext cx="7863840" cy="3420920"/>
+          </a:xfrm>
+          <a:prstGeom prst="rect">
+            <a:avLst/>
+          </a:prstGeom>
+        </p:spPr>
+      </p:pic>
+      <p:sp>
+        <p:nvSpPr>
+          <p:cNvPr id="5" name="TextBox 4"/>
           <p:cNvSpPr txBox="1"/>
           <p:nvPr/>
         </p:nvSpPr>
@@ -16636,7 +16641,7 @@
               </a:defRPr>
             </a:pPr>
             <a:r>
-              <a:t>Waar je cijfer vandaan komt</a:t>
+              <a:t>Groepscase 2 — wat je oplevert</a:t>
             </a:r>
           </a:p>
         </p:txBody>
@@ -16666,13 +16671,13 @@
             <a:pPr>
               <a:defRPr sz="1700" b="1">
                 <a:solidFill>
-                  <a:srgbClr val="25167A"/>
+                  <a:srgbClr val="000000"/>
                 </a:solidFill>
                 <a:latin typeface="Arial"/>
               </a:defRPr>
             </a:pPr>
             <a:r>
-              <a:t>Drie criteria voor IDS — de data-kant</a:t>
+              <a:t>Een Streamlit-dashboard over een onderwerp dat je zelf kiest.</a:t>
             </a:r>
           </a:p>
           <a:p>
@@ -16685,7 +16690,7 @@
               </a:defRPr>
             </a:pPr>
             <a:r>
-              <a:t>Data verzameling · twee bronnen, plus de sleutel en de rijen vóór en ná de join</a:t>
+              <a:t>Gepubliceerd via GitHub op share.streamlit.io, te openen met een link</a:t>
             </a:r>
           </a:p>
           <a:p>
@@ -16698,20 +16703,20 @@
               </a:defRPr>
             </a:pPr>
             <a:r>
-              <a:t>Data verkenning · lege waarden, bereik, dubbele rijen — en wat je ermee deed</a:t>
+              <a:t>De app haalt de data zelf op bij een openbare API — niet met de hand gedownload</a:t>
             </a:r>
           </a:p>
           <a:p>
             <a:pPr lvl="1">
               <a:defRPr sz="1400" b="0">
                 <a:solidFill>
-                  <a:srgbClr val="000000"/>
+                  <a:srgbClr val="1B4D3E"/>
                 </a:solidFill>
                 <a:latin typeface="Arial"/>
               </a:defRPr>
             </a:pPr>
             <a:r>
-              <a:t>Analyse · een conclusie die de data draagt, niet meer dan dat</a:t>
+              <a:t>Minimaal één join: twee bronnen die je tot één tabel samenvoegt</a:t>
             </a:r>
           </a:p>
           <a:p>
@@ -16721,13 +16726,13 @@
               </a:spcBef>
               <a:defRPr sz="1700" b="1">
                 <a:solidFill>
-                  <a:srgbClr val="25167A"/>
+                  <a:srgbClr val="000000"/>
                 </a:solidFill>
                 <a:latin typeface="Arial"/>
               </a:defRPr>
             </a:pPr>
             <a:r>
-              <a:t>Vier criteria voor VA — de verhaalkant</a:t>
+              <a:t>Loopt over week 3 en week 4. Dat is kort.</a:t>
             </a:r>
           </a:p>
           <a:p>
@@ -16740,7 +16745,7 @@
               </a:defRPr>
             </a:pPr>
             <a:r>
-              <a:t>Opbouw en verhaallijn · Interactiviteit · Dashboardontwerp</a:t>
+              <a:t>Donderdag 18:00 staat je onderwerp vast: welke vraag, welke twee bronnen,</a:t>
             </a:r>
           </a:p>
           <a:p>
@@ -16753,20 +16758,7 @@
               </a:defRPr>
             </a:pPr>
             <a:r>
-              <a:t>Vergelijken en annoteren · het verschil, het opgetelde verloop, of de waarde</a:t>
-            </a:r>
-          </a:p>
-          <a:p>
-            <a:pPr lvl="1">
-              <a:defRPr sz="1400" b="0">
-                <a:solidFill>
-                  <a:srgbClr val="1B4D3E"/>
-                </a:solidFill>
-                <a:latin typeface="Arial"/>
-              </a:defRPr>
-            </a:pPr>
-            <a:r>
-              <a:t>ten opzichte van het moment ervoor — diff, cumsum, shift</a:t>
+              <a:t>op welke kolom die aan elkaar passen, en wie in de groep wat doet</a:t>
             </a:r>
           </a:p>
           <a:p>
@@ -16776,13 +16768,26 @@
               </a:spcBef>
               <a:defRPr sz="1700" b="1">
                 <a:solidFill>
-                  <a:srgbClr val="000000"/>
+                  <a:srgbClr val="25167A"/>
                 </a:solidFill>
                 <a:latin typeface="Arial"/>
               </a:defRPr>
             </a:pPr>
             <a:r>
-              <a:t>Vijf niveaus, van Ontbreekt (1) tot Uitstekend (9).</a:t>
+              <a:t>Zoek nu al op of die twee bronnen écht een gemeenschappelijke kolom hebben.</a:t>
+            </a:r>
+          </a:p>
+          <a:p>
+            <a:pPr lvl="1">
+              <a:defRPr sz="1400" b="0">
+                <a:solidFill>
+                  <a:srgbClr val="505A64"/>
+                </a:solidFill>
+                <a:latin typeface="Arial"/>
+              </a:defRPr>
+            </a:pPr>
+            <a:r>
+              <a:t>"Den Haag" en "'s-Gravenhage" passen niet op elkaar zonder werk</a:t>
             </a:r>
           </a:p>
         </p:txBody>
@@ -16872,7 +16877,7 @@
               </a:defRPr>
             </a:pPr>
             <a:r>
-              <a:t>Vijf voorwaarden — die gaan van je cijfer af</a:t>
+              <a:t>Waar je cijfer vandaan komt</a:t>
             </a:r>
           </a:p>
         </p:txBody>
@@ -16902,13 +16907,13 @@
             <a:pPr>
               <a:defRPr sz="1700" b="1">
                 <a:solidFill>
-                  <a:srgbClr val="000000"/>
+                  <a:srgbClr val="25167A"/>
                 </a:solidFill>
                 <a:latin typeface="Arial"/>
               </a:defRPr>
             </a:pPr>
             <a:r>
-              <a:t>Dit zijn geen criteria maar drempels. Beide cijfers, IDS en VA.</a:t>
+              <a:t>Drie criteria voor IDS — de data-kant</a:t>
             </a:r>
           </a:p>
           <a:p>
@@ -16921,20 +16926,20 @@
               </a:defRPr>
             </a:pPr>
             <a:r>
-              <a:t>App niet online, of een schone clone draait niet zonder handwerk</a:t>
+              <a:t>Data verzameling · twee bronnen, plus de sleutel en de rijen vóór en ná de join</a:t>
             </a:r>
           </a:p>
           <a:p>
             <a:pPr lvl="1">
               <a:defRPr sz="1400" b="0">
                 <a:solidFill>
-                  <a:srgbClr val="25167A"/>
+                  <a:srgbClr val="000000"/>
                 </a:solidFill>
                 <a:latin typeface="Arial"/>
               </a:defRPr>
             </a:pPr>
             <a:r>
-              <a:t>     -1,0</a:t>
+              <a:t>Data verkenning · lege waarden, bereik, dubbele rijen — en wat je ermee deed</a:t>
             </a:r>
           </a:p>
           <a:p>
@@ -16947,46 +16952,7 @@
               </a:defRPr>
             </a:pPr>
             <a:r>
-              <a:t>Presentatie langer dan 10 minuten, exclusief vragen</a:t>
-            </a:r>
-          </a:p>
-          <a:p>
-            <a:pPr lvl="1">
-              <a:defRPr sz="1400" b="0">
-                <a:solidFill>
-                  <a:srgbClr val="25167A"/>
-                </a:solidFill>
-                <a:latin typeface="Arial"/>
-              </a:defRPr>
-            </a:pPr>
-            <a:r>
-              <a:t>     -1,0</a:t>
-            </a:r>
-          </a:p>
-          <a:p>
-            <a:pPr lvl="1">
-              <a:defRPr sz="1400" b="0">
-                <a:solidFill>
-                  <a:srgbClr val="000000"/>
-                </a:solidFill>
-                <a:latin typeface="Arial"/>
-              </a:defRPr>
-            </a:pPr>
-            <a:r>
-              <a:t>Geen slider, checkbox én dropdown, elk gekoppeld aan een tabel of grafiek</a:t>
-            </a:r>
-          </a:p>
-          <a:p>
-            <a:pPr lvl="1">
-              <a:defRPr sz="1400" b="0">
-                <a:solidFill>
-                  <a:srgbClr val="25167A"/>
-                </a:solidFill>
-                <a:latin typeface="Arial"/>
-              </a:defRPr>
-            </a:pPr>
-            <a:r>
-              <a:t>     -0,5</a:t>
+              <a:t>Analyse · een conclusie die de data draagt, niet meer dan dat</a:t>
             </a:r>
           </a:p>
           <a:p>
@@ -16996,26 +16962,68 @@
               </a:spcBef>
               <a:defRPr sz="1700" b="1">
                 <a:solidFill>
-                  <a:srgbClr val="000000"/>
+                  <a:srgbClr val="25167A"/>
                 </a:solidFill>
                 <a:latin typeface="Arial"/>
               </a:defRPr>
             </a:pPr>
             <a:r>
-              <a:t>En twee zonder aftrek, maar niet vrijblijvend:</a:t>
+              <a:t>Vier criteria voor VA — de verhaalkant</a:t>
             </a:r>
           </a:p>
           <a:p>
             <a:pPr lvl="1">
               <a:defRPr sz="1400" b="0">
                 <a:solidFill>
-                  <a:srgbClr val="505A64"/>
+                  <a:srgbClr val="000000"/>
                 </a:solidFill>
                 <a:latin typeface="Arial"/>
               </a:defRPr>
             </a:pPr>
             <a:r>
-              <a:t>Onderwerp op tijd gemeld · code van anderen met bron erbij, en uit te leggen</a:t>
+              <a:t>Opbouw en verhaallijn · Interactiviteit · Dashboardontwerp</a:t>
+            </a:r>
+          </a:p>
+          <a:p>
+            <a:pPr lvl="1">
+              <a:defRPr sz="1400" b="0">
+                <a:solidFill>
+                  <a:srgbClr val="000000"/>
+                </a:solidFill>
+                <a:latin typeface="Arial"/>
+              </a:defRPr>
+            </a:pPr>
+            <a:r>
+              <a:t>Vergelijken en annoteren · het verschil, het opgetelde verloop, of de waarde</a:t>
+            </a:r>
+          </a:p>
+          <a:p>
+            <a:pPr lvl="1">
+              <a:defRPr sz="1400" b="0">
+                <a:solidFill>
+                  <a:srgbClr val="1B4D3E"/>
+                </a:solidFill>
+                <a:latin typeface="Arial"/>
+              </a:defRPr>
+            </a:pPr>
+            <a:r>
+              <a:t>ten opzichte van het moment ervoor — diff, cumsum, shift</a:t>
+            </a:r>
+          </a:p>
+          <a:p>
+            <a:pPr>
+              <a:spcBef>
+                <a:spcPts val="1300"/>
+              </a:spcBef>
+              <a:defRPr sz="1700" b="1">
+                <a:solidFill>
+                  <a:srgbClr val="000000"/>
+                </a:solidFill>
+                <a:latin typeface="Arial"/>
+              </a:defRPr>
+            </a:pPr>
+            <a:r>
+              <a:t>Vijf niveaus, van Ontbreekt (1) tot Uitstekend (9).</a:t>
             </a:r>
           </a:p>
         </p:txBody>
@@ -17105,7 +17113,7 @@
               </a:defRPr>
             </a:pPr>
             <a:r>
-              <a:t>Dat heb je vanmiddag al gedaan</a:t>
+              <a:t>Vijf voorwaarden — die gaan van je cijfer af</a:t>
             </a:r>
           </a:p>
         </p:txBody>
@@ -17141,85 +17149,85 @@
               </a:defRPr>
             </a:pPr>
             <a:r>
-              <a:t>De demo van zojuist was Case 2 in het klein:</a:t>
+              <a:t>Dit zijn geen criteria maar drempels. Beide cijfers, IDS en VA.</a:t>
             </a:r>
           </a:p>
           <a:p>
             <a:pPr lvl="1">
               <a:defRPr sz="1400" b="0">
                 <a:solidFill>
-                  <a:srgbClr val="1B4D3E"/>
+                  <a:srgbClr val="000000"/>
                 </a:solidFill>
                 <a:latin typeface="Arial"/>
               </a:defRPr>
             </a:pPr>
             <a:r>
-              <a:t>twee tabellen op bot_naam samengevoegd, rijen geteld vóór en ná</a:t>
+              <a:t>App niet online, of een schone clone draait niet zonder handwerk</a:t>
             </a:r>
           </a:p>
           <a:p>
             <a:pPr lvl="1">
               <a:defRPr sz="1400" b="0">
                 <a:solidFill>
-                  <a:srgbClr val="000000"/>
+                  <a:srgbClr val="25167A"/>
                 </a:solidFill>
                 <a:latin typeface="Arial"/>
               </a:defRPr>
             </a:pPr>
             <a:r>
-              <a:t>     → criterium Data verzameling</a:t>
+              <a:t>     -1,0</a:t>
             </a:r>
           </a:p>
           <a:p>
             <a:pPr lvl="1">
               <a:defRPr sz="1400" b="0">
                 <a:solidFill>
-                  <a:srgbClr val="1B4D3E"/>
+                  <a:srgbClr val="000000"/>
                 </a:solidFill>
                 <a:latin typeface="Arial"/>
               </a:defRPr>
             </a:pPr>
             <a:r>
-              <a:t>928 lege waarden gevonden, en gezien wat ze met je percentage deden</a:t>
+              <a:t>Presentatie langer dan 10 minuten, exclusief vragen</a:t>
             </a:r>
           </a:p>
           <a:p>
             <a:pPr lvl="1">
               <a:defRPr sz="1400" b="0">
                 <a:solidFill>
-                  <a:srgbClr val="000000"/>
+                  <a:srgbClr val="25167A"/>
                 </a:solidFill>
                 <a:latin typeface="Arial"/>
               </a:defRPr>
             </a:pPr>
             <a:r>
-              <a:t>     → criterium Data verkenning</a:t>
+              <a:t>     -1,0</a:t>
             </a:r>
           </a:p>
           <a:p>
             <a:pPr lvl="1">
               <a:defRPr sz="1400" b="0">
                 <a:solidFill>
-                  <a:srgbClr val="1B4D3E"/>
+                  <a:srgbClr val="000000"/>
                 </a:solidFill>
                 <a:latin typeface="Arial"/>
               </a:defRPr>
             </a:pPr>
             <a:r>
-              <a:t>diff en cumsum over het verloop van een stack</a:t>
+              <a:t>Geen slider, checkbox én dropdown, elk gekoppeld aan een tabel of grafiek</a:t>
             </a:r>
           </a:p>
           <a:p>
             <a:pPr lvl="1">
               <a:defRPr sz="1400" b="0">
                 <a:solidFill>
-                  <a:srgbClr val="000000"/>
+                  <a:srgbClr val="25167A"/>
                 </a:solidFill>
                 <a:latin typeface="Arial"/>
               </a:defRPr>
             </a:pPr>
             <a:r>
-              <a:t>     → criterium Vergelijken en annoteren</a:t>
+              <a:t>     -0,5</a:t>
             </a:r>
           </a:p>
           <a:p>
@@ -17235,7 +17243,7 @@
               </a:defRPr>
             </a:pPr>
             <a:r>
-              <a:t>Het verschil met de case: daar kiest niemand de dataset voor je,</a:t>
+              <a:t>En twee zonder aftrek, maar niet vrijblijvend:</a:t>
             </a:r>
           </a:p>
           <a:p>
@@ -17248,7 +17256,7 @@
               </a:defRPr>
             </a:pPr>
             <a:r>
-              <a:t>en staat er geen kolom aan_zet klaar om je fout te laten zien.</a:t>
+              <a:t>Onderwerp op tijd gemeld · code van anderen met bron erbij, en uit te leggen</a:t>
             </a:r>
           </a:p>
         </p:txBody>
@@ -17285,6 +17293,239 @@
             </a:pPr>
             <a:r>
               <a:t>34</a:t>
+            </a:r>
+          </a:p>
+        </p:txBody>
+      </p:sp>
+    </p:spTree>
+  </p:cSld>
+  <p:clrMapOvr>
+    <a:masterClrMapping/>
+  </p:clrMapOvr>
+</p:sld>
+</file>
+
+<file path=ppt/slides/slide35.xml><?xml version="1.0" encoding="utf-8"?>
+<p:sld xmlns:a="http://schemas.openxmlformats.org/drawingml/2006/main" xmlns:p="http://schemas.openxmlformats.org/presentationml/2006/main" xmlns:r="http://schemas.openxmlformats.org/officeDocument/2006/relationships">
+  <p:cSld>
+    <p:spTree>
+      <p:nvGrpSpPr>
+        <p:cNvPr id="1" name=""/>
+        <p:cNvGrpSpPr/>
+        <p:nvPr/>
+      </p:nvGrpSpPr>
+      <p:grpSpPr/>
+      <p:sp>
+        <p:nvSpPr>
+          <p:cNvPr id="2" name="TextBox 1"/>
+          <p:cNvSpPr txBox="1"/>
+          <p:nvPr/>
+        </p:nvSpPr>
+        <p:spPr>
+          <a:xfrm>
+            <a:off x="1984248" y="941832"/>
+            <a:ext cx="8229600" cy="1143000"/>
+          </a:xfrm>
+          <a:prstGeom prst="rect">
+            <a:avLst/>
+          </a:prstGeom>
+          <a:noFill/>
+        </p:spPr>
+        <p:txBody>
+          <a:bodyPr wrap="square">
+            <a:spAutoFit/>
+          </a:bodyPr>
+          <a:lstStyle/>
+          <a:p>
+            <a:pPr>
+              <a:defRPr sz="3200">
+                <a:solidFill>
+                  <a:srgbClr val="25167A"/>
+                </a:solidFill>
+                <a:latin typeface="Arial"/>
+              </a:defRPr>
+            </a:pPr>
+            <a:r>
+              <a:t>Dat heb je vanmiddag al gedaan</a:t>
+            </a:r>
+          </a:p>
+        </p:txBody>
+      </p:sp>
+      <p:sp>
+        <p:nvSpPr>
+          <p:cNvPr id="3" name="TextBox 2"/>
+          <p:cNvSpPr txBox="1"/>
+          <p:nvPr/>
+        </p:nvSpPr>
+        <p:spPr>
+          <a:xfrm>
+            <a:off x="1984248" y="2084831"/>
+            <a:ext cx="8778240" cy="4041648"/>
+          </a:xfrm>
+          <a:prstGeom prst="rect">
+            <a:avLst/>
+          </a:prstGeom>
+          <a:noFill/>
+        </p:spPr>
+        <p:txBody>
+          <a:bodyPr wrap="square">
+            <a:spAutoFit/>
+          </a:bodyPr>
+          <a:lstStyle/>
+          <a:p>
+            <a:pPr>
+              <a:defRPr sz="1700" b="1">
+                <a:solidFill>
+                  <a:srgbClr val="000000"/>
+                </a:solidFill>
+                <a:latin typeface="Arial"/>
+              </a:defRPr>
+            </a:pPr>
+            <a:r>
+              <a:t>De demo van zojuist was Case 2 in het klein:</a:t>
+            </a:r>
+          </a:p>
+          <a:p>
+            <a:pPr lvl="1">
+              <a:defRPr sz="1400" b="0">
+                <a:solidFill>
+                  <a:srgbClr val="1B4D3E"/>
+                </a:solidFill>
+                <a:latin typeface="Arial"/>
+              </a:defRPr>
+            </a:pPr>
+            <a:r>
+              <a:t>twee tabellen op bot_naam samengevoegd, rijen geteld vóór en ná</a:t>
+            </a:r>
+          </a:p>
+          <a:p>
+            <a:pPr lvl="1">
+              <a:defRPr sz="1400" b="0">
+                <a:solidFill>
+                  <a:srgbClr val="000000"/>
+                </a:solidFill>
+                <a:latin typeface="Arial"/>
+              </a:defRPr>
+            </a:pPr>
+            <a:r>
+              <a:t>     → criterium Data verzameling</a:t>
+            </a:r>
+          </a:p>
+          <a:p>
+            <a:pPr lvl="1">
+              <a:defRPr sz="1400" b="0">
+                <a:solidFill>
+                  <a:srgbClr val="1B4D3E"/>
+                </a:solidFill>
+                <a:latin typeface="Arial"/>
+              </a:defRPr>
+            </a:pPr>
+            <a:r>
+              <a:t>928 lege waarden gevonden, en gezien wat ze met je percentage deden</a:t>
+            </a:r>
+          </a:p>
+          <a:p>
+            <a:pPr lvl="1">
+              <a:defRPr sz="1400" b="0">
+                <a:solidFill>
+                  <a:srgbClr val="000000"/>
+                </a:solidFill>
+                <a:latin typeface="Arial"/>
+              </a:defRPr>
+            </a:pPr>
+            <a:r>
+              <a:t>     → criterium Data verkenning</a:t>
+            </a:r>
+          </a:p>
+          <a:p>
+            <a:pPr lvl="1">
+              <a:defRPr sz="1400" b="0">
+                <a:solidFill>
+                  <a:srgbClr val="1B4D3E"/>
+                </a:solidFill>
+                <a:latin typeface="Arial"/>
+              </a:defRPr>
+            </a:pPr>
+            <a:r>
+              <a:t>diff en cumsum over het verloop van een stack</a:t>
+            </a:r>
+          </a:p>
+          <a:p>
+            <a:pPr lvl="1">
+              <a:defRPr sz="1400" b="0">
+                <a:solidFill>
+                  <a:srgbClr val="000000"/>
+                </a:solidFill>
+                <a:latin typeface="Arial"/>
+              </a:defRPr>
+            </a:pPr>
+            <a:r>
+              <a:t>     → criterium Vergelijken en annoteren</a:t>
+            </a:r>
+          </a:p>
+          <a:p>
+            <a:pPr>
+              <a:spcBef>
+                <a:spcPts val="1300"/>
+              </a:spcBef>
+              <a:defRPr sz="1700" b="1">
+                <a:solidFill>
+                  <a:srgbClr val="000000"/>
+                </a:solidFill>
+                <a:latin typeface="Arial"/>
+              </a:defRPr>
+            </a:pPr>
+            <a:r>
+              <a:t>Het verschil met de case: daar kiest niemand de dataset voor je,</a:t>
+            </a:r>
+          </a:p>
+          <a:p>
+            <a:pPr lvl="1">
+              <a:defRPr sz="1400" b="0">
+                <a:solidFill>
+                  <a:srgbClr val="505A64"/>
+                </a:solidFill>
+                <a:latin typeface="Arial"/>
+              </a:defRPr>
+            </a:pPr>
+            <a:r>
+              <a:t>en staat er geen kolom aan_zet klaar om je fout te laten zien.</a:t>
+            </a:r>
+          </a:p>
+        </p:txBody>
+      </p:sp>
+      <p:sp>
+        <p:nvSpPr>
+          <p:cNvPr id="4" name="TextBox 3"/>
+          <p:cNvSpPr txBox="1"/>
+          <p:nvPr/>
+        </p:nvSpPr>
+        <p:spPr>
+          <a:xfrm>
+            <a:off x="9774936" y="6126480"/>
+            <a:ext cx="630936" cy="365760"/>
+          </a:xfrm>
+          <a:prstGeom prst="rect">
+            <a:avLst/>
+          </a:prstGeom>
+          <a:noFill/>
+        </p:spPr>
+        <p:txBody>
+          <a:bodyPr wrap="none">
+            <a:spAutoFit/>
+          </a:bodyPr>
+          <a:lstStyle/>
+          <a:p>
+            <a:pPr>
+              <a:defRPr sz="1200">
+                <a:solidFill>
+                  <a:srgbClr val="505A64"/>
+                </a:solidFill>
+                <a:latin typeface="Arial"/>
+              </a:defRPr>
+            </a:pPr>
+            <a:r>
+              <a:t>35</a:t>
             </a:r>
           </a:p>
         </p:txBody>

</xml_diff>